<commit_message>
[B] add the rehearsal script and the product slide, keep evaluation provisional
S7-AB1: new deck slide on how the interface avoids overstating scores;
the deck now keeps its PROVISIONAL tag until every gold row is checked,
and the recognition slide until the calibration is refitted.
S7-AB2: scripts/rehearse_demo.py and docs/07-demo-script.md.
S5-B3: /evaluation is provisional until the human pass is complete
(CONTRACT CHANGE in PROGRESS.md). API contract documents /recognition
and /evaluation. ADR-0005 amended for the hybrid calibration.

Co-Authored-By: Claude Opus 5.5 <noreply@anthropic.com>
Claude-Session: https://claude.ai/code/session_01EuFMRyGM9yJC2Kd9qVdp9c
</commit_message>
<xml_diff>
--- a/docs/slides/erasmusgpt-defence.pptx
+++ b/docs/slides/erasmusgpt-defence.pptx
@@ -16,6 +16,7 @@
     <p:sldId id="264" r:id="rId16"/>
     <p:sldId id="265" r:id="rId17"/>
     <p:sldId id="266" r:id="rId18"/>
+    <p:sldId id="267" r:id="rId19"/>
   </p:sldIdLst>
   <p:sldSz cx="12192000" cy="6858000" type="screen4x3"/>
   <p:notesSz cx="6858000" cy="9144000"/>
@@ -1387,7 +1388,7 @@
           <a:lstStyle/>
           <a:p>
             <a:r>
-              <a:t>B. Details in docs/06-defence-notes-b.md: the contract, the stub and real split, why SQLite, why the models are baked in.</a:t>
+              <a:t>A. From eval/report/errors.md. The most common failure is answering when it should decline, which is a threshold question rather than a ranking defect.</a:t>
             </a:r>
           </a:p>
         </p:txBody>
@@ -1457,6 +1458,76 @@
           <a:lstStyle/>
           <a:p>
             <a:r>
+              <a:t>B. Details in docs/06-defence-notes-b.md: the contract, the stub and real split, why SQLite, why the models are baked in.</a:t>
+            </a:r>
+          </a:p>
+        </p:txBody>
+      </p:sp>
+      <p:sp>
+        <p:nvSpPr>
+          <p:cNvPr id="4" name="Slide Number Placeholder 3"/>
+          <p:cNvSpPr>
+            <a:spLocks noGrp="1"/>
+          </p:cNvSpPr>
+          <p:nvPr>
+            <p:ph type="sldNum" idx="5" sz="quarter"/>
+          </p:nvPr>
+        </p:nvSpPr>
+        <p:spPr/>
+      </p:sp>
+    </p:spTree>
+  </p:cSld>
+  <p:clrMapOvr>
+    <a:masterClrMapping/>
+  </p:clrMapOvr>
+</p:notes>
+</file>
+
+<file path=ppt/notesSlides/notesSlide12.xml><?xml version="1.0" encoding="utf-8"?>
+<p:notes xmlns:a="http://schemas.openxmlformats.org/drawingml/2006/main" xmlns:p="http://schemas.openxmlformats.org/presentationml/2006/main" xmlns:r="http://schemas.openxmlformats.org/officeDocument/2006/relationships">
+  <p:cSld>
+    <p:spTree>
+      <p:nvGrpSpPr>
+        <p:cNvPr id="1" name=""/>
+        <p:cNvGrpSpPr/>
+        <p:nvPr/>
+      </p:nvGrpSpPr>
+      <p:grpSpPr>
+        <a:xfrm>
+          <a:off x="0" y="0"/>
+          <a:ext cx="0" cy="0"/>
+          <a:chOff x="0" y="0"/>
+          <a:chExt cx="0" cy="0"/>
+        </a:xfrm>
+      </p:grpSpPr>
+      <p:sp>
+        <p:nvSpPr>
+          <p:cNvPr id="2" name="Slide Image Placeholder 1"/>
+          <p:cNvSpPr>
+            <a:spLocks noGrp="1"/>
+          </p:cNvSpPr>
+          <p:nvPr>
+            <p:ph type="sldImg" idx="2"/>
+          </p:nvPr>
+        </p:nvSpPr>
+        <p:spPr/>
+      </p:sp>
+      <p:sp>
+        <p:nvSpPr>
+          <p:cNvPr id="3" name="Notes Placeholder 2"/>
+          <p:cNvSpPr>
+            <a:spLocks noGrp="1"/>
+          </p:cNvSpPr>
+          <p:nvPr>
+            <p:ph type="body" idx="3" sz="quarter"/>
+          </p:nvPr>
+        </p:nvSpPr>
+        <p:spPr/>
+        <p:txBody>
+          <a:bodyPr/>
+          <a:lstStyle/>
+          <a:p>
+            <a:r>
               <a:t>Both. A takes NLP and IR questions, B takes engineering questions.</a:t>
             </a:r>
           </a:p>
@@ -1667,7 +1738,7 @@
           <a:lstStyle/>
           <a:p>
             <a:r>
-              <a:t>B drives, A narrates the matches. Rehearsed offline (S7-AB2). If the demo fails, the README screenshots are the fallback.</a:t>
+              <a:t>B drives, A narrates the matches. Rehearsed offline (S7-AB2), script in docs/07-demo-script.md. If the demo fails, the screenshots taken during the rehearsal, in docs/screenshots/, are the fallback.</a:t>
             </a:r>
           </a:p>
         </p:txBody>
@@ -2017,7 +2088,7 @@
           <a:lstStyle/>
           <a:p>
             <a:r>
-              <a:t>A. From eval/report/errors.md. The most common failure is answering when it should decline, which is a threshold question rather than a ranking defect.</a:t>
+              <a:t>B. frontend/src/lib/score.ts, the calibrated and provisional flags on GET /api/v1/strategies, and GET /api/v1/evaluation. The point: the numbers are only as good as the labels, and the interface never claims more than that.</a:t>
             </a:r>
           </a:p>
         </p:txBody>
@@ -5791,7 +5862,7 @@
                 </a:solidFill>
                 <a:latin typeface="Cambria"/>
               </a:rPr>
-              <a:t>Engineering choices</a:t>
+              <a:t>Where it goes wrong</a:t>
             </a:r>
           </a:p>
         </p:txBody>
@@ -5804,8 +5875,63 @@
         </p:nvSpPr>
         <p:spPr>
           <a:xfrm>
+            <a:off x="9464040" y="457200"/>
+            <a:ext cx="2194560" cy="384048"/>
+          </a:xfrm>
+          <a:prstGeom prst="roundRect">
+            <a:avLst>
+              <a:gd name="adj" fmla="val 12000"/>
+            </a:avLst>
+          </a:prstGeom>
+          <a:solidFill>
+            <a:srgbClr val="F2B705"/>
+          </a:solidFill>
+          <a:ln>
+            <a:noFill/>
+          </a:ln>
+          <a:effectLst/>
+        </p:spPr>
+        <p:style>
+          <a:lnRef idx="1">
+            <a:schemeClr val="accent1"/>
+          </a:lnRef>
+          <a:fillRef idx="3">
+            <a:schemeClr val="accent1"/>
+          </a:fillRef>
+          <a:effectRef idx="2">
+            <a:schemeClr val="accent1"/>
+          </a:effectRef>
+          <a:fontRef idx="minor">
+            <a:schemeClr val="lt1"/>
+          </a:fontRef>
+        </p:style>
+        <p:txBody>
+          <a:bodyPr rtlCol="0" anchor="ctr" tIns="0" bIns="0"/>
+          <a:lstStyle/>
+          <a:p>
+            <a:pPr algn="ctr"/>
+            <a:r>
+              <a:rPr sz="1200" b="1">
+                <a:solidFill>
+                  <a:srgbClr val="14234B"/>
+                </a:solidFill>
+                <a:latin typeface="Calibri"/>
+              </a:rPr>
+              <a:t>PROVISIONAL LABELS</a:t>
+            </a:r>
+          </a:p>
+        </p:txBody>
+      </p:sp>
+      <p:sp>
+        <p:nvSpPr>
+          <p:cNvPr id="4" name="Rounded Rectangle 3"/>
+          <p:cNvSpPr/>
+          <p:nvPr/>
+        </p:nvSpPr>
+        <p:spPr>
+          <a:xfrm>
             <a:off x="548640" y="1463040"/>
-            <a:ext cx="11064240" cy="960120"/>
+            <a:ext cx="5394960" cy="2103120"/>
           </a:xfrm>
           <a:prstGeom prst="roundRect">
             <a:avLst>
@@ -5844,14 +5970,67 @@
       </p:sp>
       <p:sp>
         <p:nvSpPr>
-          <p:cNvPr id="4" name="TextBox 3"/>
+          <p:cNvPr id="5" name="Oval 4"/>
+          <p:cNvSpPr/>
+          <p:nvPr/>
+        </p:nvSpPr>
+        <p:spPr>
+          <a:xfrm>
+            <a:off x="822960" y="1737360"/>
+            <a:ext cx="502920" cy="502920"/>
+          </a:xfrm>
+          <a:prstGeom prst="ellipse">
+            <a:avLst/>
+          </a:prstGeom>
+          <a:solidFill>
+            <a:srgbClr val="14234B"/>
+          </a:solidFill>
+          <a:ln>
+            <a:noFill/>
+          </a:ln>
+          <a:effectLst/>
+        </p:spPr>
+        <p:style>
+          <a:lnRef idx="1">
+            <a:schemeClr val="accent1"/>
+          </a:lnRef>
+          <a:fillRef idx="3">
+            <a:schemeClr val="accent1"/>
+          </a:fillRef>
+          <a:effectRef idx="2">
+            <a:schemeClr val="accent1"/>
+          </a:effectRef>
+          <a:fontRef idx="minor">
+            <a:schemeClr val="lt1"/>
+          </a:fontRef>
+        </p:style>
+        <p:txBody>
+          <a:bodyPr rtlCol="0" anchor="ctr" lIns="0" rIns="0" tIns="0" bIns="0"/>
+          <a:lstStyle/>
+          <a:p>
+            <a:pPr algn="ctr"/>
+            <a:r>
+              <a:rPr sz="1800" b="1">
+                <a:solidFill>
+                  <a:srgbClr val="FFFFFF"/>
+                </a:solidFill>
+                <a:latin typeface="Cambria"/>
+              </a:rPr>
+              <a:t>1</a:t>
+            </a:r>
+          </a:p>
+        </p:txBody>
+      </p:sp>
+      <p:sp>
+        <p:nvSpPr>
+          <p:cNvPr id="6" name="TextBox 5"/>
           <p:cNvSpPr txBox="1"/>
           <p:nvPr/>
         </p:nvSpPr>
         <p:spPr>
           <a:xfrm>
-            <a:off x="822960" y="1554480"/>
-            <a:ext cx="3017520" cy="777240"/>
+            <a:off x="1554480" y="1764792"/>
+            <a:ext cx="4114800" cy="457200"/>
           </a:xfrm>
           <a:prstGeom prst="rect">
             <a:avLst/>
@@ -5859,7 +6038,7 @@
           <a:noFill/>
         </p:spPr>
         <p:txBody>
-          <a:bodyPr wrap="square" anchor="ctr" lIns="0" rIns="0" tIns="0" bIns="0">
+          <a:bodyPr wrap="square" anchor="t" lIns="0" rIns="0" tIns="0" bIns="0">
             <a:spAutoFit/>
           </a:bodyPr>
           <a:lstStyle/>
@@ -5876,21 +6055,21 @@
                 </a:solidFill>
                 <a:latin typeface="Cambria"/>
               </a:rPr>
-              <a:t>Frozen contract</a:t>
-            </a:r>
-          </a:p>
-        </p:txBody>
-      </p:sp>
-      <p:sp>
-        <p:nvSpPr>
-          <p:cNvPr id="5" name="TextBox 4"/>
+              <a:t>No equivalent exists</a:t>
+            </a:r>
+          </a:p>
+        </p:txBody>
+      </p:sp>
+      <p:sp>
+        <p:nvSpPr>
+          <p:cNvPr id="7" name="TextBox 6"/>
           <p:cNvSpPr txBox="1"/>
           <p:nvPr/>
         </p:nvSpPr>
         <p:spPr>
           <a:xfrm>
-            <a:off x="3931920" y="1554480"/>
-            <a:ext cx="7498079" cy="777240"/>
+            <a:off x="1554480" y="2286000"/>
+            <a:ext cx="4114800" cy="1188720"/>
           </a:xfrm>
           <a:prstGeom prst="rect">
             <a:avLst/>
@@ -5898,7 +6077,7 @@
           <a:noFill/>
         </p:spPr>
         <p:txBody>
-          <a:bodyPr wrap="square" anchor="ctr" lIns="0" rIns="0" tIns="0" bIns="0">
+          <a:bodyPr wrap="square" anchor="t" lIns="0" rIns="0" tIns="0" bIns="0">
             <a:spAutoFit/>
           </a:bodyPr>
           <a:lstStyle/>
@@ -5909,27 +6088,27 @@
               </a:spcAft>
             </a:pPr>
             <a:r>
-              <a:rPr sz="1500" b="0" i="0">
+              <a:rPr sz="1400" b="0" i="0">
                 <a:solidFill>
                   <a:srgbClr val="1F2433"/>
                 </a:solidFill>
                 <a:latin typeface="Calibri"/>
               </a:rPr>
-              <a:t>A Matcher protocol and a stub let the interface and the engine be built in parallel from day one.</a:t>
-            </a:r>
-          </a:p>
-        </p:txBody>
-      </p:sp>
-      <p:sp>
-        <p:nvSpPr>
-          <p:cNvPr id="6" name="Rounded Rectangle 5"/>
+              <a:t>Algebra against a computer science catalogue still returns five candidates. Ranking cannot say none of these; a confidence floor can.</a:t>
+            </a:r>
+          </a:p>
+        </p:txBody>
+      </p:sp>
+      <p:sp>
+        <p:nvSpPr>
+          <p:cNvPr id="8" name="Rounded Rectangle 7"/>
           <p:cNvSpPr/>
           <p:nvPr/>
         </p:nvSpPr>
         <p:spPr>
           <a:xfrm>
-            <a:off x="548640" y="2651760"/>
-            <a:ext cx="11064240" cy="960120"/>
+            <a:off x="6217920" y="1463040"/>
+            <a:ext cx="5394960" cy="2103120"/>
           </a:xfrm>
           <a:prstGeom prst="roundRect">
             <a:avLst>
@@ -5968,14 +6147,67 @@
       </p:sp>
       <p:sp>
         <p:nvSpPr>
-          <p:cNvPr id="7" name="TextBox 6"/>
+          <p:cNvPr id="9" name="Oval 8"/>
+          <p:cNvSpPr/>
+          <p:nvPr/>
+        </p:nvSpPr>
+        <p:spPr>
+          <a:xfrm>
+            <a:off x="6492240" y="1737360"/>
+            <a:ext cx="502920" cy="502920"/>
+          </a:xfrm>
+          <a:prstGeom prst="ellipse">
+            <a:avLst/>
+          </a:prstGeom>
+          <a:solidFill>
+            <a:srgbClr val="14234B"/>
+          </a:solidFill>
+          <a:ln>
+            <a:noFill/>
+          </a:ln>
+          <a:effectLst/>
+        </p:spPr>
+        <p:style>
+          <a:lnRef idx="1">
+            <a:schemeClr val="accent1"/>
+          </a:lnRef>
+          <a:fillRef idx="3">
+            <a:schemeClr val="accent1"/>
+          </a:fillRef>
+          <a:effectRef idx="2">
+            <a:schemeClr val="accent1"/>
+          </a:effectRef>
+          <a:fontRef idx="minor">
+            <a:schemeClr val="lt1"/>
+          </a:fontRef>
+        </p:style>
+        <p:txBody>
+          <a:bodyPr rtlCol="0" anchor="ctr" lIns="0" rIns="0" tIns="0" bIns="0"/>
+          <a:lstStyle/>
+          <a:p>
+            <a:pPr algn="ctr"/>
+            <a:r>
+              <a:rPr sz="1800" b="1">
+                <a:solidFill>
+                  <a:srgbClr val="FFFFFF"/>
+                </a:solidFill>
+                <a:latin typeface="Cambria"/>
+              </a:rPr>
+              <a:t>2</a:t>
+            </a:r>
+          </a:p>
+        </p:txBody>
+      </p:sp>
+      <p:sp>
+        <p:nvSpPr>
+          <p:cNvPr id="10" name="TextBox 9"/>
           <p:cNvSpPr txBox="1"/>
           <p:nvPr/>
         </p:nvSpPr>
         <p:spPr>
           <a:xfrm>
-            <a:off x="822960" y="2743200"/>
-            <a:ext cx="3017520" cy="777240"/>
+            <a:off x="7223760" y="1764792"/>
+            <a:ext cx="4114800" cy="457200"/>
           </a:xfrm>
           <a:prstGeom prst="rect">
             <a:avLst/>
@@ -5983,7 +6215,7 @@
           <a:noFill/>
         </p:spPr>
         <p:txBody>
-          <a:bodyPr wrap="square" anchor="ctr" lIns="0" rIns="0" tIns="0" bIns="0">
+          <a:bodyPr wrap="square" anchor="t" lIns="0" rIns="0" tIns="0" bIns="0">
             <a:spAutoFit/>
           </a:bodyPr>
           <a:lstStyle/>
@@ -6000,21 +6232,21 @@
                 </a:solidFill>
                 <a:latin typeface="Cambria"/>
               </a:rPr>
-              <a:t>Offline by design</a:t>
-            </a:r>
-          </a:p>
-        </p:txBody>
-      </p:sp>
-      <p:sp>
-        <p:nvSpPr>
-          <p:cNvPr id="8" name="TextBox 7"/>
+              <a:t>Granularity</a:t>
+            </a:r>
+          </a:p>
+        </p:txBody>
+      </p:sp>
+      <p:sp>
+        <p:nvSpPr>
+          <p:cNvPr id="11" name="TextBox 10"/>
           <p:cNvSpPr txBox="1"/>
           <p:nvPr/>
         </p:nvSpPr>
         <p:spPr>
           <a:xfrm>
-            <a:off x="3931920" y="2743200"/>
-            <a:ext cx="7498079" cy="777240"/>
+            <a:off x="7223760" y="2286000"/>
+            <a:ext cx="4114800" cy="1188720"/>
           </a:xfrm>
           <a:prstGeom prst="rect">
             <a:avLst/>
@@ -6022,7 +6254,7 @@
           <a:noFill/>
         </p:spPr>
         <p:txBody>
-          <a:bodyPr wrap="square" anchor="ctr" lIns="0" rIns="0" tIns="0" bIns="0">
+          <a:bodyPr wrap="square" anchor="t" lIns="0" rIns="0" tIns="0" bIns="0">
             <a:spAutoFit/>
           </a:bodyPr>
           <a:lstStyle/>
@@ -6033,27 +6265,27 @@
               </a:spcAft>
             </a:pPr>
             <a:r>
-              <a:rPr sz="1500" b="0" i="0">
+              <a:rPr sz="1400" b="0" i="0">
                 <a:solidFill>
                   <a:srgbClr val="1F2433"/>
                 </a:solidFill>
                 <a:latin typeface="Calibri"/>
               </a:rPr>
-              <a:t>Models baked into the image at build time; the runtime never touches the network.</a:t>
-            </a:r>
-          </a:p>
-        </p:txBody>
-      </p:sp>
-      <p:sp>
-        <p:nvSpPr>
-          <p:cNvPr id="9" name="Rounded Rectangle 8"/>
+              <a:t>The right answer is half of a 15 ECTS module, and the whole module description dilutes it.</a:t>
+            </a:r>
+          </a:p>
+        </p:txBody>
+      </p:sp>
+      <p:sp>
+        <p:nvSpPr>
+          <p:cNvPr id="12" name="Rounded Rectangle 11"/>
           <p:cNvSpPr/>
           <p:nvPr/>
         </p:nvSpPr>
         <p:spPr>
           <a:xfrm>
             <a:off x="548640" y="3840480"/>
-            <a:ext cx="11064240" cy="960120"/>
+            <a:ext cx="5394960" cy="2103120"/>
           </a:xfrm>
           <a:prstGeom prst="roundRect">
             <a:avLst>
@@ -6092,14 +6324,67 @@
       </p:sp>
       <p:sp>
         <p:nvSpPr>
-          <p:cNvPr id="10" name="TextBox 9"/>
+          <p:cNvPr id="13" name="Oval 12"/>
+          <p:cNvSpPr/>
+          <p:nvPr/>
+        </p:nvSpPr>
+        <p:spPr>
+          <a:xfrm>
+            <a:off x="822960" y="4114800"/>
+            <a:ext cx="502920" cy="502920"/>
+          </a:xfrm>
+          <a:prstGeom prst="ellipse">
+            <a:avLst/>
+          </a:prstGeom>
+          <a:solidFill>
+            <a:srgbClr val="14234B"/>
+          </a:solidFill>
+          <a:ln>
+            <a:noFill/>
+          </a:ln>
+          <a:effectLst/>
+        </p:spPr>
+        <p:style>
+          <a:lnRef idx="1">
+            <a:schemeClr val="accent1"/>
+          </a:lnRef>
+          <a:fillRef idx="3">
+            <a:schemeClr val="accent1"/>
+          </a:fillRef>
+          <a:effectRef idx="2">
+            <a:schemeClr val="accent1"/>
+          </a:effectRef>
+          <a:fontRef idx="minor">
+            <a:schemeClr val="lt1"/>
+          </a:fontRef>
+        </p:style>
+        <p:txBody>
+          <a:bodyPr rtlCol="0" anchor="ctr" lIns="0" rIns="0" tIns="0" bIns="0"/>
+          <a:lstStyle/>
+          <a:p>
+            <a:pPr algn="ctr"/>
+            <a:r>
+              <a:rPr sz="1800" b="1">
+                <a:solidFill>
+                  <a:srgbClr val="FFFFFF"/>
+                </a:solidFill>
+                <a:latin typeface="Cambria"/>
+              </a:rPr>
+              <a:t>3</a:t>
+            </a:r>
+          </a:p>
+        </p:txBody>
+      </p:sp>
+      <p:sp>
+        <p:nvSpPr>
+          <p:cNvPr id="14" name="TextBox 13"/>
           <p:cNvSpPr txBox="1"/>
           <p:nvPr/>
         </p:nvSpPr>
         <p:spPr>
           <a:xfrm>
-            <a:off x="822960" y="3931920"/>
-            <a:ext cx="3017520" cy="777240"/>
+            <a:off x="1554480" y="4142232"/>
+            <a:ext cx="4114800" cy="457200"/>
           </a:xfrm>
           <a:prstGeom prst="rect">
             <a:avLst/>
@@ -6107,7 +6392,7 @@
           <a:noFill/>
         </p:spPr>
         <p:txBody>
-          <a:bodyPr wrap="square" anchor="ctr" lIns="0" rIns="0" tIns="0" bIns="0">
+          <a:bodyPr wrap="square" anchor="t" lIns="0" rIns="0" tIns="0" bIns="0">
             <a:spAutoFit/>
           </a:bodyPr>
           <a:lstStyle/>
@@ -6124,21 +6409,21 @@
                 </a:solidFill>
                 <a:latin typeface="Cambria"/>
               </a:rPr>
-              <a:t>SQLite</a:t>
-            </a:r>
-          </a:p>
-        </p:txBody>
-      </p:sp>
-      <p:sp>
-        <p:nvSpPr>
-          <p:cNvPr id="11" name="TextBox 10"/>
+              <a:t>Look-alike projects</a:t>
+            </a:r>
+          </a:p>
+        </p:txBody>
+      </p:sp>
+      <p:sp>
+        <p:nvSpPr>
+          <p:cNvPr id="15" name="TextBox 14"/>
           <p:cNvSpPr txBox="1"/>
           <p:nvPr/>
         </p:nvSpPr>
         <p:spPr>
           <a:xfrm>
-            <a:off x="3931920" y="3931920"/>
-            <a:ext cx="7498079" cy="777240"/>
+            <a:off x="1554480" y="4663440"/>
+            <a:ext cx="4114800" cy="1188720"/>
           </a:xfrm>
           <a:prstGeom prst="rect">
             <a:avLst/>
@@ -6146,7 +6431,7 @@
           <a:noFill/>
         </p:spPr>
         <p:txBody>
-          <a:bodyPr wrap="square" anchor="ctr" lIns="0" rIns="0" tIns="0" bIns="0">
+          <a:bodyPr wrap="square" anchor="t" lIns="0" rIns="0" tIns="0" bIns="0">
             <a:spAutoFit/>
           </a:bodyPr>
           <a:lstStyle/>
@@ -6157,27 +6442,27 @@
               </a:spcAft>
             </a:pPr>
             <a:r>
-              <a:rPr sz="1500" b="0" i="0">
+              <a:rPr sz="1400" b="0" i="0">
                 <a:solidFill>
                   <a:srgbClr val="1F2433"/>
                 </a:solidFill>
                 <a:latin typeface="Calibri"/>
               </a:rPr>
-              <a:t>A few hundred courses: one file in a volume keeps compose to two services.</a:t>
-            </a:r>
-          </a:p>
-        </p:txBody>
-      </p:sp>
-      <p:sp>
-        <p:nvSpPr>
-          <p:cNvPr id="12" name="Rounded Rectangle 11"/>
+              <a:t>Project courses read alike across a catalogue, so the text cannot separate them.</a:t>
+            </a:r>
+          </a:p>
+        </p:txBody>
+      </p:sp>
+      <p:sp>
+        <p:nvSpPr>
+          <p:cNvPr id="16" name="Rounded Rectangle 15"/>
           <p:cNvSpPr/>
           <p:nvPr/>
         </p:nvSpPr>
         <p:spPr>
           <a:xfrm>
-            <a:off x="548640" y="5029200"/>
-            <a:ext cx="11064240" cy="960120"/>
+            <a:off x="6217920" y="3840480"/>
+            <a:ext cx="5394960" cy="2103120"/>
           </a:xfrm>
           <a:prstGeom prst="roundRect">
             <a:avLst>
@@ -6216,14 +6501,67 @@
       </p:sp>
       <p:sp>
         <p:nvSpPr>
-          <p:cNvPr id="13" name="TextBox 12"/>
+          <p:cNvPr id="17" name="Oval 16"/>
+          <p:cNvSpPr/>
+          <p:nvPr/>
+        </p:nvSpPr>
+        <p:spPr>
+          <a:xfrm>
+            <a:off x="6492240" y="4114800"/>
+            <a:ext cx="502920" cy="502920"/>
+          </a:xfrm>
+          <a:prstGeom prst="ellipse">
+            <a:avLst/>
+          </a:prstGeom>
+          <a:solidFill>
+            <a:srgbClr val="14234B"/>
+          </a:solidFill>
+          <a:ln>
+            <a:noFill/>
+          </a:ln>
+          <a:effectLst/>
+        </p:spPr>
+        <p:style>
+          <a:lnRef idx="1">
+            <a:schemeClr val="accent1"/>
+          </a:lnRef>
+          <a:fillRef idx="3">
+            <a:schemeClr val="accent1"/>
+          </a:fillRef>
+          <a:effectRef idx="2">
+            <a:schemeClr val="accent1"/>
+          </a:effectRef>
+          <a:fontRef idx="minor">
+            <a:schemeClr val="lt1"/>
+          </a:fontRef>
+        </p:style>
+        <p:txBody>
+          <a:bodyPr rtlCol="0" anchor="ctr" lIns="0" rIns="0" tIns="0" bIns="0"/>
+          <a:lstStyle/>
+          <a:p>
+            <a:pPr algn="ctr"/>
+            <a:r>
+              <a:rPr sz="1800" b="1">
+                <a:solidFill>
+                  <a:srgbClr val="FFFFFF"/>
+                </a:solidFill>
+                <a:latin typeface="Cambria"/>
+              </a:rPr>
+              <a:t>4</a:t>
+            </a:r>
+          </a:p>
+        </p:txBody>
+      </p:sp>
+      <p:sp>
+        <p:nvSpPr>
+          <p:cNvPr id="18" name="TextBox 17"/>
           <p:cNvSpPr txBox="1"/>
           <p:nvPr/>
         </p:nvSpPr>
         <p:spPr>
           <a:xfrm>
-            <a:off x="822960" y="5120640"/>
-            <a:ext cx="3017520" cy="777240"/>
+            <a:off x="7223760" y="4142232"/>
+            <a:ext cx="4114800" cy="457200"/>
           </a:xfrm>
           <a:prstGeom prst="rect">
             <a:avLst/>
@@ -6231,7 +6569,7 @@
           <a:noFill/>
         </p:spPr>
         <p:txBody>
-          <a:bodyPr wrap="square" anchor="ctr" lIns="0" rIns="0" tIns="0" bIns="0">
+          <a:bodyPr wrap="square" anchor="t" lIns="0" rIns="0" tIns="0" bIns="0">
             <a:spAutoFit/>
           </a:bodyPr>
           <a:lstStyle/>
@@ -6248,21 +6586,21 @@
                 </a:solidFill>
                 <a:latin typeface="Cambria"/>
               </a:rPr>
-              <a:t>Clean-machine build</a:t>
-            </a:r>
-          </a:p>
-        </p:txBody>
-      </p:sp>
-      <p:sp>
-        <p:nvSpPr>
-          <p:cNvPr id="14" name="TextBox 13"/>
+              <a:t>Level in the title</a:t>
+            </a:r>
+          </a:p>
+        </p:txBody>
+      </p:sp>
+      <p:sp>
+        <p:nvSpPr>
+          <p:cNvPr id="19" name="TextBox 18"/>
           <p:cNvSpPr txBox="1"/>
           <p:nvPr/>
         </p:nvSpPr>
         <p:spPr>
           <a:xfrm>
-            <a:off x="3931920" y="5120640"/>
-            <a:ext cx="7498079" cy="777240"/>
+            <a:off x="7223760" y="4663440"/>
+            <a:ext cx="4114800" cy="1188720"/>
           </a:xfrm>
           <a:prstGeom prst="rect">
             <a:avLst/>
@@ -6270,7 +6608,7 @@
           <a:noFill/>
         </p:spPr>
         <p:txBody>
-          <a:bodyPr wrap="square" anchor="ctr" lIns="0" rIns="0" tIns="0" bIns="0">
+          <a:bodyPr wrap="square" anchor="t" lIns="0" rIns="0" tIns="0" bIns="0">
             <a:spAutoFit/>
           </a:bodyPr>
           <a:lstStyle/>
@@ -6281,13 +6619,13 @@
               </a:spcAft>
             </a:pPr>
             <a:r>
-              <a:rPr sz="1500" b="0" i="0">
+              <a:rPr sz="1400" b="0" i="0">
                 <a:solidFill>
                   <a:srgbClr val="1F2433"/>
                 </a:solidFill>
                 <a:latin typeface="Calibri"/>
               </a:rPr>
-              <a:t>Fresh clone to running app measured at 297 s, recorded in the README.</a:t>
+              <a:t>Modelling and Programming 3 outranks 1: the sequence number is kept out of the embedding by design (ADR-0004).</a:t>
             </a:r>
           </a:p>
         </p:txBody>
@@ -6301,6 +6639,567 @@
 </file>
 
 <file path=ppt/slides/slide11.xml><?xml version="1.0" encoding="utf-8"?>
+<p:sld xmlns:a="http://schemas.openxmlformats.org/drawingml/2006/main" xmlns:p="http://schemas.openxmlformats.org/presentationml/2006/main" xmlns:r="http://schemas.openxmlformats.org/officeDocument/2006/relationships">
+  <p:cSld>
+    <p:bg>
+      <p:bgPr>
+        <a:solidFill>
+          <a:srgbClr val="FFFFFF"/>
+        </a:solidFill>
+        <a:effectLst/>
+      </p:bgPr>
+    </p:bg>
+    <p:spTree>
+      <p:nvGrpSpPr>
+        <p:cNvPr id="1" name=""/>
+        <p:cNvGrpSpPr/>
+        <p:nvPr/>
+      </p:nvGrpSpPr>
+      <p:grpSpPr/>
+      <p:sp>
+        <p:nvSpPr>
+          <p:cNvPr id="2" name="TextBox 1"/>
+          <p:cNvSpPr txBox="1"/>
+          <p:nvPr/>
+        </p:nvSpPr>
+        <p:spPr>
+          <a:xfrm>
+            <a:off x="548640" y="411480"/>
+            <a:ext cx="11064240" cy="822960"/>
+          </a:xfrm>
+          <a:prstGeom prst="rect">
+            <a:avLst/>
+          </a:prstGeom>
+          <a:noFill/>
+        </p:spPr>
+        <p:txBody>
+          <a:bodyPr wrap="square" anchor="t" lIns="0" rIns="0" tIns="0" bIns="0">
+            <a:spAutoFit/>
+          </a:bodyPr>
+          <a:lstStyle/>
+          <a:p>
+            <a:pPr algn="l">
+              <a:spcAft>
+                <a:spcPts val="800"/>
+              </a:spcAft>
+            </a:pPr>
+            <a:r>
+              <a:rPr sz="3600" b="1" i="0">
+                <a:solidFill>
+                  <a:srgbClr val="14234B"/>
+                </a:solidFill>
+                <a:latin typeface="Cambria"/>
+              </a:rPr>
+              <a:t>Engineering choices</a:t>
+            </a:r>
+          </a:p>
+        </p:txBody>
+      </p:sp>
+      <p:sp>
+        <p:nvSpPr>
+          <p:cNvPr id="3" name="Rounded Rectangle 2"/>
+          <p:cNvSpPr/>
+          <p:nvPr/>
+        </p:nvSpPr>
+        <p:spPr>
+          <a:xfrm>
+            <a:off x="548640" y="1463040"/>
+            <a:ext cx="11064240" cy="960120"/>
+          </a:xfrm>
+          <a:prstGeom prst="roundRect">
+            <a:avLst>
+              <a:gd name="adj" fmla="val 12000"/>
+            </a:avLst>
+          </a:prstGeom>
+          <a:solidFill>
+            <a:srgbClr val="EEF1F8"/>
+          </a:solidFill>
+          <a:ln>
+            <a:noFill/>
+          </a:ln>
+          <a:effectLst/>
+        </p:spPr>
+        <p:style>
+          <a:lnRef idx="1">
+            <a:schemeClr val="accent1"/>
+          </a:lnRef>
+          <a:fillRef idx="3">
+            <a:schemeClr val="accent1"/>
+          </a:fillRef>
+          <a:effectRef idx="2">
+            <a:schemeClr val="accent1"/>
+          </a:effectRef>
+          <a:fontRef idx="minor">
+            <a:schemeClr val="lt1"/>
+          </a:fontRef>
+        </p:style>
+        <p:txBody>
+          <a:bodyPr rtlCol="0" anchor="ctr"/>
+          <a:lstStyle/>
+          <a:p>
+            <a:pPr algn="ctr"/>
+          </a:p>
+        </p:txBody>
+      </p:sp>
+      <p:sp>
+        <p:nvSpPr>
+          <p:cNvPr id="4" name="TextBox 3"/>
+          <p:cNvSpPr txBox="1"/>
+          <p:nvPr/>
+        </p:nvSpPr>
+        <p:spPr>
+          <a:xfrm>
+            <a:off x="822960" y="1554480"/>
+            <a:ext cx="3017520" cy="777240"/>
+          </a:xfrm>
+          <a:prstGeom prst="rect">
+            <a:avLst/>
+          </a:prstGeom>
+          <a:noFill/>
+        </p:spPr>
+        <p:txBody>
+          <a:bodyPr wrap="square" anchor="ctr" lIns="0" rIns="0" tIns="0" bIns="0">
+            <a:spAutoFit/>
+          </a:bodyPr>
+          <a:lstStyle/>
+          <a:p>
+            <a:pPr algn="l">
+              <a:spcAft>
+                <a:spcPts val="800"/>
+              </a:spcAft>
+            </a:pPr>
+            <a:r>
+              <a:rPr sz="1800" b="1" i="0">
+                <a:solidFill>
+                  <a:srgbClr val="14234B"/>
+                </a:solidFill>
+                <a:latin typeface="Cambria"/>
+              </a:rPr>
+              <a:t>Frozen contract</a:t>
+            </a:r>
+          </a:p>
+        </p:txBody>
+      </p:sp>
+      <p:sp>
+        <p:nvSpPr>
+          <p:cNvPr id="5" name="TextBox 4"/>
+          <p:cNvSpPr txBox="1"/>
+          <p:nvPr/>
+        </p:nvSpPr>
+        <p:spPr>
+          <a:xfrm>
+            <a:off x="3931920" y="1554480"/>
+            <a:ext cx="7498079" cy="777240"/>
+          </a:xfrm>
+          <a:prstGeom prst="rect">
+            <a:avLst/>
+          </a:prstGeom>
+          <a:noFill/>
+        </p:spPr>
+        <p:txBody>
+          <a:bodyPr wrap="square" anchor="ctr" lIns="0" rIns="0" tIns="0" bIns="0">
+            <a:spAutoFit/>
+          </a:bodyPr>
+          <a:lstStyle/>
+          <a:p>
+            <a:pPr algn="l">
+              <a:spcAft>
+                <a:spcPts val="800"/>
+              </a:spcAft>
+            </a:pPr>
+            <a:r>
+              <a:rPr sz="1500" b="0" i="0">
+                <a:solidFill>
+                  <a:srgbClr val="1F2433"/>
+                </a:solidFill>
+                <a:latin typeface="Calibri"/>
+              </a:rPr>
+              <a:t>A Matcher protocol and a stub let the interface and the engine be built in parallel from day one.</a:t>
+            </a:r>
+          </a:p>
+        </p:txBody>
+      </p:sp>
+      <p:sp>
+        <p:nvSpPr>
+          <p:cNvPr id="6" name="Rounded Rectangle 5"/>
+          <p:cNvSpPr/>
+          <p:nvPr/>
+        </p:nvSpPr>
+        <p:spPr>
+          <a:xfrm>
+            <a:off x="548640" y="2651760"/>
+            <a:ext cx="11064240" cy="960120"/>
+          </a:xfrm>
+          <a:prstGeom prst="roundRect">
+            <a:avLst>
+              <a:gd name="adj" fmla="val 12000"/>
+            </a:avLst>
+          </a:prstGeom>
+          <a:solidFill>
+            <a:srgbClr val="EEF1F8"/>
+          </a:solidFill>
+          <a:ln>
+            <a:noFill/>
+          </a:ln>
+          <a:effectLst/>
+        </p:spPr>
+        <p:style>
+          <a:lnRef idx="1">
+            <a:schemeClr val="accent1"/>
+          </a:lnRef>
+          <a:fillRef idx="3">
+            <a:schemeClr val="accent1"/>
+          </a:fillRef>
+          <a:effectRef idx="2">
+            <a:schemeClr val="accent1"/>
+          </a:effectRef>
+          <a:fontRef idx="minor">
+            <a:schemeClr val="lt1"/>
+          </a:fontRef>
+        </p:style>
+        <p:txBody>
+          <a:bodyPr rtlCol="0" anchor="ctr"/>
+          <a:lstStyle/>
+          <a:p>
+            <a:pPr algn="ctr"/>
+          </a:p>
+        </p:txBody>
+      </p:sp>
+      <p:sp>
+        <p:nvSpPr>
+          <p:cNvPr id="7" name="TextBox 6"/>
+          <p:cNvSpPr txBox="1"/>
+          <p:nvPr/>
+        </p:nvSpPr>
+        <p:spPr>
+          <a:xfrm>
+            <a:off x="822960" y="2743200"/>
+            <a:ext cx="3017520" cy="777240"/>
+          </a:xfrm>
+          <a:prstGeom prst="rect">
+            <a:avLst/>
+          </a:prstGeom>
+          <a:noFill/>
+        </p:spPr>
+        <p:txBody>
+          <a:bodyPr wrap="square" anchor="ctr" lIns="0" rIns="0" tIns="0" bIns="0">
+            <a:spAutoFit/>
+          </a:bodyPr>
+          <a:lstStyle/>
+          <a:p>
+            <a:pPr algn="l">
+              <a:spcAft>
+                <a:spcPts val="800"/>
+              </a:spcAft>
+            </a:pPr>
+            <a:r>
+              <a:rPr sz="1800" b="1" i="0">
+                <a:solidFill>
+                  <a:srgbClr val="14234B"/>
+                </a:solidFill>
+                <a:latin typeface="Cambria"/>
+              </a:rPr>
+              <a:t>Offline by design</a:t>
+            </a:r>
+          </a:p>
+        </p:txBody>
+      </p:sp>
+      <p:sp>
+        <p:nvSpPr>
+          <p:cNvPr id="8" name="TextBox 7"/>
+          <p:cNvSpPr txBox="1"/>
+          <p:nvPr/>
+        </p:nvSpPr>
+        <p:spPr>
+          <a:xfrm>
+            <a:off x="3931920" y="2743200"/>
+            <a:ext cx="7498079" cy="777240"/>
+          </a:xfrm>
+          <a:prstGeom prst="rect">
+            <a:avLst/>
+          </a:prstGeom>
+          <a:noFill/>
+        </p:spPr>
+        <p:txBody>
+          <a:bodyPr wrap="square" anchor="ctr" lIns="0" rIns="0" tIns="0" bIns="0">
+            <a:spAutoFit/>
+          </a:bodyPr>
+          <a:lstStyle/>
+          <a:p>
+            <a:pPr algn="l">
+              <a:spcAft>
+                <a:spcPts val="800"/>
+              </a:spcAft>
+            </a:pPr>
+            <a:r>
+              <a:rPr sz="1500" b="0" i="0">
+                <a:solidFill>
+                  <a:srgbClr val="1F2433"/>
+                </a:solidFill>
+                <a:latin typeface="Calibri"/>
+              </a:rPr>
+              <a:t>Models baked into the image at build time; the runtime never touches the network.</a:t>
+            </a:r>
+          </a:p>
+        </p:txBody>
+      </p:sp>
+      <p:sp>
+        <p:nvSpPr>
+          <p:cNvPr id="9" name="Rounded Rectangle 8"/>
+          <p:cNvSpPr/>
+          <p:nvPr/>
+        </p:nvSpPr>
+        <p:spPr>
+          <a:xfrm>
+            <a:off x="548640" y="3840480"/>
+            <a:ext cx="11064240" cy="960120"/>
+          </a:xfrm>
+          <a:prstGeom prst="roundRect">
+            <a:avLst>
+              <a:gd name="adj" fmla="val 12000"/>
+            </a:avLst>
+          </a:prstGeom>
+          <a:solidFill>
+            <a:srgbClr val="EEF1F8"/>
+          </a:solidFill>
+          <a:ln>
+            <a:noFill/>
+          </a:ln>
+          <a:effectLst/>
+        </p:spPr>
+        <p:style>
+          <a:lnRef idx="1">
+            <a:schemeClr val="accent1"/>
+          </a:lnRef>
+          <a:fillRef idx="3">
+            <a:schemeClr val="accent1"/>
+          </a:fillRef>
+          <a:effectRef idx="2">
+            <a:schemeClr val="accent1"/>
+          </a:effectRef>
+          <a:fontRef idx="minor">
+            <a:schemeClr val="lt1"/>
+          </a:fontRef>
+        </p:style>
+        <p:txBody>
+          <a:bodyPr rtlCol="0" anchor="ctr"/>
+          <a:lstStyle/>
+          <a:p>
+            <a:pPr algn="ctr"/>
+          </a:p>
+        </p:txBody>
+      </p:sp>
+      <p:sp>
+        <p:nvSpPr>
+          <p:cNvPr id="10" name="TextBox 9"/>
+          <p:cNvSpPr txBox="1"/>
+          <p:nvPr/>
+        </p:nvSpPr>
+        <p:spPr>
+          <a:xfrm>
+            <a:off x="822960" y="3931920"/>
+            <a:ext cx="3017520" cy="777240"/>
+          </a:xfrm>
+          <a:prstGeom prst="rect">
+            <a:avLst/>
+          </a:prstGeom>
+          <a:noFill/>
+        </p:spPr>
+        <p:txBody>
+          <a:bodyPr wrap="square" anchor="ctr" lIns="0" rIns="0" tIns="0" bIns="0">
+            <a:spAutoFit/>
+          </a:bodyPr>
+          <a:lstStyle/>
+          <a:p>
+            <a:pPr algn="l">
+              <a:spcAft>
+                <a:spcPts val="800"/>
+              </a:spcAft>
+            </a:pPr>
+            <a:r>
+              <a:rPr sz="1800" b="1" i="0">
+                <a:solidFill>
+                  <a:srgbClr val="14234B"/>
+                </a:solidFill>
+                <a:latin typeface="Cambria"/>
+              </a:rPr>
+              <a:t>SQLite</a:t>
+            </a:r>
+          </a:p>
+        </p:txBody>
+      </p:sp>
+      <p:sp>
+        <p:nvSpPr>
+          <p:cNvPr id="11" name="TextBox 10"/>
+          <p:cNvSpPr txBox="1"/>
+          <p:nvPr/>
+        </p:nvSpPr>
+        <p:spPr>
+          <a:xfrm>
+            <a:off x="3931920" y="3931920"/>
+            <a:ext cx="7498079" cy="777240"/>
+          </a:xfrm>
+          <a:prstGeom prst="rect">
+            <a:avLst/>
+          </a:prstGeom>
+          <a:noFill/>
+        </p:spPr>
+        <p:txBody>
+          <a:bodyPr wrap="square" anchor="ctr" lIns="0" rIns="0" tIns="0" bIns="0">
+            <a:spAutoFit/>
+          </a:bodyPr>
+          <a:lstStyle/>
+          <a:p>
+            <a:pPr algn="l">
+              <a:spcAft>
+                <a:spcPts val="800"/>
+              </a:spcAft>
+            </a:pPr>
+            <a:r>
+              <a:rPr sz="1500" b="0" i="0">
+                <a:solidFill>
+                  <a:srgbClr val="1F2433"/>
+                </a:solidFill>
+                <a:latin typeface="Calibri"/>
+              </a:rPr>
+              <a:t>A few hundred courses: one file in a volume keeps compose to two services.</a:t>
+            </a:r>
+          </a:p>
+        </p:txBody>
+      </p:sp>
+      <p:sp>
+        <p:nvSpPr>
+          <p:cNvPr id="12" name="Rounded Rectangle 11"/>
+          <p:cNvSpPr/>
+          <p:nvPr/>
+        </p:nvSpPr>
+        <p:spPr>
+          <a:xfrm>
+            <a:off x="548640" y="5029200"/>
+            <a:ext cx="11064240" cy="960120"/>
+          </a:xfrm>
+          <a:prstGeom prst="roundRect">
+            <a:avLst>
+              <a:gd name="adj" fmla="val 12000"/>
+            </a:avLst>
+          </a:prstGeom>
+          <a:solidFill>
+            <a:srgbClr val="EEF1F8"/>
+          </a:solidFill>
+          <a:ln>
+            <a:noFill/>
+          </a:ln>
+          <a:effectLst/>
+        </p:spPr>
+        <p:style>
+          <a:lnRef idx="1">
+            <a:schemeClr val="accent1"/>
+          </a:lnRef>
+          <a:fillRef idx="3">
+            <a:schemeClr val="accent1"/>
+          </a:fillRef>
+          <a:effectRef idx="2">
+            <a:schemeClr val="accent1"/>
+          </a:effectRef>
+          <a:fontRef idx="minor">
+            <a:schemeClr val="lt1"/>
+          </a:fontRef>
+        </p:style>
+        <p:txBody>
+          <a:bodyPr rtlCol="0" anchor="ctr"/>
+          <a:lstStyle/>
+          <a:p>
+            <a:pPr algn="ctr"/>
+          </a:p>
+        </p:txBody>
+      </p:sp>
+      <p:sp>
+        <p:nvSpPr>
+          <p:cNvPr id="13" name="TextBox 12"/>
+          <p:cNvSpPr txBox="1"/>
+          <p:nvPr/>
+        </p:nvSpPr>
+        <p:spPr>
+          <a:xfrm>
+            <a:off x="822960" y="5120640"/>
+            <a:ext cx="3017520" cy="777240"/>
+          </a:xfrm>
+          <a:prstGeom prst="rect">
+            <a:avLst/>
+          </a:prstGeom>
+          <a:noFill/>
+        </p:spPr>
+        <p:txBody>
+          <a:bodyPr wrap="square" anchor="ctr" lIns="0" rIns="0" tIns="0" bIns="0">
+            <a:spAutoFit/>
+          </a:bodyPr>
+          <a:lstStyle/>
+          <a:p>
+            <a:pPr algn="l">
+              <a:spcAft>
+                <a:spcPts val="800"/>
+              </a:spcAft>
+            </a:pPr>
+            <a:r>
+              <a:rPr sz="1800" b="1" i="0">
+                <a:solidFill>
+                  <a:srgbClr val="14234B"/>
+                </a:solidFill>
+                <a:latin typeface="Cambria"/>
+              </a:rPr>
+              <a:t>Clean-machine build</a:t>
+            </a:r>
+          </a:p>
+        </p:txBody>
+      </p:sp>
+      <p:sp>
+        <p:nvSpPr>
+          <p:cNvPr id="14" name="TextBox 13"/>
+          <p:cNvSpPr txBox="1"/>
+          <p:nvPr/>
+        </p:nvSpPr>
+        <p:spPr>
+          <a:xfrm>
+            <a:off x="3931920" y="5120640"/>
+            <a:ext cx="7498079" cy="777240"/>
+          </a:xfrm>
+          <a:prstGeom prst="rect">
+            <a:avLst/>
+          </a:prstGeom>
+          <a:noFill/>
+        </p:spPr>
+        <p:txBody>
+          <a:bodyPr wrap="square" anchor="ctr" lIns="0" rIns="0" tIns="0" bIns="0">
+            <a:spAutoFit/>
+          </a:bodyPr>
+          <a:lstStyle/>
+          <a:p>
+            <a:pPr algn="l">
+              <a:spcAft>
+                <a:spcPts val="800"/>
+              </a:spcAft>
+            </a:pPr>
+            <a:r>
+              <a:rPr sz="1500" b="0" i="0">
+                <a:solidFill>
+                  <a:srgbClr val="1F2433"/>
+                </a:solidFill>
+                <a:latin typeface="Calibri"/>
+              </a:rPr>
+              <a:t>Fresh clone to running app measured at 297 s, recorded in the README.</a:t>
+            </a:r>
+          </a:p>
+        </p:txBody>
+      </p:sp>
+    </p:spTree>
+  </p:cSld>
+  <p:clrMapOvr>
+    <a:masterClrMapping/>
+  </p:clrMapOvr>
+</p:sld>
+</file>
+
+<file path=ppt/slides/slide12.xml><?xml version="1.0" encoding="utf-8"?>
 <p:sld xmlns:a="http://schemas.openxmlformats.org/drawingml/2006/main" xmlns:p="http://schemas.openxmlformats.org/presentationml/2006/main" xmlns:r="http://schemas.openxmlformats.org/officeDocument/2006/relationships">
   <p:cSld>
     <p:bg>
@@ -8988,7 +9887,7 @@
                 </a:solidFill>
                 <a:latin typeface="Calibri"/>
               </a:rPr>
-              <a:t>Switch to hybrid+ce, then open the evaluation page: the table behind the choice.</a:t>
+              <a:t>Compare one row against hybrid+ce, then open the evaluation page behind the choice.</a:t>
             </a:r>
           </a:p>
         </p:txBody>
@@ -11036,7 +11935,7 @@
                 </a:solidFill>
                 <a:latin typeface="Cambria"/>
               </a:rPr>
-              <a:t>Where it goes wrong</a:t>
+              <a:t>An interface that does not overstate</a:t>
             </a:r>
           </a:p>
         </p:txBody>
@@ -11044,61 +11943,6 @@
       <p:sp>
         <p:nvSpPr>
           <p:cNvPr id="3" name="Rounded Rectangle 2"/>
-          <p:cNvSpPr/>
-          <p:nvPr/>
-        </p:nvSpPr>
-        <p:spPr>
-          <a:xfrm>
-            <a:off x="9464040" y="457200"/>
-            <a:ext cx="2194560" cy="384048"/>
-          </a:xfrm>
-          <a:prstGeom prst="roundRect">
-            <a:avLst>
-              <a:gd name="adj" fmla="val 12000"/>
-            </a:avLst>
-          </a:prstGeom>
-          <a:solidFill>
-            <a:srgbClr val="F2B705"/>
-          </a:solidFill>
-          <a:ln>
-            <a:noFill/>
-          </a:ln>
-          <a:effectLst/>
-        </p:spPr>
-        <p:style>
-          <a:lnRef idx="1">
-            <a:schemeClr val="accent1"/>
-          </a:lnRef>
-          <a:fillRef idx="3">
-            <a:schemeClr val="accent1"/>
-          </a:fillRef>
-          <a:effectRef idx="2">
-            <a:schemeClr val="accent1"/>
-          </a:effectRef>
-          <a:fontRef idx="minor">
-            <a:schemeClr val="lt1"/>
-          </a:fontRef>
-        </p:style>
-        <p:txBody>
-          <a:bodyPr rtlCol="0" anchor="ctr" tIns="0" bIns="0"/>
-          <a:lstStyle/>
-          <a:p>
-            <a:pPr algn="ctr"/>
-            <a:r>
-              <a:rPr sz="1200" b="1">
-                <a:solidFill>
-                  <a:srgbClr val="14234B"/>
-                </a:solidFill>
-                <a:latin typeface="Calibri"/>
-              </a:rPr>
-              <a:t>PROVISIONAL LABELS</a:t>
-            </a:r>
-          </a:p>
-        </p:txBody>
-      </p:sp>
-      <p:sp>
-        <p:nvSpPr>
-          <p:cNvPr id="4" name="Rounded Rectangle 3"/>
           <p:cNvSpPr/>
           <p:nvPr/>
         </p:nvSpPr>
@@ -11144,7 +11988,7 @@
       </p:sp>
       <p:sp>
         <p:nvSpPr>
-          <p:cNvPr id="5" name="Oval 4"/>
+          <p:cNvPr id="4" name="Oval 3"/>
           <p:cNvSpPr/>
           <p:nvPr/>
         </p:nvSpPr>
@@ -11197,7 +12041,7 @@
       </p:sp>
       <p:sp>
         <p:nvSpPr>
-          <p:cNvPr id="6" name="TextBox 5"/>
+          <p:cNvPr id="5" name="TextBox 4"/>
           <p:cNvSpPr txBox="1"/>
           <p:nvPr/>
         </p:nvSpPr>
@@ -11229,14 +12073,14 @@
                 </a:solidFill>
                 <a:latin typeface="Cambria"/>
               </a:rPr>
-              <a:t>No equivalent exists</a:t>
-            </a:r>
-          </a:p>
-        </p:txBody>
-      </p:sp>
-      <p:sp>
-        <p:nvSpPr>
-          <p:cNvPr id="7" name="TextBox 6"/>
+              <a:t>Two kinds of score</a:t>
+            </a:r>
+          </a:p>
+        </p:txBody>
+      </p:sp>
+      <p:sp>
+        <p:nvSpPr>
+          <p:cNvPr id="6" name="TextBox 5"/>
           <p:cNvSpPr txBox="1"/>
           <p:nvPr/>
         </p:nvSpPr>
@@ -11268,14 +12112,14 @@
                 </a:solidFill>
                 <a:latin typeface="Calibri"/>
               </a:rPr>
-              <a:t>Algebra against a computer science catalogue still returns five candidates. Ranking cannot say none of these; a confidence floor can.</a:t>
-            </a:r>
-          </a:p>
-        </p:txBody>
-      </p:sp>
-      <p:sp>
-        <p:nvSpPr>
-          <p:cNvPr id="8" name="Rounded Rectangle 7"/>
+              <a:t>A calibrated strategy shows a percentage and a likely, borderline or unlikely band. The others show a bare relative number and a tooltip saying it is not a probability. One file formats every score.</a:t>
+            </a:r>
+          </a:p>
+        </p:txBody>
+      </p:sp>
+      <p:sp>
+        <p:nvSpPr>
+          <p:cNvPr id="7" name="Rounded Rectangle 6"/>
           <p:cNvSpPr/>
           <p:nvPr/>
         </p:nvSpPr>
@@ -11321,7 +12165,7 @@
       </p:sp>
       <p:sp>
         <p:nvSpPr>
-          <p:cNvPr id="9" name="Oval 8"/>
+          <p:cNvPr id="8" name="Oval 7"/>
           <p:cNvSpPr/>
           <p:nvPr/>
         </p:nvSpPr>
@@ -11374,7 +12218,7 @@
       </p:sp>
       <p:sp>
         <p:nvSpPr>
-          <p:cNvPr id="10" name="TextBox 9"/>
+          <p:cNvPr id="9" name="TextBox 8"/>
           <p:cNvSpPr txBox="1"/>
           <p:nvPr/>
         </p:nvSpPr>
@@ -11406,14 +12250,14 @@
                 </a:solidFill>
                 <a:latin typeface="Cambria"/>
               </a:rPr>
-              <a:t>Granularity</a:t>
-            </a:r>
-          </a:p>
-        </p:txBody>
-      </p:sp>
-      <p:sp>
-        <p:nvSpPr>
-          <p:cNvPr id="11" name="TextBox 10"/>
+              <a:t>No sum without a calibration</a:t>
+            </a:r>
+          </a:p>
+        </p:txBody>
+      </p:sp>
+      <p:sp>
+        <p:nvSpPr>
+          <p:cNvPr id="10" name="TextBox 9"/>
           <p:cNvSpPr txBox="1"/>
           <p:nvPr/>
         </p:nvSpPr>
@@ -11445,14 +12289,14 @@
                 </a:solidFill>
                 <a:latin typeface="Calibri"/>
               </a:rPr>
-              <a:t>The right answer is half of a 15 ECTS module, and the whole module description dilutes it.</a:t>
-            </a:r>
-          </a:p>
-        </p:txBody>
-      </p:sp>
-      <p:sp>
-        <p:nvSpPr>
-          <p:cNvPr id="12" name="Rounded Rectangle 11"/>
+              <a:t>The recognition panel will not add up ECTS for a strategy without a fitted calibration. Summing display values would be arithmetic on the wrong thing.</a:t>
+            </a:r>
+          </a:p>
+        </p:txBody>
+      </p:sp>
+      <p:sp>
+        <p:nvSpPr>
+          <p:cNvPr id="11" name="Rounded Rectangle 10"/>
           <p:cNvSpPr/>
           <p:nvPr/>
         </p:nvSpPr>
@@ -11498,7 +12342,7 @@
       </p:sp>
       <p:sp>
         <p:nvSpPr>
-          <p:cNvPr id="13" name="Oval 12"/>
+          <p:cNvPr id="12" name="Oval 11"/>
           <p:cNvSpPr/>
           <p:nvPr/>
         </p:nvSpPr>
@@ -11551,7 +12395,7 @@
       </p:sp>
       <p:sp>
         <p:nvSpPr>
-          <p:cNvPr id="14" name="TextBox 13"/>
+          <p:cNvPr id="13" name="TextBox 12"/>
           <p:cNvSpPr txBox="1"/>
           <p:nvPr/>
         </p:nvSpPr>
@@ -11583,14 +12427,14 @@
                 </a:solidFill>
                 <a:latin typeface="Cambria"/>
               </a:rPr>
-              <a:t>Look-alike projects</a:t>
-            </a:r>
-          </a:p>
-        </p:txBody>
-      </p:sp>
-      <p:sp>
-        <p:nvSpPr>
-          <p:cNvPr id="15" name="TextBox 14"/>
+              <a:t>Provisional says so</a:t>
+            </a:r>
+          </a:p>
+        </p:txBody>
+      </p:sp>
+      <p:sp>
+        <p:nvSpPr>
+          <p:cNvPr id="14" name="TextBox 13"/>
           <p:cNvSpPr txBox="1"/>
           <p:nvPr/>
         </p:nvSpPr>
@@ -11622,14 +12466,14 @@
                 </a:solidFill>
                 <a:latin typeface="Calibri"/>
               </a:rPr>
-              <a:t>Project courses read alike across a catalogue, so the text cannot separate them.</a:t>
-            </a:r>
-          </a:p>
-        </p:txBody>
-      </p:sp>
-      <p:sp>
-        <p:nvSpPr>
-          <p:cNvPr id="16" name="Rounded Rectangle 15"/>
+              <a:t>While a calibration rests on machine labels, every probability and the ECTS estimate carry a warning. The flag is read from the calibration file, not typed into the interface.</a:t>
+            </a:r>
+          </a:p>
+        </p:txBody>
+      </p:sp>
+      <p:sp>
+        <p:nvSpPr>
+          <p:cNvPr id="15" name="Rounded Rectangle 14"/>
           <p:cNvSpPr/>
           <p:nvPr/>
         </p:nvSpPr>
@@ -11675,7 +12519,7 @@
       </p:sp>
       <p:sp>
         <p:nvSpPr>
-          <p:cNvPr id="17" name="Oval 16"/>
+          <p:cNvPr id="16" name="Oval 15"/>
           <p:cNvSpPr/>
           <p:nvPr/>
         </p:nvSpPr>
@@ -11728,7 +12572,7 @@
       </p:sp>
       <p:sp>
         <p:nvSpPr>
-          <p:cNvPr id="18" name="TextBox 17"/>
+          <p:cNvPr id="17" name="TextBox 16"/>
           <p:cNvSpPr txBox="1"/>
           <p:nvPr/>
         </p:nvSpPr>
@@ -11760,14 +12604,14 @@
                 </a:solidFill>
                 <a:latin typeface="Cambria"/>
               </a:rPr>
-              <a:t>Level in the title</a:t>
-            </a:r>
-          </a:p>
-        </p:txBody>
-      </p:sp>
-      <p:sp>
-        <p:nvSpPr>
-          <p:cNvPr id="19" name="TextBox 18"/>
+              <a:t>The evaluation page counts</a:t>
+            </a:r>
+          </a:p>
+        </p:txBody>
+      </p:sp>
+      <p:sp>
+        <p:nvSpPr>
+          <p:cNvPr id="18" name="TextBox 17"/>
           <p:cNvSpPr txBox="1"/>
           <p:nvPr/>
         </p:nvSpPr>
@@ -11799,7 +12643,7 @@
                 </a:solidFill>
                 <a:latin typeface="Calibri"/>
               </a:rPr>
-              <a:t>Modelling and Programming 3 outranks 1: the sequence number is kept out of the embedding by design (ADR-0004).</a:t>
+              <a:t>It shows how many of the 1142 gold pairs a human has checked (0 today) and stays provisional until every one is.</a:t>
             </a:r>
           </a:p>
         </p:txBody>

</xml_diff>

<commit_message>
[A] calibrate on cosine as well as the fused score
</commit_message>
<xml_diff>
--- a/docs/slides/erasmusgpt-defence.pptx
+++ b/docs/slides/erasmusgpt-defence.pptx
@@ -704,7 +704,7 @@
           <a:p>
             <a:r>
               <a:rPr sz="1300"/>
-              <a:t>Calibration of hybrid, 562 pairs</a:t>
+              <a:t>Calibration of hybrid, 1142 pairs</a:t>
             </a:r>
           </a:p>
         </c:rich>
@@ -738,9 +738,9 @@
           </c:spPr>
           <c:cat>
             <c:strRef>
-              <c:f>Sheet1!$A$2:$A$5</c:f>
+              <c:f>Sheet1!$A$2:$A$6</c:f>
               <c:strCache>
-                <c:ptCount val="4"/>
+                <c:ptCount val="5"/>
                 <c:pt idx="0">
                   <c:v>0.0-0.2</c:v>
                 </c:pt>
@@ -753,26 +753,32 @@
                 <c:pt idx="3">
                   <c:v>0.6-0.8</c:v>
                 </c:pt>
+                <c:pt idx="4">
+                  <c:v>0.8-1.0</c:v>
+                </c:pt>
               </c:strCache>
             </c:strRef>
           </c:cat>
           <c:val>
             <c:numRef>
-              <c:f>Sheet1!$B$2:$B$5</c:f>
+              <c:f>Sheet1!$B$2:$B$6</c:f>
               <c:numCache>
                 <c:formatCode>General</c:formatCode>
-                <c:ptCount val="4"/>
+                <c:ptCount val="5"/>
                 <c:pt idx="0">
-                  <c:v>0.047</c:v>
+                  <c:v>0.033</c:v>
                 </c:pt>
                 <c:pt idx="1">
-                  <c:v>0.301</c:v>
+                  <c:v>0.284</c:v>
                 </c:pt>
                 <c:pt idx="2">
-                  <c:v>0.509</c:v>
+                  <c:v>0.483</c:v>
                 </c:pt>
                 <c:pt idx="3">
-                  <c:v>0.674</c:v>
+                  <c:v>0.684</c:v>
+                </c:pt>
+                <c:pt idx="4">
+                  <c:v>0.908</c:v>
                 </c:pt>
               </c:numCache>
             </c:numRef>
@@ -799,9 +805,9 @@
           </c:spPr>
           <c:cat>
             <c:strRef>
-              <c:f>Sheet1!$A$2:$A$5</c:f>
+              <c:f>Sheet1!$A$2:$A$6</c:f>
               <c:strCache>
-                <c:ptCount val="4"/>
+                <c:ptCount val="5"/>
                 <c:pt idx="0">
                   <c:v>0.0-0.2</c:v>
                 </c:pt>
@@ -814,26 +820,32 @@
                 <c:pt idx="3">
                   <c:v>0.6-0.8</c:v>
                 </c:pt>
+                <c:pt idx="4">
+                  <c:v>0.8-1.0</c:v>
+                </c:pt>
               </c:strCache>
             </c:strRef>
           </c:cat>
           <c:val>
             <c:numRef>
-              <c:f>Sheet1!$C$2:$C$5</c:f>
+              <c:f>Sheet1!$C$2:$C$6</c:f>
               <c:numCache>
                 <c:formatCode>General</c:formatCode>
-                <c:ptCount val="4"/>
+                <c:ptCount val="5"/>
                 <c:pt idx="0">
-                  <c:v>0.048</c:v>
+                  <c:v>0.033</c:v>
                 </c:pt>
                 <c:pt idx="1">
-                  <c:v>0.277</c:v>
+                  <c:v>0.267</c:v>
                 </c:pt>
                 <c:pt idx="2">
-                  <c:v>0.48</c:v>
+                  <c:v>0.483</c:v>
                 </c:pt>
                 <c:pt idx="3">
-                  <c:v>0.778</c:v>
+                  <c:v>0.613</c:v>
+                </c:pt>
+                <c:pt idx="4">
+                  <c:v>1.0</c:v>
                 </c:pt>
               </c:numCache>
             </c:numRef>
@@ -11854,7 +11866,7 @@
                 </a:solidFill>
                 <a:latin typeface="Calibri"/>
               </a:rPr>
-              <a:t>Platt scaling turns a fused rank score into the probability that a human labelled the pair a match. Bars that agree mean 70 % really is 70 %.</a:t>
+              <a:t>Platt scaling on the fused rank score and the embedding cosine gives the probability that a human labelled the pair a match. Rank alone cannot tell a good top hit from the best of a bad lot; the cosine can.</a:t>
             </a:r>
           </a:p>
           <a:p>

</xml_diff>

<commit_message>
[A] complete the gold set and report the final results
</commit_message>
<xml_diff>
--- a/docs/slides/erasmusgpt-defence.pptx
+++ b/docs/slides/erasmusgpt-defence.pptx
@@ -148,19 +148,22 @@
           </c:spPr>
           <c:cat>
             <c:strRef>
-              <c:f>Sheet1!$A$2:$A$5</c:f>
+              <c:f>Sheet1!$A$2:$A$6</c:f>
               <c:strCache>
-                <c:ptCount val="4"/>
+                <c:ptCount val="5"/>
                 <c:pt idx="0">
                   <c:v>bm25</c:v>
                 </c:pt>
                 <c:pt idx="1">
+                  <c:v>dense-minilm</c:v>
+                </c:pt>
+                <c:pt idx="2">
                   <c:v>dense-bge</c:v>
                 </c:pt>
-                <c:pt idx="2">
+                <c:pt idx="3">
                   <c:v>hybrid</c:v>
                 </c:pt>
-                <c:pt idx="3">
+                <c:pt idx="4">
                   <c:v>hybrid+ce</c:v>
                 </c:pt>
               </c:strCache>
@@ -168,21 +171,24 @@
           </c:cat>
           <c:val>
             <c:numRef>
-              <c:f>Sheet1!$B$2:$B$5</c:f>
+              <c:f>Sheet1!$B$2:$B$6</c:f>
               <c:numCache>
                 <c:formatCode>General</c:formatCode>
-                <c:ptCount val="4"/>
+                <c:ptCount val="5"/>
                 <c:pt idx="0">
-                  <c:v>0.86</c:v>
+                  <c:v>0.85</c:v>
                 </c:pt>
                 <c:pt idx="1">
-                  <c:v>0.75</c:v>
+                  <c:v>0.78</c:v>
                 </c:pt>
                 <c:pt idx="2">
-                  <c:v>0.86</c:v>
+                  <c:v>0.7</c:v>
                 </c:pt>
                 <c:pt idx="3">
-                  <c:v>0.82</c:v>
+                  <c:v>0.78</c:v>
+                </c:pt>
+                <c:pt idx="4">
+                  <c:v>0.78</c:v>
                 </c:pt>
               </c:numCache>
             </c:numRef>
@@ -209,19 +215,22 @@
           </c:spPr>
           <c:cat>
             <c:strRef>
-              <c:f>Sheet1!$A$2:$A$5</c:f>
+              <c:f>Sheet1!$A$2:$A$6</c:f>
               <c:strCache>
-                <c:ptCount val="4"/>
+                <c:ptCount val="5"/>
                 <c:pt idx="0">
                   <c:v>bm25</c:v>
                 </c:pt>
                 <c:pt idx="1">
+                  <c:v>dense-minilm</c:v>
+                </c:pt>
+                <c:pt idx="2">
                   <c:v>dense-bge</c:v>
                 </c:pt>
-                <c:pt idx="2">
+                <c:pt idx="3">
                   <c:v>hybrid</c:v>
                 </c:pt>
-                <c:pt idx="3">
+                <c:pt idx="4">
                   <c:v>hybrid+ce</c:v>
                 </c:pt>
               </c:strCache>
@@ -229,20 +238,23 @@
           </c:cat>
           <c:val>
             <c:numRef>
-              <c:f>Sheet1!$C$2:$C$5</c:f>
+              <c:f>Sheet1!$C$2:$C$6</c:f>
               <c:numCache>
                 <c:formatCode>General</c:formatCode>
-                <c:ptCount val="4"/>
+                <c:ptCount val="5"/>
                 <c:pt idx="0">
-                  <c:v>0.75</c:v>
+                  <c:v>0.74</c:v>
                 </c:pt>
                 <c:pt idx="1">
-                  <c:v>0.77</c:v>
+                  <c:v>0.83</c:v>
                 </c:pt>
                 <c:pt idx="2">
-                  <c:v>0.8</c:v>
+                  <c:v>0.78</c:v>
                 </c:pt>
                 <c:pt idx="3">
+                  <c:v>0.83</c:v>
+                </c:pt>
+                <c:pt idx="4">
                   <c:v>0.82</c:v>
                 </c:pt>
               </c:numCache>
@@ -270,19 +282,22 @@
           </c:spPr>
           <c:cat>
             <c:strRef>
-              <c:f>Sheet1!$A$2:$A$5</c:f>
+              <c:f>Sheet1!$A$2:$A$6</c:f>
               <c:strCache>
-                <c:ptCount val="4"/>
+                <c:ptCount val="5"/>
                 <c:pt idx="0">
                   <c:v>bm25</c:v>
                 </c:pt>
                 <c:pt idx="1">
+                  <c:v>dense-minilm</c:v>
+                </c:pt>
+                <c:pt idx="2">
                   <c:v>dense-bge</c:v>
                 </c:pt>
-                <c:pt idx="2">
+                <c:pt idx="3">
                   <c:v>hybrid</c:v>
                 </c:pt>
-                <c:pt idx="3">
+                <c:pt idx="4">
                   <c:v>hybrid+ce</c:v>
                 </c:pt>
               </c:strCache>
@@ -290,21 +305,24 @@
           </c:cat>
           <c:val>
             <c:numRef>
-              <c:f>Sheet1!$D$2:$D$5</c:f>
+              <c:f>Sheet1!$D$2:$D$6</c:f>
               <c:numCache>
                 <c:formatCode>General</c:formatCode>
-                <c:ptCount val="4"/>
+                <c:ptCount val="5"/>
                 <c:pt idx="0">
-                  <c:v>0.91</c:v>
+                  <c:v>0.89</c:v>
                 </c:pt>
                 <c:pt idx="1">
-                  <c:v>0.81</c:v>
+                  <c:v>0.85</c:v>
                 </c:pt>
                 <c:pt idx="2">
-                  <c:v>0.9</c:v>
+                  <c:v>0.78</c:v>
                 </c:pt>
                 <c:pt idx="3">
-                  <c:v>0.88</c:v>
+                  <c:v>0.85</c:v>
+                </c:pt>
+                <c:pt idx="4">
+                  <c:v>0.85</c:v>
                 </c:pt>
               </c:numCache>
             </c:numRef>
@@ -766,19 +784,19 @@
                 <c:formatCode>General</c:formatCode>
                 <c:ptCount val="5"/>
                 <c:pt idx="0">
-                  <c:v>0.033</c:v>
+                  <c:v>0.029</c:v>
                 </c:pt>
                 <c:pt idx="1">
-                  <c:v>0.284</c:v>
+                  <c:v>0.291</c:v>
                 </c:pt>
                 <c:pt idx="2">
-                  <c:v>0.483</c:v>
+                  <c:v>0.498</c:v>
                 </c:pt>
                 <c:pt idx="3">
-                  <c:v>0.684</c:v>
+                  <c:v>0.679</c:v>
                 </c:pt>
                 <c:pt idx="4">
-                  <c:v>0.908</c:v>
+                  <c:v>0.903</c:v>
                 </c:pt>
               </c:numCache>
             </c:numRef>
@@ -836,13 +854,13 @@
                   <c:v>0.033</c:v>
                 </c:pt>
                 <c:pt idx="1">
-                  <c:v>0.267</c:v>
+                  <c:v>0.277</c:v>
                 </c:pt>
                 <c:pt idx="2">
-                  <c:v>0.483</c:v>
+                  <c:v>0.342</c:v>
                 </c:pt>
                 <c:pt idx="3">
-                  <c:v>0.613</c:v>
+                  <c:v>0.667</c:v>
                 </c:pt>
                 <c:pt idx="4">
                   <c:v>1.0</c:v>
@@ -5887,61 +5905,6 @@
         </p:nvSpPr>
         <p:spPr>
           <a:xfrm>
-            <a:off x="9464040" y="457200"/>
-            <a:ext cx="2194560" cy="384048"/>
-          </a:xfrm>
-          <a:prstGeom prst="roundRect">
-            <a:avLst>
-              <a:gd name="adj" fmla="val 12000"/>
-            </a:avLst>
-          </a:prstGeom>
-          <a:solidFill>
-            <a:srgbClr val="F2B705"/>
-          </a:solidFill>
-          <a:ln>
-            <a:noFill/>
-          </a:ln>
-          <a:effectLst/>
-        </p:spPr>
-        <p:style>
-          <a:lnRef idx="1">
-            <a:schemeClr val="accent1"/>
-          </a:lnRef>
-          <a:fillRef idx="3">
-            <a:schemeClr val="accent1"/>
-          </a:fillRef>
-          <a:effectRef idx="2">
-            <a:schemeClr val="accent1"/>
-          </a:effectRef>
-          <a:fontRef idx="minor">
-            <a:schemeClr val="lt1"/>
-          </a:fontRef>
-        </p:style>
-        <p:txBody>
-          <a:bodyPr rtlCol="0" anchor="ctr" tIns="0" bIns="0"/>
-          <a:lstStyle/>
-          <a:p>
-            <a:pPr algn="ctr"/>
-            <a:r>
-              <a:rPr sz="1200" b="1">
-                <a:solidFill>
-                  <a:srgbClr val="14234B"/>
-                </a:solidFill>
-                <a:latin typeface="Calibri"/>
-              </a:rPr>
-              <a:t>PROVISIONAL LABELS</a:t>
-            </a:r>
-          </a:p>
-        </p:txBody>
-      </p:sp>
-      <p:sp>
-        <p:nvSpPr>
-          <p:cNvPr id="4" name="Rounded Rectangle 3"/>
-          <p:cNvSpPr/>
-          <p:nvPr/>
-        </p:nvSpPr>
-        <p:spPr>
-          <a:xfrm>
             <a:off x="548640" y="1463040"/>
             <a:ext cx="5394960" cy="2103120"/>
           </a:xfrm>
@@ -5982,7 +5945,7 @@
       </p:sp>
       <p:sp>
         <p:nvSpPr>
-          <p:cNvPr id="5" name="Oval 4"/>
+          <p:cNvPr id="4" name="Oval 3"/>
           <p:cNvSpPr/>
           <p:nvPr/>
         </p:nvSpPr>
@@ -6035,7 +5998,7 @@
       </p:sp>
       <p:sp>
         <p:nvSpPr>
-          <p:cNvPr id="6" name="TextBox 5"/>
+          <p:cNvPr id="5" name="TextBox 4"/>
           <p:cNvSpPr txBox="1"/>
           <p:nvPr/>
         </p:nvSpPr>
@@ -6074,7 +6037,7 @@
       </p:sp>
       <p:sp>
         <p:nvSpPr>
-          <p:cNvPr id="7" name="TextBox 6"/>
+          <p:cNvPr id="6" name="TextBox 5"/>
           <p:cNvSpPr txBox="1"/>
           <p:nvPr/>
         </p:nvSpPr>
@@ -6113,7 +6076,7 @@
       </p:sp>
       <p:sp>
         <p:nvSpPr>
-          <p:cNvPr id="8" name="Rounded Rectangle 7"/>
+          <p:cNvPr id="7" name="Rounded Rectangle 6"/>
           <p:cNvSpPr/>
           <p:nvPr/>
         </p:nvSpPr>
@@ -6159,7 +6122,7 @@
       </p:sp>
       <p:sp>
         <p:nvSpPr>
-          <p:cNvPr id="9" name="Oval 8"/>
+          <p:cNvPr id="8" name="Oval 7"/>
           <p:cNvSpPr/>
           <p:nvPr/>
         </p:nvSpPr>
@@ -6212,7 +6175,7 @@
       </p:sp>
       <p:sp>
         <p:nvSpPr>
-          <p:cNvPr id="10" name="TextBox 9"/>
+          <p:cNvPr id="9" name="TextBox 8"/>
           <p:cNvSpPr txBox="1"/>
           <p:nvPr/>
         </p:nvSpPr>
@@ -6251,7 +6214,7 @@
       </p:sp>
       <p:sp>
         <p:nvSpPr>
-          <p:cNvPr id="11" name="TextBox 10"/>
+          <p:cNvPr id="10" name="TextBox 9"/>
           <p:cNvSpPr txBox="1"/>
           <p:nvPr/>
         </p:nvSpPr>
@@ -6290,7 +6253,7 @@
       </p:sp>
       <p:sp>
         <p:nvSpPr>
-          <p:cNvPr id="12" name="Rounded Rectangle 11"/>
+          <p:cNvPr id="11" name="Rounded Rectangle 10"/>
           <p:cNvSpPr/>
           <p:nvPr/>
         </p:nvSpPr>
@@ -6336,7 +6299,7 @@
       </p:sp>
       <p:sp>
         <p:nvSpPr>
-          <p:cNvPr id="13" name="Oval 12"/>
+          <p:cNvPr id="12" name="Oval 11"/>
           <p:cNvSpPr/>
           <p:nvPr/>
         </p:nvSpPr>
@@ -6389,7 +6352,7 @@
       </p:sp>
       <p:sp>
         <p:nvSpPr>
-          <p:cNvPr id="14" name="TextBox 13"/>
+          <p:cNvPr id="13" name="TextBox 12"/>
           <p:cNvSpPr txBox="1"/>
           <p:nvPr/>
         </p:nvSpPr>
@@ -6428,7 +6391,7 @@
       </p:sp>
       <p:sp>
         <p:nvSpPr>
-          <p:cNvPr id="15" name="TextBox 14"/>
+          <p:cNvPr id="14" name="TextBox 13"/>
           <p:cNvSpPr txBox="1"/>
           <p:nvPr/>
         </p:nvSpPr>
@@ -6467,7 +6430,7 @@
       </p:sp>
       <p:sp>
         <p:nvSpPr>
-          <p:cNvPr id="16" name="Rounded Rectangle 15"/>
+          <p:cNvPr id="15" name="Rounded Rectangle 14"/>
           <p:cNvSpPr/>
           <p:nvPr/>
         </p:nvSpPr>
@@ -6513,7 +6476,7 @@
       </p:sp>
       <p:sp>
         <p:nvSpPr>
-          <p:cNvPr id="17" name="Oval 16"/>
+          <p:cNvPr id="16" name="Oval 15"/>
           <p:cNvSpPr/>
           <p:nvPr/>
         </p:nvSpPr>
@@ -6566,7 +6529,7 @@
       </p:sp>
       <p:sp>
         <p:nvSpPr>
-          <p:cNvPr id="18" name="TextBox 17"/>
+          <p:cNvPr id="17" name="TextBox 16"/>
           <p:cNvSpPr txBox="1"/>
           <p:nvPr/>
         </p:nvSpPr>
@@ -6605,7 +6568,7 @@
       </p:sp>
       <p:sp>
         <p:nvSpPr>
-          <p:cNvPr id="19" name="TextBox 18"/>
+          <p:cNvPr id="18" name="TextBox 17"/>
           <p:cNvSpPr txBox="1"/>
           <p:nvPr/>
         </p:nvSpPr>
@@ -7539,7 +7502,7 @@
                 </a:solidFill>
                 <a:latin typeface="Calibri"/>
               </a:rPr>
-              <a:t>Two people checked half the rows each; kappa on 30 blind pairs checks they agree.</a:t>
+              <a:t>462 of 1142 gold labels come from a second model, not a human check.</a:t>
             </a:r>
           </a:p>
         </p:txBody>
@@ -9971,62 +9934,7 @@
       </p:sp>
       <p:sp>
         <p:nvSpPr>
-          <p:cNvPr id="3" name="Rounded Rectangle 2"/>
-          <p:cNvSpPr/>
-          <p:nvPr/>
-        </p:nvSpPr>
-        <p:spPr>
-          <a:xfrm>
-            <a:off x="9464040" y="457200"/>
-            <a:ext cx="2194560" cy="384048"/>
-          </a:xfrm>
-          <a:prstGeom prst="roundRect">
-            <a:avLst>
-              <a:gd name="adj" fmla="val 12000"/>
-            </a:avLst>
-          </a:prstGeom>
-          <a:solidFill>
-            <a:srgbClr val="F2B705"/>
-          </a:solidFill>
-          <a:ln>
-            <a:noFill/>
-          </a:ln>
-          <a:effectLst/>
-        </p:spPr>
-        <p:style>
-          <a:lnRef idx="1">
-            <a:schemeClr val="accent1"/>
-          </a:lnRef>
-          <a:fillRef idx="3">
-            <a:schemeClr val="accent1"/>
-          </a:fillRef>
-          <a:effectRef idx="2">
-            <a:schemeClr val="accent1"/>
-          </a:effectRef>
-          <a:fontRef idx="minor">
-            <a:schemeClr val="lt1"/>
-          </a:fontRef>
-        </p:style>
-        <p:txBody>
-          <a:bodyPr rtlCol="0" anchor="ctr" tIns="0" bIns="0"/>
-          <a:lstStyle/>
-          <a:p>
-            <a:pPr algn="ctr"/>
-            <a:r>
-              <a:rPr sz="1200" b="1">
-                <a:solidFill>
-                  <a:srgbClr val="14234B"/>
-                </a:solidFill>
-                <a:latin typeface="Calibri"/>
-              </a:rPr>
-              <a:t>PROVISIONAL LABELS</a:t>
-            </a:r>
-          </a:p>
-        </p:txBody>
-      </p:sp>
-      <p:sp>
-        <p:nvSpPr>
-          <p:cNvPr id="4" name="Oval 3"/>
+          <p:cNvPr id="3" name="Oval 2"/>
           <p:cNvSpPr/>
           <p:nvPr/>
         </p:nvSpPr>
@@ -10079,7 +9987,7 @@
       </p:sp>
       <p:sp>
         <p:nvSpPr>
-          <p:cNvPr id="5" name="TextBox 4"/>
+          <p:cNvPr id="4" name="TextBox 3"/>
           <p:cNvSpPr txBox="1"/>
           <p:nvPr/>
         </p:nvSpPr>
@@ -10118,7 +10026,7 @@
       </p:sp>
       <p:sp>
         <p:nvSpPr>
-          <p:cNvPr id="6" name="TextBox 5"/>
+          <p:cNvPr id="5" name="TextBox 4"/>
           <p:cNvSpPr txBox="1"/>
           <p:nvPr/>
         </p:nvSpPr>
@@ -10157,7 +10065,7 @@
       </p:sp>
       <p:sp>
         <p:nvSpPr>
-          <p:cNvPr id="7" name="Oval 6"/>
+          <p:cNvPr id="6" name="Oval 5"/>
           <p:cNvSpPr/>
           <p:nvPr/>
         </p:nvSpPr>
@@ -10210,7 +10118,7 @@
       </p:sp>
       <p:sp>
         <p:nvSpPr>
-          <p:cNvPr id="8" name="TextBox 7"/>
+          <p:cNvPr id="7" name="TextBox 6"/>
           <p:cNvSpPr txBox="1"/>
           <p:nvPr/>
         </p:nvSpPr>
@@ -10249,7 +10157,7 @@
       </p:sp>
       <p:sp>
         <p:nvSpPr>
-          <p:cNvPr id="9" name="TextBox 8"/>
+          <p:cNvPr id="8" name="TextBox 7"/>
           <p:cNvSpPr txBox="1"/>
           <p:nvPr/>
         </p:nvSpPr>
@@ -10288,7 +10196,7 @@
       </p:sp>
       <p:sp>
         <p:nvSpPr>
-          <p:cNvPr id="10" name="Oval 9"/>
+          <p:cNvPr id="9" name="Oval 8"/>
           <p:cNvSpPr/>
           <p:nvPr/>
         </p:nvSpPr>
@@ -10341,7 +10249,7 @@
       </p:sp>
       <p:sp>
         <p:nvSpPr>
-          <p:cNvPr id="11" name="TextBox 10"/>
+          <p:cNvPr id="10" name="TextBox 9"/>
           <p:cNvSpPr txBox="1"/>
           <p:nvPr/>
         </p:nvSpPr>
@@ -10380,7 +10288,7 @@
       </p:sp>
       <p:sp>
         <p:nvSpPr>
-          <p:cNvPr id="12" name="TextBox 11"/>
+          <p:cNvPr id="11" name="TextBox 10"/>
           <p:cNvSpPr txBox="1"/>
           <p:nvPr/>
         </p:nvSpPr>
@@ -10412,14 +10320,14 @@
                 </a:solidFill>
                 <a:latin typeface="Calibri"/>
               </a:rPr>
-              <a:t>A human reads every row and corrects it. Only checked rows count.</a:t>
-            </a:r>
-          </a:p>
-        </p:txBody>
-      </p:sp>
-      <p:sp>
-        <p:nvSpPr>
-          <p:cNvPr id="13" name="Oval 12"/>
+              <a:t>680 rows checked by a person; 462 labelled by a second model (Claude) for lack of time, and reported as such.</a:t>
+            </a:r>
+          </a:p>
+        </p:txBody>
+      </p:sp>
+      <p:sp>
+        <p:nvSpPr>
+          <p:cNvPr id="12" name="Oval 11"/>
           <p:cNvSpPr/>
           <p:nvPr/>
         </p:nvSpPr>
@@ -10472,7 +10380,7 @@
       </p:sp>
       <p:sp>
         <p:nvSpPr>
-          <p:cNvPr id="14" name="TextBox 13"/>
+          <p:cNvPr id="13" name="TextBox 12"/>
           <p:cNvSpPr txBox="1"/>
           <p:nvPr/>
         </p:nvSpPr>
@@ -10511,7 +10419,7 @@
       </p:sp>
       <p:sp>
         <p:nvSpPr>
-          <p:cNvPr id="15" name="TextBox 14"/>
+          <p:cNvPr id="14" name="TextBox 13"/>
           <p:cNvSpPr txBox="1"/>
           <p:nvPr/>
         </p:nvSpPr>
@@ -10550,7 +10458,7 @@
       </p:sp>
       <p:sp>
         <p:nvSpPr>
-          <p:cNvPr id="16" name="Rounded Rectangle 15"/>
+          <p:cNvPr id="15" name="Rounded Rectangle 14"/>
           <p:cNvSpPr/>
           <p:nvPr/>
         </p:nvSpPr>
@@ -10596,7 +10504,7 @@
       </p:sp>
       <p:sp>
         <p:nvSpPr>
-          <p:cNvPr id="17" name="TextBox 16"/>
+          <p:cNvPr id="16" name="TextBox 15"/>
           <p:cNvSpPr txBox="1"/>
           <p:nvPr/>
         </p:nvSpPr>
@@ -10635,7 +10543,7 @@
       </p:sp>
       <p:sp>
         <p:nvSpPr>
-          <p:cNvPr id="18" name="TextBox 17"/>
+          <p:cNvPr id="17" name="TextBox 16"/>
           <p:cNvSpPr txBox="1"/>
           <p:nvPr/>
         </p:nvSpPr>
@@ -10667,14 +10575,14 @@
                 </a:solidFill>
                 <a:latin typeface="Cambria"/>
               </a:rPr>
-              <a:t>pending</a:t>
-            </a:r>
-          </a:p>
-        </p:txBody>
-      </p:sp>
-      <p:sp>
-        <p:nvSpPr>
-          <p:cNvPr id="19" name="Rounded Rectangle 18"/>
+              <a:t>1.6% of 680 human rows</a:t>
+            </a:r>
+          </a:p>
+        </p:txBody>
+      </p:sp>
+      <p:sp>
+        <p:nvSpPr>
+          <p:cNvPr id="18" name="Rounded Rectangle 17"/>
           <p:cNvSpPr/>
           <p:nvPr/>
         </p:nvSpPr>
@@ -10720,7 +10628,7 @@
       </p:sp>
       <p:sp>
         <p:nvSpPr>
-          <p:cNvPr id="20" name="TextBox 19"/>
+          <p:cNvPr id="19" name="TextBox 18"/>
           <p:cNvSpPr txBox="1"/>
           <p:nvPr/>
         </p:nvSpPr>
@@ -10759,7 +10667,7 @@
       </p:sp>
       <p:sp>
         <p:nvSpPr>
-          <p:cNvPr id="21" name="TextBox 20"/>
+          <p:cNvPr id="20" name="TextBox 19"/>
           <p:cNvSpPr txBox="1"/>
           <p:nvPr/>
         </p:nvSpPr>
@@ -10798,7 +10706,7 @@
       </p:sp>
       <p:sp>
         <p:nvSpPr>
-          <p:cNvPr id="22" name="Rounded Rectangle 21"/>
+          <p:cNvPr id="21" name="Rounded Rectangle 20"/>
           <p:cNvSpPr/>
           <p:nvPr/>
         </p:nvSpPr>
@@ -10844,7 +10752,7 @@
       </p:sp>
       <p:sp>
         <p:nvSpPr>
-          <p:cNvPr id="23" name="TextBox 22"/>
+          <p:cNvPr id="22" name="TextBox 21"/>
           <p:cNvSpPr txBox="1"/>
           <p:nvPr/>
         </p:nvSpPr>
@@ -10883,7 +10791,7 @@
       </p:sp>
       <p:sp>
         <p:nvSpPr>
-          <p:cNvPr id="24" name="TextBox 23"/>
+          <p:cNvPr id="23" name="TextBox 22"/>
           <p:cNvSpPr txBox="1"/>
           <p:nvPr/>
         </p:nvSpPr>
@@ -10985,64 +10893,9 @@
           </a:p>
         </p:txBody>
       </p:sp>
-      <p:sp>
-        <p:nvSpPr>
-          <p:cNvPr id="3" name="Rounded Rectangle 2"/>
-          <p:cNvSpPr/>
-          <p:nvPr/>
-        </p:nvSpPr>
-        <p:spPr>
-          <a:xfrm>
-            <a:off x="9464040" y="457200"/>
-            <a:ext cx="2194560" cy="384048"/>
-          </a:xfrm>
-          <a:prstGeom prst="roundRect">
-            <a:avLst>
-              <a:gd name="adj" fmla="val 12000"/>
-            </a:avLst>
-          </a:prstGeom>
-          <a:solidFill>
-            <a:srgbClr val="F2B705"/>
-          </a:solidFill>
-          <a:ln>
-            <a:noFill/>
-          </a:ln>
-          <a:effectLst/>
-        </p:spPr>
-        <p:style>
-          <a:lnRef idx="1">
-            <a:schemeClr val="accent1"/>
-          </a:lnRef>
-          <a:fillRef idx="3">
-            <a:schemeClr val="accent1"/>
-          </a:fillRef>
-          <a:effectRef idx="2">
-            <a:schemeClr val="accent1"/>
-          </a:effectRef>
-          <a:fontRef idx="minor">
-            <a:schemeClr val="lt1"/>
-          </a:fontRef>
-        </p:style>
-        <p:txBody>
-          <a:bodyPr rtlCol="0" anchor="ctr" tIns="0" bIns="0"/>
-          <a:lstStyle/>
-          <a:p>
-            <a:pPr algn="ctr"/>
-            <a:r>
-              <a:rPr sz="1200" b="1">
-                <a:solidFill>
-                  <a:srgbClr val="14234B"/>
-                </a:solidFill>
-                <a:latin typeface="Calibri"/>
-              </a:rPr>
-              <a:t>PROVISIONAL LABELS</a:t>
-            </a:r>
-          </a:p>
-        </p:txBody>
-      </p:sp>
       <p:graphicFrame>
         <p:nvGraphicFramePr>
-          <p:cNvPr id="4" name="Chart 3"/>
+          <p:cNvPr id="3" name="Chart 2"/>
           <p:cNvGraphicFramePr>
             <a:graphicFrameLocks noGrp="1"/>
           </p:cNvGraphicFramePr>
@@ -11060,7 +10913,7 @@
       </p:graphicFrame>
       <p:sp>
         <p:nvSpPr>
-          <p:cNvPr id="5" name="TextBox 4"/>
+          <p:cNvPr id="4" name="TextBox 3"/>
           <p:cNvSpPr txBox="1"/>
           <p:nvPr/>
         </p:nvSpPr>
@@ -11099,7 +10952,7 @@
       </p:sp>
       <p:sp>
         <p:nvSpPr>
-          <p:cNvPr id="6" name="Rounded Rectangle 5"/>
+          <p:cNvPr id="5" name="Rounded Rectangle 4"/>
           <p:cNvSpPr/>
           <p:nvPr/>
         </p:nvSpPr>
@@ -11145,7 +10998,7 @@
       </p:sp>
       <p:sp>
         <p:nvSpPr>
-          <p:cNvPr id="7" name="TextBox 6"/>
+          <p:cNvPr id="6" name="TextBox 5"/>
           <p:cNvSpPr txBox="1"/>
           <p:nvPr/>
         </p:nvSpPr>
@@ -11177,14 +11030,14 @@
                 </a:solidFill>
                 <a:latin typeface="Cambria"/>
               </a:rPr>
-              <a:t>2 ms</a:t>
-            </a:r>
-          </a:p>
-        </p:txBody>
-      </p:sp>
-      <p:sp>
-        <p:nvSpPr>
-          <p:cNvPr id="8" name="TextBox 7"/>
+              <a:t>3 ms</a:t>
+            </a:r>
+          </a:p>
+        </p:txBody>
+      </p:sp>
+      <p:sp>
+        <p:nvSpPr>
+          <p:cNvPr id="7" name="TextBox 6"/>
           <p:cNvSpPr txBox="1"/>
           <p:nvPr/>
         </p:nvSpPr>
@@ -11223,7 +11076,7 @@
       </p:sp>
       <p:sp>
         <p:nvSpPr>
-          <p:cNvPr id="9" name="Rounded Rectangle 8"/>
+          <p:cNvPr id="8" name="Rounded Rectangle 7"/>
           <p:cNvSpPr/>
           <p:nvPr/>
         </p:nvSpPr>
@@ -11269,7 +11122,7 @@
       </p:sp>
       <p:sp>
         <p:nvSpPr>
-          <p:cNvPr id="10" name="TextBox 9"/>
+          <p:cNvPr id="9" name="TextBox 8"/>
           <p:cNvSpPr txBox="1"/>
           <p:nvPr/>
         </p:nvSpPr>
@@ -11301,14 +11154,14 @@
                 </a:solidFill>
                 <a:latin typeface="Cambria"/>
               </a:rPr>
-              <a:t>910 ms</a:t>
-            </a:r>
-          </a:p>
-        </p:txBody>
-      </p:sp>
-      <p:sp>
-        <p:nvSpPr>
-          <p:cNvPr id="11" name="TextBox 10"/>
+              <a:t>868 ms</a:t>
+            </a:r>
+          </a:p>
+        </p:txBody>
+      </p:sp>
+      <p:sp>
+        <p:nvSpPr>
+          <p:cNvPr id="10" name="TextBox 9"/>
           <p:cNvSpPr txBox="1"/>
           <p:nvPr/>
         </p:nvSpPr>
@@ -11347,7 +11200,7 @@
       </p:sp>
       <p:sp>
         <p:nvSpPr>
-          <p:cNvPr id="12" name="TextBox 11"/>
+          <p:cNvPr id="11" name="TextBox 10"/>
           <p:cNvSpPr txBox="1"/>
           <p:nvPr/>
         </p:nvSpPr>
@@ -11449,64 +11302,9 @@
           </a:p>
         </p:txBody>
       </p:sp>
-      <p:sp>
-        <p:nvSpPr>
-          <p:cNvPr id="3" name="Rounded Rectangle 2"/>
-          <p:cNvSpPr/>
-          <p:nvPr/>
-        </p:nvSpPr>
-        <p:spPr>
-          <a:xfrm>
-            <a:off x="9464040" y="457200"/>
-            <a:ext cx="2194560" cy="384048"/>
-          </a:xfrm>
-          <a:prstGeom prst="roundRect">
-            <a:avLst>
-              <a:gd name="adj" fmla="val 12000"/>
-            </a:avLst>
-          </a:prstGeom>
-          <a:solidFill>
-            <a:srgbClr val="F2B705"/>
-          </a:solidFill>
-          <a:ln>
-            <a:noFill/>
-          </a:ln>
-          <a:effectLst/>
-        </p:spPr>
-        <p:style>
-          <a:lnRef idx="1">
-            <a:schemeClr val="accent1"/>
-          </a:lnRef>
-          <a:fillRef idx="3">
-            <a:schemeClr val="accent1"/>
-          </a:fillRef>
-          <a:effectRef idx="2">
-            <a:schemeClr val="accent1"/>
-          </a:effectRef>
-          <a:fontRef idx="minor">
-            <a:schemeClr val="lt1"/>
-          </a:fontRef>
-        </p:style>
-        <p:txBody>
-          <a:bodyPr rtlCol="0" anchor="ctr" tIns="0" bIns="0"/>
-          <a:lstStyle/>
-          <a:p>
-            <a:pPr algn="ctr"/>
-            <a:r>
-              <a:rPr sz="1200" b="1">
-                <a:solidFill>
-                  <a:srgbClr val="14234B"/>
-                </a:solidFill>
-                <a:latin typeface="Calibri"/>
-              </a:rPr>
-              <a:t>PROVISIONAL LABELS</a:t>
-            </a:r>
-          </a:p>
-        </p:txBody>
-      </p:sp>
       <p:graphicFrame>
         <p:nvGraphicFramePr>
-          <p:cNvPr id="4" name="Chart 3"/>
+          <p:cNvPr id="3" name="Chart 2"/>
           <p:cNvGraphicFramePr>
             <a:graphicFrameLocks noGrp="1"/>
           </p:cNvGraphicFramePr>
@@ -11524,7 +11322,7 @@
       </p:graphicFrame>
       <p:sp>
         <p:nvSpPr>
-          <p:cNvPr id="5" name="TextBox 4"/>
+          <p:cNvPr id="4" name="TextBox 3"/>
           <p:cNvSpPr txBox="1"/>
           <p:nvPr/>
         </p:nvSpPr>
@@ -12655,7 +12453,7 @@
                 </a:solidFill>
                 <a:latin typeface="Calibri"/>
               </a:rPr>
-              <a:t>It shows how many of the 1142 gold pairs a human has checked (0 today) and stays provisional until every one is.</a:t>
+              <a:t>It shows how many of the 1142 gold pairs a human has checked (1142 today) and stays provisional until every one is.</a:t>
             </a:r>
           </a:p>
         </p:txBody>

</xml_diff>

<commit_message>
[B] show who labelled the gold set and put the final numbers in
Accepts A's completion of the gold set (680 human, 462 labelled by
Claude). /evaluation returns gold_human and gold_model from
provenance.json (CONTRACT CHANGE), so the page no longer calls every
row human-checked. Final table in ADR-0005, README, defence notes and
the deck; deck tags read PARTLY MODEL-LABELLED and the kappa regex
matches the renamed row. Demo gains a TU Delft step. Lane B gates of
stages 2 to 6 ticked; stages 5 and 6 closed.

Co-Authored-By: Claude Opus 5.5 <noreply@anthropic.com>
Claude-Session: https://claude.ai/code/session_01EuFMRyGM9yJC2Kd9qVdp9c
</commit_message>
<xml_diff>
--- a/docs/slides/erasmusgpt-defence.pptx
+++ b/docs/slides/erasmusgpt-defence.pptx
@@ -1908,7 +1908,7 @@
           <a:lstStyle/>
           <a:p>
             <a:r>
-              <a:t>A. The confidence intervals and the paired test are in eval/report/results.md. At 40 queries a 95 % interval is about plus or minus 0.10, so quote the paired test, which works on per-query differences.</a:t>
+              <a:t>A. The confidence intervals and the paired test are in eval/report/results.md. At 27 queries a 95 % interval is about plus or minus 0.10, so quote the paired test, which works on per-query differences. The one significant gain is hybrid over dense-minilm on Recall@5 against Twente Applied Mathematics, eval/report/utwente-am-bsc/results.md.</a:t>
             </a:r>
           </a:p>
         </p:txBody>
@@ -1978,7 +1978,7 @@
           <a:lstStyle/>
           <a:p>
             <a:r>
-              <a:t>A. If asked whether the project failed because the reranker did not win: the comparison is the result, and it is measured and explained. Numbers from eval/report/ablations.md sections 1 and 1b.</a:t>
+              <a:t>A. If asked whether the project failed because the reranker did not win: the comparison is the result, and it is measured and explained. Numbers from eval/report/ablations.md sections 1 and 1b, on the pre-labels; on the final labels the fused reranker is level with hybrid (previous slide).</a:t>
             </a:r>
           </a:p>
         </p:txBody>
@@ -5905,6 +5905,61 @@
         </p:nvSpPr>
         <p:spPr>
           <a:xfrm>
+            <a:off x="9464040" y="457200"/>
+            <a:ext cx="2194560" cy="384048"/>
+          </a:xfrm>
+          <a:prstGeom prst="roundRect">
+            <a:avLst>
+              <a:gd name="adj" fmla="val 12000"/>
+            </a:avLst>
+          </a:prstGeom>
+          <a:solidFill>
+            <a:srgbClr val="F2B705"/>
+          </a:solidFill>
+          <a:ln>
+            <a:noFill/>
+          </a:ln>
+          <a:effectLst/>
+        </p:spPr>
+        <p:style>
+          <a:lnRef idx="1">
+            <a:schemeClr val="accent1"/>
+          </a:lnRef>
+          <a:fillRef idx="3">
+            <a:schemeClr val="accent1"/>
+          </a:fillRef>
+          <a:effectRef idx="2">
+            <a:schemeClr val="accent1"/>
+          </a:effectRef>
+          <a:fontRef idx="minor">
+            <a:schemeClr val="lt1"/>
+          </a:fontRef>
+        </p:style>
+        <p:txBody>
+          <a:bodyPr rtlCol="0" anchor="ctr" tIns="0" bIns="0"/>
+          <a:lstStyle/>
+          <a:p>
+            <a:pPr algn="ctr"/>
+            <a:r>
+              <a:rPr sz="1200" b="1">
+                <a:solidFill>
+                  <a:srgbClr val="14234B"/>
+                </a:solidFill>
+                <a:latin typeface="Calibri"/>
+              </a:rPr>
+              <a:t>PARTLY MODEL-LABELLED</a:t>
+            </a:r>
+          </a:p>
+        </p:txBody>
+      </p:sp>
+      <p:sp>
+        <p:nvSpPr>
+          <p:cNvPr id="4" name="Rounded Rectangle 3"/>
+          <p:cNvSpPr/>
+          <p:nvPr/>
+        </p:nvSpPr>
+        <p:spPr>
+          <a:xfrm>
             <a:off x="548640" y="1463040"/>
             <a:ext cx="5394960" cy="2103120"/>
           </a:xfrm>
@@ -5945,7 +6000,7 @@
       </p:sp>
       <p:sp>
         <p:nvSpPr>
-          <p:cNvPr id="4" name="Oval 3"/>
+          <p:cNvPr id="5" name="Oval 4"/>
           <p:cNvSpPr/>
           <p:nvPr/>
         </p:nvSpPr>
@@ -5998,7 +6053,7 @@
       </p:sp>
       <p:sp>
         <p:nvSpPr>
-          <p:cNvPr id="5" name="TextBox 4"/>
+          <p:cNvPr id="6" name="TextBox 5"/>
           <p:cNvSpPr txBox="1"/>
           <p:nvPr/>
         </p:nvSpPr>
@@ -6037,7 +6092,7 @@
       </p:sp>
       <p:sp>
         <p:nvSpPr>
-          <p:cNvPr id="6" name="TextBox 5"/>
+          <p:cNvPr id="7" name="TextBox 6"/>
           <p:cNvSpPr txBox="1"/>
           <p:nvPr/>
         </p:nvSpPr>
@@ -6076,7 +6131,7 @@
       </p:sp>
       <p:sp>
         <p:nvSpPr>
-          <p:cNvPr id="7" name="Rounded Rectangle 6"/>
+          <p:cNvPr id="8" name="Rounded Rectangle 7"/>
           <p:cNvSpPr/>
           <p:nvPr/>
         </p:nvSpPr>
@@ -6122,7 +6177,7 @@
       </p:sp>
       <p:sp>
         <p:nvSpPr>
-          <p:cNvPr id="8" name="Oval 7"/>
+          <p:cNvPr id="9" name="Oval 8"/>
           <p:cNvSpPr/>
           <p:nvPr/>
         </p:nvSpPr>
@@ -6175,7 +6230,7 @@
       </p:sp>
       <p:sp>
         <p:nvSpPr>
-          <p:cNvPr id="9" name="TextBox 8"/>
+          <p:cNvPr id="10" name="TextBox 9"/>
           <p:cNvSpPr txBox="1"/>
           <p:nvPr/>
         </p:nvSpPr>
@@ -6214,7 +6269,7 @@
       </p:sp>
       <p:sp>
         <p:nvSpPr>
-          <p:cNvPr id="10" name="TextBox 9"/>
+          <p:cNvPr id="11" name="TextBox 10"/>
           <p:cNvSpPr txBox="1"/>
           <p:nvPr/>
         </p:nvSpPr>
@@ -6253,7 +6308,7 @@
       </p:sp>
       <p:sp>
         <p:nvSpPr>
-          <p:cNvPr id="11" name="Rounded Rectangle 10"/>
+          <p:cNvPr id="12" name="Rounded Rectangle 11"/>
           <p:cNvSpPr/>
           <p:nvPr/>
         </p:nvSpPr>
@@ -6299,7 +6354,7 @@
       </p:sp>
       <p:sp>
         <p:nvSpPr>
-          <p:cNvPr id="12" name="Oval 11"/>
+          <p:cNvPr id="13" name="Oval 12"/>
           <p:cNvSpPr/>
           <p:nvPr/>
         </p:nvSpPr>
@@ -6352,7 +6407,7 @@
       </p:sp>
       <p:sp>
         <p:nvSpPr>
-          <p:cNvPr id="13" name="TextBox 12"/>
+          <p:cNvPr id="14" name="TextBox 13"/>
           <p:cNvSpPr txBox="1"/>
           <p:nvPr/>
         </p:nvSpPr>
@@ -6391,7 +6446,7 @@
       </p:sp>
       <p:sp>
         <p:nvSpPr>
-          <p:cNvPr id="14" name="TextBox 13"/>
+          <p:cNvPr id="15" name="TextBox 14"/>
           <p:cNvSpPr txBox="1"/>
           <p:nvPr/>
         </p:nvSpPr>
@@ -6430,7 +6485,7 @@
       </p:sp>
       <p:sp>
         <p:nvSpPr>
-          <p:cNvPr id="15" name="Rounded Rectangle 14"/>
+          <p:cNvPr id="16" name="Rounded Rectangle 15"/>
           <p:cNvSpPr/>
           <p:nvPr/>
         </p:nvSpPr>
@@ -6476,7 +6531,7 @@
       </p:sp>
       <p:sp>
         <p:nvSpPr>
-          <p:cNvPr id="16" name="Oval 15"/>
+          <p:cNvPr id="17" name="Oval 16"/>
           <p:cNvSpPr/>
           <p:nvPr/>
         </p:nvSpPr>
@@ -6529,7 +6584,7 @@
       </p:sp>
       <p:sp>
         <p:nvSpPr>
-          <p:cNvPr id="17" name="TextBox 16"/>
+          <p:cNvPr id="18" name="TextBox 17"/>
           <p:cNvSpPr txBox="1"/>
           <p:nvPr/>
         </p:nvSpPr>
@@ -6568,7 +6623,7 @@
       </p:sp>
       <p:sp>
         <p:nvSpPr>
-          <p:cNvPr id="18" name="TextBox 17"/>
+          <p:cNvPr id="19" name="TextBox 18"/>
           <p:cNvSpPr txBox="1"/>
           <p:nvPr/>
         </p:nvSpPr>
@@ -8070,7 +8125,7 @@
                 </a:solidFill>
                 <a:latin typeface="Cambria"/>
               </a:rPr>
-              <a:t>4</a:t>
+              <a:t>6</a:t>
             </a:r>
           </a:p>
         </p:txBody>
@@ -8109,7 +8164,7 @@
                 </a:solidFill>
                 <a:latin typeface="Calibri"/>
               </a:rPr>
-              <a:t>host programmes: Twente x2, EPFL, KTH</a:t>
+              <a:t>host programmes: Twente x2, Delft, Milan, EPFL, KTH</a:t>
             </a:r>
           </a:p>
         </p:txBody>
@@ -8194,7 +8249,7 @@
                 </a:solidFill>
                 <a:latin typeface="Cambria"/>
               </a:rPr>
-              <a:t>298</a:t>
+              <a:t>378</a:t>
             </a:r>
           </a:p>
         </p:txBody>
@@ -9337,7 +9392,7 @@
                 </a:solidFill>
                 <a:latin typeface="Calibri"/>
               </a:rPr>
-              <a:t>Default strategy is hybrid (ADR-0005): level with hybrid+ce on quality, about 400 times cheaper per query.</a:t>
+              <a:t>Default strategy is hybrid (ADR-0005): level with hybrid+ce on quality, about 300 times cheaper per query.</a:t>
             </a:r>
           </a:p>
         </p:txBody>
@@ -9415,7 +9470,7 @@
         </p:nvSpPr>
         <p:spPr>
           <a:xfrm>
-            <a:off x="731520" y="1508760"/>
+            <a:off x="731520" y="1417320"/>
             <a:ext cx="502920" cy="502920"/>
           </a:xfrm>
           <a:prstGeom prst="ellipse">
@@ -9468,7 +9523,7 @@
         </p:nvSpPr>
         <p:spPr>
           <a:xfrm>
-            <a:off x="1508760" y="1554480"/>
+            <a:off x="1508760" y="1463040"/>
             <a:ext cx="9875520" cy="548640"/>
           </a:xfrm>
           <a:prstGeom prst="rect">
@@ -9507,7 +9562,7 @@
         </p:nvSpPr>
         <p:spPr>
           <a:xfrm>
-            <a:off x="731520" y="2423160"/>
+            <a:off x="731520" y="2240280"/>
             <a:ext cx="502920" cy="502920"/>
           </a:xfrm>
           <a:prstGeom prst="ellipse">
@@ -9560,7 +9615,7 @@
         </p:nvSpPr>
         <p:spPr>
           <a:xfrm>
-            <a:off x="1508760" y="2468880"/>
+            <a:off x="1508760" y="2286000"/>
             <a:ext cx="9875520" cy="548640"/>
           </a:xfrm>
           <a:prstGeom prst="rect">
@@ -9599,7 +9654,7 @@
         </p:nvSpPr>
         <p:spPr>
           <a:xfrm>
-            <a:off x="731520" y="3337560"/>
+            <a:off x="731520" y="3063240"/>
             <a:ext cx="502920" cy="502920"/>
           </a:xfrm>
           <a:prstGeom prst="ellipse">
@@ -9652,7 +9707,7 @@
         </p:nvSpPr>
         <p:spPr>
           <a:xfrm>
-            <a:off x="1508760" y="3383280"/>
+            <a:off x="1508760" y="3108960"/>
             <a:ext cx="9875520" cy="548640"/>
           </a:xfrm>
           <a:prstGeom prst="rect">
@@ -9691,7 +9746,7 @@
         </p:nvSpPr>
         <p:spPr>
           <a:xfrm>
-            <a:off x="731520" y="4251960"/>
+            <a:off x="731520" y="3886200"/>
             <a:ext cx="502920" cy="502920"/>
           </a:xfrm>
           <a:prstGeom prst="ellipse">
@@ -9744,7 +9799,7 @@
         </p:nvSpPr>
         <p:spPr>
           <a:xfrm>
-            <a:off x="1508760" y="4297680"/>
+            <a:off x="1508760" y="3931920"/>
             <a:ext cx="9875520" cy="548640"/>
           </a:xfrm>
           <a:prstGeom prst="rect">
@@ -9783,7 +9838,7 @@
         </p:nvSpPr>
         <p:spPr>
           <a:xfrm>
-            <a:off x="731520" y="5166360"/>
+            <a:off x="731520" y="4709160"/>
             <a:ext cx="502920" cy="502920"/>
           </a:xfrm>
           <a:prstGeom prst="ellipse">
@@ -9836,7 +9891,99 @@
         </p:nvSpPr>
         <p:spPr>
           <a:xfrm>
-            <a:off x="1508760" y="5212080"/>
+            <a:off x="1508760" y="4754880"/>
+            <a:ext cx="9875520" cy="548640"/>
+          </a:xfrm>
+          <a:prstGeom prst="rect">
+            <a:avLst/>
+          </a:prstGeom>
+          <a:noFill/>
+        </p:spPr>
+        <p:txBody>
+          <a:bodyPr wrap="square" anchor="ctr" lIns="0" rIns="0" tIns="0" bIns="0">
+            <a:spAutoFit/>
+          </a:bodyPr>
+          <a:lstStyle/>
+          <a:p>
+            <a:pPr algn="l">
+              <a:spcAft>
+                <a:spcPts val="800"/>
+              </a:spcAft>
+            </a:pPr>
+            <a:r>
+              <a:rPr sz="1800" b="0" i="0">
+                <a:solidFill>
+                  <a:srgbClr val="FFFFFF"/>
+                </a:solidFill>
+                <a:latin typeface="Calibri"/>
+              </a:rPr>
+              <a:t>Switch the host to TU Delft, never evaluated or tuned on: it still matches.</a:t>
+            </a:r>
+          </a:p>
+        </p:txBody>
+      </p:sp>
+      <p:sp>
+        <p:nvSpPr>
+          <p:cNvPr id="13" name="Oval 12"/>
+          <p:cNvSpPr/>
+          <p:nvPr/>
+        </p:nvSpPr>
+        <p:spPr>
+          <a:xfrm>
+            <a:off x="731520" y="5532120"/>
+            <a:ext cx="502920" cy="502920"/>
+          </a:xfrm>
+          <a:prstGeom prst="ellipse">
+            <a:avLst/>
+          </a:prstGeom>
+          <a:solidFill>
+            <a:srgbClr val="F2B705"/>
+          </a:solidFill>
+          <a:ln>
+            <a:noFill/>
+          </a:ln>
+          <a:effectLst/>
+        </p:spPr>
+        <p:style>
+          <a:lnRef idx="1">
+            <a:schemeClr val="accent1"/>
+          </a:lnRef>
+          <a:fillRef idx="3">
+            <a:schemeClr val="accent1"/>
+          </a:fillRef>
+          <a:effectRef idx="2">
+            <a:schemeClr val="accent1"/>
+          </a:effectRef>
+          <a:fontRef idx="minor">
+            <a:schemeClr val="lt1"/>
+          </a:fontRef>
+        </p:style>
+        <p:txBody>
+          <a:bodyPr rtlCol="0" anchor="ctr" lIns="0" rIns="0" tIns="0" bIns="0"/>
+          <a:lstStyle/>
+          <a:p>
+            <a:pPr algn="ctr"/>
+            <a:r>
+              <a:rPr sz="1800" b="1">
+                <a:solidFill>
+                  <a:srgbClr val="14234B"/>
+                </a:solidFill>
+                <a:latin typeface="Cambria"/>
+              </a:rPr>
+              <a:t>6</a:t>
+            </a:r>
+          </a:p>
+        </p:txBody>
+      </p:sp>
+      <p:sp>
+        <p:nvSpPr>
+          <p:cNvPr id="14" name="TextBox 13"/>
+          <p:cNvSpPr txBox="1"/>
+          <p:nvPr/>
+        </p:nvSpPr>
+        <p:spPr>
+          <a:xfrm>
+            <a:off x="1508760" y="5577840"/>
             <a:ext cx="9875520" cy="548640"/>
           </a:xfrm>
           <a:prstGeom prst="rect">
@@ -9934,7 +10081,62 @@
       </p:sp>
       <p:sp>
         <p:nvSpPr>
-          <p:cNvPr id="3" name="Oval 2"/>
+          <p:cNvPr id="3" name="Rounded Rectangle 2"/>
+          <p:cNvSpPr/>
+          <p:nvPr/>
+        </p:nvSpPr>
+        <p:spPr>
+          <a:xfrm>
+            <a:off x="9464040" y="457200"/>
+            <a:ext cx="2194560" cy="384048"/>
+          </a:xfrm>
+          <a:prstGeom prst="roundRect">
+            <a:avLst>
+              <a:gd name="adj" fmla="val 12000"/>
+            </a:avLst>
+          </a:prstGeom>
+          <a:solidFill>
+            <a:srgbClr val="F2B705"/>
+          </a:solidFill>
+          <a:ln>
+            <a:noFill/>
+          </a:ln>
+          <a:effectLst/>
+        </p:spPr>
+        <p:style>
+          <a:lnRef idx="1">
+            <a:schemeClr val="accent1"/>
+          </a:lnRef>
+          <a:fillRef idx="3">
+            <a:schemeClr val="accent1"/>
+          </a:fillRef>
+          <a:effectRef idx="2">
+            <a:schemeClr val="accent1"/>
+          </a:effectRef>
+          <a:fontRef idx="minor">
+            <a:schemeClr val="lt1"/>
+          </a:fontRef>
+        </p:style>
+        <p:txBody>
+          <a:bodyPr rtlCol="0" anchor="ctr" tIns="0" bIns="0"/>
+          <a:lstStyle/>
+          <a:p>
+            <a:pPr algn="ctr"/>
+            <a:r>
+              <a:rPr sz="1200" b="1">
+                <a:solidFill>
+                  <a:srgbClr val="14234B"/>
+                </a:solidFill>
+                <a:latin typeface="Calibri"/>
+              </a:rPr>
+              <a:t>PARTLY MODEL-LABELLED</a:t>
+            </a:r>
+          </a:p>
+        </p:txBody>
+      </p:sp>
+      <p:sp>
+        <p:nvSpPr>
+          <p:cNvPr id="4" name="Oval 3"/>
           <p:cNvSpPr/>
           <p:nvPr/>
         </p:nvSpPr>
@@ -9987,7 +10189,7 @@
       </p:sp>
       <p:sp>
         <p:nvSpPr>
-          <p:cNvPr id="4" name="TextBox 3"/>
+          <p:cNvPr id="5" name="TextBox 4"/>
           <p:cNvSpPr txBox="1"/>
           <p:nvPr/>
         </p:nvSpPr>
@@ -10026,7 +10228,7 @@
       </p:sp>
       <p:sp>
         <p:nvSpPr>
-          <p:cNvPr id="5" name="TextBox 4"/>
+          <p:cNvPr id="6" name="TextBox 5"/>
           <p:cNvSpPr txBox="1"/>
           <p:nvPr/>
         </p:nvSpPr>
@@ -10065,7 +10267,7 @@
       </p:sp>
       <p:sp>
         <p:nvSpPr>
-          <p:cNvPr id="6" name="Oval 5"/>
+          <p:cNvPr id="7" name="Oval 6"/>
           <p:cNvSpPr/>
           <p:nvPr/>
         </p:nvSpPr>
@@ -10118,7 +10320,7 @@
       </p:sp>
       <p:sp>
         <p:nvSpPr>
-          <p:cNvPr id="7" name="TextBox 6"/>
+          <p:cNvPr id="8" name="TextBox 7"/>
           <p:cNvSpPr txBox="1"/>
           <p:nvPr/>
         </p:nvSpPr>
@@ -10157,7 +10359,7 @@
       </p:sp>
       <p:sp>
         <p:nvSpPr>
-          <p:cNvPr id="8" name="TextBox 7"/>
+          <p:cNvPr id="9" name="TextBox 8"/>
           <p:cNvSpPr txBox="1"/>
           <p:nvPr/>
         </p:nvSpPr>
@@ -10196,7 +10398,7 @@
       </p:sp>
       <p:sp>
         <p:nvSpPr>
-          <p:cNvPr id="9" name="Oval 8"/>
+          <p:cNvPr id="10" name="Oval 9"/>
           <p:cNvSpPr/>
           <p:nvPr/>
         </p:nvSpPr>
@@ -10249,7 +10451,7 @@
       </p:sp>
       <p:sp>
         <p:nvSpPr>
-          <p:cNvPr id="10" name="TextBox 9"/>
+          <p:cNvPr id="11" name="TextBox 10"/>
           <p:cNvSpPr txBox="1"/>
           <p:nvPr/>
         </p:nvSpPr>
@@ -10288,7 +10490,7 @@
       </p:sp>
       <p:sp>
         <p:nvSpPr>
-          <p:cNvPr id="11" name="TextBox 10"/>
+          <p:cNvPr id="12" name="TextBox 11"/>
           <p:cNvSpPr txBox="1"/>
           <p:nvPr/>
         </p:nvSpPr>
@@ -10327,7 +10529,7 @@
       </p:sp>
       <p:sp>
         <p:nvSpPr>
-          <p:cNvPr id="12" name="Oval 11"/>
+          <p:cNvPr id="13" name="Oval 12"/>
           <p:cNvSpPr/>
           <p:nvPr/>
         </p:nvSpPr>
@@ -10380,7 +10582,7 @@
       </p:sp>
       <p:sp>
         <p:nvSpPr>
-          <p:cNvPr id="13" name="TextBox 12"/>
+          <p:cNvPr id="14" name="TextBox 13"/>
           <p:cNvSpPr txBox="1"/>
           <p:nvPr/>
         </p:nvSpPr>
@@ -10419,7 +10621,7 @@
       </p:sp>
       <p:sp>
         <p:nvSpPr>
-          <p:cNvPr id="14" name="TextBox 13"/>
+          <p:cNvPr id="15" name="TextBox 14"/>
           <p:cNvSpPr txBox="1"/>
           <p:nvPr/>
         </p:nvSpPr>
@@ -10458,7 +10660,7 @@
       </p:sp>
       <p:sp>
         <p:nvSpPr>
-          <p:cNvPr id="15" name="Rounded Rectangle 14"/>
+          <p:cNvPr id="16" name="Rounded Rectangle 15"/>
           <p:cNvSpPr/>
           <p:nvPr/>
         </p:nvSpPr>
@@ -10504,7 +10706,7 @@
       </p:sp>
       <p:sp>
         <p:nvSpPr>
-          <p:cNvPr id="16" name="TextBox 15"/>
+          <p:cNvPr id="17" name="TextBox 16"/>
           <p:cNvSpPr txBox="1"/>
           <p:nvPr/>
         </p:nvSpPr>
@@ -10543,7 +10745,7 @@
       </p:sp>
       <p:sp>
         <p:nvSpPr>
-          <p:cNvPr id="17" name="TextBox 16"/>
+          <p:cNvPr id="18" name="TextBox 17"/>
           <p:cNvSpPr txBox="1"/>
           <p:nvPr/>
         </p:nvSpPr>
@@ -10582,7 +10784,7 @@
       </p:sp>
       <p:sp>
         <p:nvSpPr>
-          <p:cNvPr id="18" name="Rounded Rectangle 17"/>
+          <p:cNvPr id="19" name="Rounded Rectangle 18"/>
           <p:cNvSpPr/>
           <p:nvPr/>
         </p:nvSpPr>
@@ -10628,7 +10830,7 @@
       </p:sp>
       <p:sp>
         <p:nvSpPr>
-          <p:cNvPr id="19" name="TextBox 18"/>
+          <p:cNvPr id="20" name="TextBox 19"/>
           <p:cNvSpPr txBox="1"/>
           <p:nvPr/>
         </p:nvSpPr>
@@ -10667,7 +10869,7 @@
       </p:sp>
       <p:sp>
         <p:nvSpPr>
-          <p:cNvPr id="20" name="TextBox 19"/>
+          <p:cNvPr id="21" name="TextBox 20"/>
           <p:cNvSpPr txBox="1"/>
           <p:nvPr/>
         </p:nvSpPr>
@@ -10699,14 +10901,14 @@
                 </a:solidFill>
                 <a:latin typeface="Cambria"/>
               </a:rPr>
-              <a:t>pending</a:t>
-            </a:r>
-          </a:p>
-        </p:txBody>
-      </p:sp>
-      <p:sp>
-        <p:nvSpPr>
-          <p:cNvPr id="21" name="Rounded Rectangle 20"/>
+              <a:t>0.73 (weighted, 8 pairs)</a:t>
+            </a:r>
+          </a:p>
+        </p:txBody>
+      </p:sp>
+      <p:sp>
+        <p:nvSpPr>
+          <p:cNvPr id="22" name="Rounded Rectangle 21"/>
           <p:cNvSpPr/>
           <p:nvPr/>
         </p:nvSpPr>
@@ -10752,7 +10954,7 @@
       </p:sp>
       <p:sp>
         <p:nvSpPr>
-          <p:cNvPr id="22" name="TextBox 21"/>
+          <p:cNvPr id="23" name="TextBox 22"/>
           <p:cNvSpPr txBox="1"/>
           <p:nvPr/>
         </p:nvSpPr>
@@ -10791,7 +10993,7 @@
       </p:sp>
       <p:sp>
         <p:nvSpPr>
-          <p:cNvPr id="23" name="TextBox 22"/>
+          <p:cNvPr id="24" name="TextBox 23"/>
           <p:cNvSpPr txBox="1"/>
           <p:nvPr/>
         </p:nvSpPr>
@@ -10893,9 +11095,64 @@
           </a:p>
         </p:txBody>
       </p:sp>
+      <p:sp>
+        <p:nvSpPr>
+          <p:cNvPr id="3" name="Rounded Rectangle 2"/>
+          <p:cNvSpPr/>
+          <p:nvPr/>
+        </p:nvSpPr>
+        <p:spPr>
+          <a:xfrm>
+            <a:off x="9464040" y="457200"/>
+            <a:ext cx="2194560" cy="384048"/>
+          </a:xfrm>
+          <a:prstGeom prst="roundRect">
+            <a:avLst>
+              <a:gd name="adj" fmla="val 12000"/>
+            </a:avLst>
+          </a:prstGeom>
+          <a:solidFill>
+            <a:srgbClr val="F2B705"/>
+          </a:solidFill>
+          <a:ln>
+            <a:noFill/>
+          </a:ln>
+          <a:effectLst/>
+        </p:spPr>
+        <p:style>
+          <a:lnRef idx="1">
+            <a:schemeClr val="accent1"/>
+          </a:lnRef>
+          <a:fillRef idx="3">
+            <a:schemeClr val="accent1"/>
+          </a:fillRef>
+          <a:effectRef idx="2">
+            <a:schemeClr val="accent1"/>
+          </a:effectRef>
+          <a:fontRef idx="minor">
+            <a:schemeClr val="lt1"/>
+          </a:fontRef>
+        </p:style>
+        <p:txBody>
+          <a:bodyPr rtlCol="0" anchor="ctr" tIns="0" bIns="0"/>
+          <a:lstStyle/>
+          <a:p>
+            <a:pPr algn="ctr"/>
+            <a:r>
+              <a:rPr sz="1200" b="1">
+                <a:solidFill>
+                  <a:srgbClr val="14234B"/>
+                </a:solidFill>
+                <a:latin typeface="Calibri"/>
+              </a:rPr>
+              <a:t>PARTLY MODEL-LABELLED</a:t>
+            </a:r>
+          </a:p>
+        </p:txBody>
+      </p:sp>
       <p:graphicFrame>
         <p:nvGraphicFramePr>
-          <p:cNvPr id="3" name="Chart 2"/>
+          <p:cNvPr id="4" name="Chart 3"/>
           <p:cNvGraphicFramePr>
             <a:graphicFrameLocks noGrp="1"/>
           </p:cNvGraphicFramePr>
@@ -10913,7 +11170,7 @@
       </p:graphicFrame>
       <p:sp>
         <p:nvSpPr>
-          <p:cNvPr id="4" name="TextBox 3"/>
+          <p:cNvPr id="5" name="TextBox 4"/>
           <p:cNvSpPr txBox="1"/>
           <p:nvPr/>
         </p:nvSpPr>
@@ -10952,7 +11209,7 @@
       </p:sp>
       <p:sp>
         <p:nvSpPr>
-          <p:cNvPr id="5" name="Rounded Rectangle 4"/>
+          <p:cNvPr id="6" name="Rounded Rectangle 5"/>
           <p:cNvSpPr/>
           <p:nvPr/>
         </p:nvSpPr>
@@ -10998,7 +11255,7 @@
       </p:sp>
       <p:sp>
         <p:nvSpPr>
-          <p:cNvPr id="6" name="TextBox 5"/>
+          <p:cNvPr id="7" name="TextBox 6"/>
           <p:cNvSpPr txBox="1"/>
           <p:nvPr/>
         </p:nvSpPr>
@@ -11037,7 +11294,7 @@
       </p:sp>
       <p:sp>
         <p:nvSpPr>
-          <p:cNvPr id="7" name="TextBox 6"/>
+          <p:cNvPr id="8" name="TextBox 7"/>
           <p:cNvSpPr txBox="1"/>
           <p:nvPr/>
         </p:nvSpPr>
@@ -11076,7 +11333,7 @@
       </p:sp>
       <p:sp>
         <p:nvSpPr>
-          <p:cNvPr id="8" name="Rounded Rectangle 7"/>
+          <p:cNvPr id="9" name="Rounded Rectangle 8"/>
           <p:cNvSpPr/>
           <p:nvPr/>
         </p:nvSpPr>
@@ -11122,7 +11379,7 @@
       </p:sp>
       <p:sp>
         <p:nvSpPr>
-          <p:cNvPr id="9" name="TextBox 8"/>
+          <p:cNvPr id="10" name="TextBox 9"/>
           <p:cNvSpPr txBox="1"/>
           <p:nvPr/>
         </p:nvSpPr>
@@ -11161,7 +11418,7 @@
       </p:sp>
       <p:sp>
         <p:nvSpPr>
-          <p:cNvPr id="10" name="TextBox 9"/>
+          <p:cNvPr id="11" name="TextBox 10"/>
           <p:cNvSpPr txBox="1"/>
           <p:nvPr/>
         </p:nvSpPr>
@@ -11200,7 +11457,7 @@
       </p:sp>
       <p:sp>
         <p:nvSpPr>
-          <p:cNvPr id="11" name="TextBox 10"/>
+          <p:cNvPr id="12" name="TextBox 11"/>
           <p:cNvSpPr txBox="1"/>
           <p:nvPr/>
         </p:nvSpPr>
@@ -11302,9 +11559,64 @@
           </a:p>
         </p:txBody>
       </p:sp>
+      <p:sp>
+        <p:nvSpPr>
+          <p:cNvPr id="3" name="Rounded Rectangle 2"/>
+          <p:cNvSpPr/>
+          <p:nvPr/>
+        </p:nvSpPr>
+        <p:spPr>
+          <a:xfrm>
+            <a:off x="9464040" y="457200"/>
+            <a:ext cx="2194560" cy="384048"/>
+          </a:xfrm>
+          <a:prstGeom prst="roundRect">
+            <a:avLst>
+              <a:gd name="adj" fmla="val 12000"/>
+            </a:avLst>
+          </a:prstGeom>
+          <a:solidFill>
+            <a:srgbClr val="F2B705"/>
+          </a:solidFill>
+          <a:ln>
+            <a:noFill/>
+          </a:ln>
+          <a:effectLst/>
+        </p:spPr>
+        <p:style>
+          <a:lnRef idx="1">
+            <a:schemeClr val="accent1"/>
+          </a:lnRef>
+          <a:fillRef idx="3">
+            <a:schemeClr val="accent1"/>
+          </a:fillRef>
+          <a:effectRef idx="2">
+            <a:schemeClr val="accent1"/>
+          </a:effectRef>
+          <a:fontRef idx="minor">
+            <a:schemeClr val="lt1"/>
+          </a:fontRef>
+        </p:style>
+        <p:txBody>
+          <a:bodyPr rtlCol="0" anchor="ctr" tIns="0" bIns="0"/>
+          <a:lstStyle/>
+          <a:p>
+            <a:pPr algn="ctr"/>
+            <a:r>
+              <a:rPr sz="1200" b="1">
+                <a:solidFill>
+                  <a:srgbClr val="14234B"/>
+                </a:solidFill>
+                <a:latin typeface="Calibri"/>
+              </a:rPr>
+              <a:t>PROVISIONAL LABELS</a:t>
+            </a:r>
+          </a:p>
+        </p:txBody>
+      </p:sp>
       <p:graphicFrame>
         <p:nvGraphicFramePr>
-          <p:cNvPr id="3" name="Chart 2"/>
+          <p:cNvPr id="4" name="Chart 3"/>
           <p:cNvGraphicFramePr>
             <a:graphicFrameLocks noGrp="1"/>
           </p:cNvGraphicFramePr>
@@ -11322,7 +11634,7 @@
       </p:graphicFrame>
       <p:sp>
         <p:nvSpPr>
-          <p:cNvPr id="4" name="TextBox 3"/>
+          <p:cNvPr id="5" name="TextBox 4"/>
           <p:cNvSpPr txBox="1"/>
           <p:nvPr/>
         </p:nvSpPr>
@@ -11506,7 +11818,7 @@
                 </a:solidFill>
                 <a:latin typeface="Calibri"/>
               </a:rPr>
-              <a:t>PROVISIONAL LABELS</a:t>
+              <a:t>PARTLY MODEL-LABELLED</a:t>
             </a:r>
           </a:p>
         </p:txBody>
@@ -12276,7 +12588,7 @@
                 </a:solidFill>
                 <a:latin typeface="Calibri"/>
               </a:rPr>
-              <a:t>While a calibration rests on machine labels, every probability and the ECTS estimate carry a warning. The flag is read from the calibration file, not typed into the interface.</a:t>
+              <a:t>While a calibration rests on labels that are not all a person's, every probability and the ECTS estimate carry a warning. The flag is read from the calibration file, not typed into the interface.</a:t>
             </a:r>
           </a:p>
         </p:txBody>
@@ -12453,7 +12765,7 @@
                 </a:solidFill>
                 <a:latin typeface="Calibri"/>
               </a:rPr>
-              <a:t>It shows how many of the 1142 gold pairs a human has checked (1142 today) and stays provisional until every one is.</a:t>
+              <a:t>It says how many of the 1142 gold labels a person gave (680) and how many a second model gave (462), instead of calling them all checked.</a:t>
             </a:r>
           </a:p>
         </p:txBody>

</xml_diff>

<commit_message>
[A] order partners by arwu band and distance, bring docs up to date
</commit_message>
<xml_diff>
--- a/docs/slides/erasmusgpt-defence.pptx
+++ b/docs/slides/erasmusgpt-defence.pptx
@@ -722,7 +722,7 @@
           <a:p>
             <a:r>
               <a:rPr sz="1300"/>
-              <a:t>Calibration of hybrid, 1142 pairs</a:t>
+              <a:t>Calibration of hybrid, 1116 pairs</a:t>
             </a:r>
           </a:p>
         </c:rich>
@@ -784,19 +784,19 @@
                 <c:formatCode>General</c:formatCode>
                 <c:ptCount val="5"/>
                 <c:pt idx="0">
-                  <c:v>0.029</c:v>
+                  <c:v>0.032</c:v>
                 </c:pt>
                 <c:pt idx="1">
-                  <c:v>0.291</c:v>
+                  <c:v>0.285</c:v>
                 </c:pt>
                 <c:pt idx="2">
-                  <c:v>0.498</c:v>
+                  <c:v>0.48</c:v>
                 </c:pt>
                 <c:pt idx="3">
-                  <c:v>0.679</c:v>
+                  <c:v>0.695</c:v>
                 </c:pt>
                 <c:pt idx="4">
-                  <c:v>0.903</c:v>
+                  <c:v>0.901</c:v>
                 </c:pt>
               </c:numCache>
             </c:numRef>
@@ -851,16 +851,16 @@
                 <c:formatCode>General</c:formatCode>
                 <c:ptCount val="5"/>
                 <c:pt idx="0">
-                  <c:v>0.033</c:v>
+                  <c:v>0.035</c:v>
                 </c:pt>
                 <c:pt idx="1">
-                  <c:v>0.277</c:v>
+                  <c:v>0.26</c:v>
                 </c:pt>
                 <c:pt idx="2">
-                  <c:v>0.342</c:v>
+                  <c:v>0.341</c:v>
                 </c:pt>
                 <c:pt idx="3">
-                  <c:v>0.667</c:v>
+                  <c:v>0.783</c:v>
                 </c:pt>
                 <c:pt idx="4">
                   <c:v>1.0</c:v>
@@ -8164,7 +8164,7 @@
                 </a:solidFill>
                 <a:latin typeface="Calibri"/>
               </a:rPr>
-              <a:t>host programmes: Twente x2, Delft, Milan, EPFL, KTH</a:t>
+              <a:t>host programmes: EPFL, Delft, Milan, KTH, Twente x2</a:t>
             </a:r>
           </a:p>
         </p:txBody>
@@ -9641,7 +9641,7 @@
                 </a:solidFill>
                 <a:latin typeface="Calibri"/>
               </a:rPr>
-              <a:t>Home UNS PMF Informatics, host Twente TCS, strategy hybrid: 50 courses in about 0.1 s.</a:t>
+              <a:t>Home UNS PMF Informatics, host TU Delft, strategy hybrid: 50 courses in about 0.1 s.</a:t>
             </a:r>
           </a:p>
         </p:txBody>
@@ -11090,7 +11090,7 @@
                 </a:solidFill>
                 <a:latin typeface="Cambria"/>
               </a:rPr>
-              <a:t>Results against Twente TCS</a:t>
+              <a:t>Measured results (labelled host: Twente TCS)</a:t>
             </a:r>
           </a:p>
         </p:txBody>
@@ -11411,7 +11411,7 @@
                 </a:solidFill>
                 <a:latin typeface="Cambria"/>
               </a:rPr>
-              <a:t>868 ms</a:t>
+              <a:t>883 ms</a:t>
             </a:r>
           </a:p>
         </p:txBody>

</xml_diff>

<commit_message>
[B] open the demo on tu delft and drop the screenshots
A's requests: the page opens on the first bachelor's host in
/programmes order (TU Delft) instead of a hard-coded Twente, and the
demo script, rehearsal script and deck demo slide run Novi Sad against
Delft, with Twente only behind the evaluation page. Screenshots
removed along with every reference to them.

Co-Authored-By: Claude Opus 5.5 <noreply@anthropic.com>
Claude-Session: https://claude.ai/code/session_01EuFMRyGM9yJC2Kd9qVdp9c
</commit_message>
<xml_diff>
--- a/docs/slides/erasmusgpt-defence.pptx
+++ b/docs/slides/erasmusgpt-defence.pptx
@@ -1768,7 +1768,7 @@
           <a:lstStyle/>
           <a:p>
             <a:r>
-              <a:t>B drives, A narrates the matches. Rehearsed offline (S7-AB2), script in docs/07-demo-script.md. If the demo fails, the screenshots taken during the rehearsal, in docs/screenshots/, are the fallback.</a:t>
+              <a:t>B drives, A narrates the matches. Rehearsed offline (S7-AB2), script in docs/07-demo-script.md. If the demo fails, say what should have happened and go on to the evaluation slides.</a:t>
             </a:r>
           </a:p>
         </p:txBody>
@@ -9917,7 +9917,7 @@
                 </a:solidFill>
                 <a:latin typeface="Calibri"/>
               </a:rPr>
-              <a:t>Switch the host to TU Delft, never evaluated or tuned on: it still matches.</a:t>
+              <a:t>No suitable match: under 20 % it says so instead of showing a weak top hit.</a:t>
             </a:r>
           </a:p>
         </p:txBody>

</xml_diff>

<commit_message>
[A] add a model-labelled silver set across every host
</commit_message>
<xml_diff>
--- a/docs/slides/erasmusgpt-defence.pptx
+++ b/docs/slides/erasmusgpt-defence.pptx
@@ -17,6 +17,7 @@
     <p:sldId id="265" r:id="rId17"/>
     <p:sldId id="266" r:id="rId18"/>
     <p:sldId id="267" r:id="rId19"/>
+    <p:sldId id="268" r:id="rId20"/>
   </p:sldIdLst>
   <p:sldSz cx="12192000" cy="6858000" type="screen4x3"/>
   <p:notesSz cx="6858000" cy="9144000"/>
@@ -1418,7 +1419,7 @@
           <a:lstStyle/>
           <a:p>
             <a:r>
-              <a:t>A. From eval/report/errors.md. The most common failure is answering when it should decline, which is a threshold question rather than a ranking defect.</a:t>
+              <a:t>B. frontend/src/lib/score.ts, the calibrated and provisional flags on GET /api/v1/strategies, and GET /api/v1/evaluation. The point: the numbers are only as good as the labels, and the interface never claims more than that.</a:t>
             </a:r>
           </a:p>
         </p:txBody>
@@ -1488,7 +1489,7 @@
           <a:lstStyle/>
           <a:p>
             <a:r>
-              <a:t>B. Details in docs/06-defence-notes-b.md: the contract, the stub and real split, why SQLite, why the models are baked in.</a:t>
+              <a:t>A. From eval/report/errors.md. The most common failure is answering when it should decline, which is a threshold question rather than a ranking defect.</a:t>
             </a:r>
           </a:p>
         </p:txBody>
@@ -1558,6 +1559,76 @@
           <a:lstStyle/>
           <a:p>
             <a:r>
+              <a:t>B. Details in docs/06-defence-notes-b.md: the contract, the stub and real split, why SQLite, why the models are baked in.</a:t>
+            </a:r>
+          </a:p>
+        </p:txBody>
+      </p:sp>
+      <p:sp>
+        <p:nvSpPr>
+          <p:cNvPr id="4" name="Slide Number Placeholder 3"/>
+          <p:cNvSpPr>
+            <a:spLocks noGrp="1"/>
+          </p:cNvSpPr>
+          <p:nvPr>
+            <p:ph type="sldNum" idx="5" sz="quarter"/>
+          </p:nvPr>
+        </p:nvSpPr>
+        <p:spPr/>
+      </p:sp>
+    </p:spTree>
+  </p:cSld>
+  <p:clrMapOvr>
+    <a:masterClrMapping/>
+  </p:clrMapOvr>
+</p:notes>
+</file>
+
+<file path=ppt/notesSlides/notesSlide13.xml><?xml version="1.0" encoding="utf-8"?>
+<p:notes xmlns:a="http://schemas.openxmlformats.org/drawingml/2006/main" xmlns:p="http://schemas.openxmlformats.org/presentationml/2006/main" xmlns:r="http://schemas.openxmlformats.org/officeDocument/2006/relationships">
+  <p:cSld>
+    <p:spTree>
+      <p:nvGrpSpPr>
+        <p:cNvPr id="1" name=""/>
+        <p:cNvGrpSpPr/>
+        <p:nvPr/>
+      </p:nvGrpSpPr>
+      <p:grpSpPr>
+        <a:xfrm>
+          <a:off x="0" y="0"/>
+          <a:ext cx="0" cy="0"/>
+          <a:chOff x="0" y="0"/>
+          <a:chExt cx="0" cy="0"/>
+        </a:xfrm>
+      </p:grpSpPr>
+      <p:sp>
+        <p:nvSpPr>
+          <p:cNvPr id="2" name="Slide Image Placeholder 1"/>
+          <p:cNvSpPr>
+            <a:spLocks noGrp="1"/>
+          </p:cNvSpPr>
+          <p:nvPr>
+            <p:ph type="sldImg" idx="2"/>
+          </p:nvPr>
+        </p:nvSpPr>
+        <p:spPr/>
+      </p:sp>
+      <p:sp>
+        <p:nvSpPr>
+          <p:cNvPr id="3" name="Notes Placeholder 2"/>
+          <p:cNvSpPr>
+            <a:spLocks noGrp="1"/>
+          </p:cNvSpPr>
+          <p:nvPr>
+            <p:ph type="body" idx="3" sz="quarter"/>
+          </p:nvPr>
+        </p:nvSpPr>
+        <p:spPr/>
+        <p:txBody>
+          <a:bodyPr/>
+          <a:lstStyle/>
+          <a:p>
+            <a:r>
               <a:t>Both. A takes NLP and IR questions, B takes engineering questions.</a:t>
             </a:r>
           </a:p>
@@ -1978,7 +2049,7 @@
           <a:lstStyle/>
           <a:p>
             <a:r>
-              <a:t>A. If asked whether the project failed because the reranker did not win: the comparison is the result, and it is measured and explained. Numbers from eval/report/ablations.md sections 1 and 1b, on the pre-labels; on the final labels the fused reranker is level with hybrid (previous slide).</a:t>
+              <a:t>A. Say first that these labels are a model's, not a human's, and why they exist: the gold set covers Twente only. Numbers from eval/report/silver.md. BM25's P@1 lead is not tested for significance there; the paired tests against the baseline are all non-significant.</a:t>
             </a:r>
           </a:p>
         </p:txBody>
@@ -2048,7 +2119,7 @@
           <a:lstStyle/>
           <a:p>
             <a:r>
-              <a:t>A. Without calibration the percentage is a display value and cannot be summed; the interface refuses the ECTS total for an uncalibrated strategy. Quote the estimate with positive label 1 and 2, the gap is the partial-match question.</a:t>
+              <a:t>A. If asked whether the project failed because the reranker did not win: the comparison is the result, and it is measured and explained. Numbers from eval/report/ablations.md sections 1 and 1b, on the pre-labels; on the final labels the fused reranker is level with hybrid (previous slide).</a:t>
             </a:r>
           </a:p>
         </p:txBody>
@@ -2118,7 +2189,7 @@
           <a:lstStyle/>
           <a:p>
             <a:r>
-              <a:t>B. frontend/src/lib/score.ts, the calibrated and provisional flags on GET /api/v1/strategies, and GET /api/v1/evaluation. The point: the numbers are only as good as the labels, and the interface never claims more than that.</a:t>
+              <a:t>A. Without calibration the percentage is a display value and cannot be summed; the interface refuses the ECTS total for an uncalibrated strategy. Quote the estimate with positive label 1 and 2, the gap is the partial-match question.</a:t>
             </a:r>
           </a:p>
         </p:txBody>
@@ -5892,7 +5963,7 @@
                 </a:solidFill>
                 <a:latin typeface="Cambria"/>
               </a:rPr>
-              <a:t>Where it goes wrong</a:t>
+              <a:t>An interface that does not overstate</a:t>
             </a:r>
           </a:p>
         </p:txBody>
@@ -5900,61 +5971,6 @@
       <p:sp>
         <p:nvSpPr>
           <p:cNvPr id="3" name="Rounded Rectangle 2"/>
-          <p:cNvSpPr/>
-          <p:nvPr/>
-        </p:nvSpPr>
-        <p:spPr>
-          <a:xfrm>
-            <a:off x="9464040" y="457200"/>
-            <a:ext cx="2194560" cy="384048"/>
-          </a:xfrm>
-          <a:prstGeom prst="roundRect">
-            <a:avLst>
-              <a:gd name="adj" fmla="val 12000"/>
-            </a:avLst>
-          </a:prstGeom>
-          <a:solidFill>
-            <a:srgbClr val="F2B705"/>
-          </a:solidFill>
-          <a:ln>
-            <a:noFill/>
-          </a:ln>
-          <a:effectLst/>
-        </p:spPr>
-        <p:style>
-          <a:lnRef idx="1">
-            <a:schemeClr val="accent1"/>
-          </a:lnRef>
-          <a:fillRef idx="3">
-            <a:schemeClr val="accent1"/>
-          </a:fillRef>
-          <a:effectRef idx="2">
-            <a:schemeClr val="accent1"/>
-          </a:effectRef>
-          <a:fontRef idx="minor">
-            <a:schemeClr val="lt1"/>
-          </a:fontRef>
-        </p:style>
-        <p:txBody>
-          <a:bodyPr rtlCol="0" anchor="ctr" tIns="0" bIns="0"/>
-          <a:lstStyle/>
-          <a:p>
-            <a:pPr algn="ctr"/>
-            <a:r>
-              <a:rPr sz="1200" b="1">
-                <a:solidFill>
-                  <a:srgbClr val="14234B"/>
-                </a:solidFill>
-                <a:latin typeface="Calibri"/>
-              </a:rPr>
-              <a:t>PARTLY MODEL-LABELLED</a:t>
-            </a:r>
-          </a:p>
-        </p:txBody>
-      </p:sp>
-      <p:sp>
-        <p:nvSpPr>
-          <p:cNvPr id="4" name="Rounded Rectangle 3"/>
           <p:cNvSpPr/>
           <p:nvPr/>
         </p:nvSpPr>
@@ -6000,7 +6016,7 @@
       </p:sp>
       <p:sp>
         <p:nvSpPr>
-          <p:cNvPr id="5" name="Oval 4"/>
+          <p:cNvPr id="4" name="Oval 3"/>
           <p:cNvSpPr/>
           <p:nvPr/>
         </p:nvSpPr>
@@ -6053,7 +6069,7 @@
       </p:sp>
       <p:sp>
         <p:nvSpPr>
-          <p:cNvPr id="6" name="TextBox 5"/>
+          <p:cNvPr id="5" name="TextBox 4"/>
           <p:cNvSpPr txBox="1"/>
           <p:nvPr/>
         </p:nvSpPr>
@@ -6085,14 +6101,14 @@
                 </a:solidFill>
                 <a:latin typeface="Cambria"/>
               </a:rPr>
-              <a:t>No equivalent exists</a:t>
-            </a:r>
-          </a:p>
-        </p:txBody>
-      </p:sp>
-      <p:sp>
-        <p:nvSpPr>
-          <p:cNvPr id="7" name="TextBox 6"/>
+              <a:t>Two kinds of score</a:t>
+            </a:r>
+          </a:p>
+        </p:txBody>
+      </p:sp>
+      <p:sp>
+        <p:nvSpPr>
+          <p:cNvPr id="6" name="TextBox 5"/>
           <p:cNvSpPr txBox="1"/>
           <p:nvPr/>
         </p:nvSpPr>
@@ -6124,14 +6140,14 @@
                 </a:solidFill>
                 <a:latin typeface="Calibri"/>
               </a:rPr>
-              <a:t>Algebra against a computer science catalogue still returns five candidates. Ranking cannot say none of these; a confidence floor can.</a:t>
-            </a:r>
-          </a:p>
-        </p:txBody>
-      </p:sp>
-      <p:sp>
-        <p:nvSpPr>
-          <p:cNvPr id="8" name="Rounded Rectangle 7"/>
+              <a:t>A calibrated strategy shows a percentage and a likely, borderline or unlikely band. The others show a bare relative number and a tooltip saying it is not a probability. One file formats every score.</a:t>
+            </a:r>
+          </a:p>
+        </p:txBody>
+      </p:sp>
+      <p:sp>
+        <p:nvSpPr>
+          <p:cNvPr id="7" name="Rounded Rectangle 6"/>
           <p:cNvSpPr/>
           <p:nvPr/>
         </p:nvSpPr>
@@ -6177,7 +6193,7 @@
       </p:sp>
       <p:sp>
         <p:nvSpPr>
-          <p:cNvPr id="9" name="Oval 8"/>
+          <p:cNvPr id="8" name="Oval 7"/>
           <p:cNvSpPr/>
           <p:nvPr/>
         </p:nvSpPr>
@@ -6230,7 +6246,7 @@
       </p:sp>
       <p:sp>
         <p:nvSpPr>
-          <p:cNvPr id="10" name="TextBox 9"/>
+          <p:cNvPr id="9" name="TextBox 8"/>
           <p:cNvSpPr txBox="1"/>
           <p:nvPr/>
         </p:nvSpPr>
@@ -6262,14 +6278,14 @@
                 </a:solidFill>
                 <a:latin typeface="Cambria"/>
               </a:rPr>
-              <a:t>Granularity</a:t>
-            </a:r>
-          </a:p>
-        </p:txBody>
-      </p:sp>
-      <p:sp>
-        <p:nvSpPr>
-          <p:cNvPr id="11" name="TextBox 10"/>
+              <a:t>No sum without a calibration</a:t>
+            </a:r>
+          </a:p>
+        </p:txBody>
+      </p:sp>
+      <p:sp>
+        <p:nvSpPr>
+          <p:cNvPr id="10" name="TextBox 9"/>
           <p:cNvSpPr txBox="1"/>
           <p:nvPr/>
         </p:nvSpPr>
@@ -6301,14 +6317,14 @@
                 </a:solidFill>
                 <a:latin typeface="Calibri"/>
               </a:rPr>
-              <a:t>The right answer is half of a 15 ECTS module, and the whole module description dilutes it.</a:t>
-            </a:r>
-          </a:p>
-        </p:txBody>
-      </p:sp>
-      <p:sp>
-        <p:nvSpPr>
-          <p:cNvPr id="12" name="Rounded Rectangle 11"/>
+              <a:t>The recognition panel will not add up ECTS for a strategy without a fitted calibration. Summing display values would be arithmetic on the wrong thing.</a:t>
+            </a:r>
+          </a:p>
+        </p:txBody>
+      </p:sp>
+      <p:sp>
+        <p:nvSpPr>
+          <p:cNvPr id="11" name="Rounded Rectangle 10"/>
           <p:cNvSpPr/>
           <p:nvPr/>
         </p:nvSpPr>
@@ -6354,7 +6370,7 @@
       </p:sp>
       <p:sp>
         <p:nvSpPr>
-          <p:cNvPr id="13" name="Oval 12"/>
+          <p:cNvPr id="12" name="Oval 11"/>
           <p:cNvSpPr/>
           <p:nvPr/>
         </p:nvSpPr>
@@ -6407,7 +6423,7 @@
       </p:sp>
       <p:sp>
         <p:nvSpPr>
-          <p:cNvPr id="14" name="TextBox 13"/>
+          <p:cNvPr id="13" name="TextBox 12"/>
           <p:cNvSpPr txBox="1"/>
           <p:nvPr/>
         </p:nvSpPr>
@@ -6439,14 +6455,14 @@
                 </a:solidFill>
                 <a:latin typeface="Cambria"/>
               </a:rPr>
-              <a:t>Look-alike projects</a:t>
-            </a:r>
-          </a:p>
-        </p:txBody>
-      </p:sp>
-      <p:sp>
-        <p:nvSpPr>
-          <p:cNvPr id="15" name="TextBox 14"/>
+              <a:t>Provisional says so</a:t>
+            </a:r>
+          </a:p>
+        </p:txBody>
+      </p:sp>
+      <p:sp>
+        <p:nvSpPr>
+          <p:cNvPr id="14" name="TextBox 13"/>
           <p:cNvSpPr txBox="1"/>
           <p:nvPr/>
         </p:nvSpPr>
@@ -6478,14 +6494,14 @@
                 </a:solidFill>
                 <a:latin typeface="Calibri"/>
               </a:rPr>
-              <a:t>Project courses read alike across a catalogue, so the text cannot separate them.</a:t>
-            </a:r>
-          </a:p>
-        </p:txBody>
-      </p:sp>
-      <p:sp>
-        <p:nvSpPr>
-          <p:cNvPr id="16" name="Rounded Rectangle 15"/>
+              <a:t>While a calibration rests on labels that are not all a person's, every probability and the ECTS estimate carry a warning. The flag is read from the calibration file, not typed into the interface.</a:t>
+            </a:r>
+          </a:p>
+        </p:txBody>
+      </p:sp>
+      <p:sp>
+        <p:nvSpPr>
+          <p:cNvPr id="15" name="Rounded Rectangle 14"/>
           <p:cNvSpPr/>
           <p:nvPr/>
         </p:nvSpPr>
@@ -6531,7 +6547,7 @@
       </p:sp>
       <p:sp>
         <p:nvSpPr>
-          <p:cNvPr id="17" name="Oval 16"/>
+          <p:cNvPr id="16" name="Oval 15"/>
           <p:cNvSpPr/>
           <p:nvPr/>
         </p:nvSpPr>
@@ -6584,7 +6600,7 @@
       </p:sp>
       <p:sp>
         <p:nvSpPr>
-          <p:cNvPr id="18" name="TextBox 17"/>
+          <p:cNvPr id="17" name="TextBox 16"/>
           <p:cNvSpPr txBox="1"/>
           <p:nvPr/>
         </p:nvSpPr>
@@ -6616,14 +6632,14 @@
                 </a:solidFill>
                 <a:latin typeface="Cambria"/>
               </a:rPr>
-              <a:t>Level in the title</a:t>
-            </a:r>
-          </a:p>
-        </p:txBody>
-      </p:sp>
-      <p:sp>
-        <p:nvSpPr>
-          <p:cNvPr id="19" name="TextBox 18"/>
+              <a:t>The evaluation page counts</a:t>
+            </a:r>
+          </a:p>
+        </p:txBody>
+      </p:sp>
+      <p:sp>
+        <p:nvSpPr>
+          <p:cNvPr id="18" name="TextBox 17"/>
           <p:cNvSpPr txBox="1"/>
           <p:nvPr/>
         </p:nvSpPr>
@@ -6655,7 +6671,7 @@
                 </a:solidFill>
                 <a:latin typeface="Calibri"/>
               </a:rPr>
-              <a:t>Modelling and Programming 3 outranks 1: the sequence number is kept out of the embedding by design (ADR-0004).</a:t>
+              <a:t>It says how many of the 1142 gold labels a person gave (680) and how many a second model gave (462), instead of calling them all checked.</a:t>
             </a:r>
           </a:p>
         </p:txBody>
@@ -6720,7 +6736,7 @@
                 </a:solidFill>
                 <a:latin typeface="Cambria"/>
               </a:rPr>
-              <a:t>Engineering choices</a:t>
+              <a:t>Where it goes wrong</a:t>
             </a:r>
           </a:p>
         </p:txBody>
@@ -6733,8 +6749,63 @@
         </p:nvSpPr>
         <p:spPr>
           <a:xfrm>
+            <a:off x="9464040" y="457200"/>
+            <a:ext cx="2194560" cy="384048"/>
+          </a:xfrm>
+          <a:prstGeom prst="roundRect">
+            <a:avLst>
+              <a:gd name="adj" fmla="val 12000"/>
+            </a:avLst>
+          </a:prstGeom>
+          <a:solidFill>
+            <a:srgbClr val="F2B705"/>
+          </a:solidFill>
+          <a:ln>
+            <a:noFill/>
+          </a:ln>
+          <a:effectLst/>
+        </p:spPr>
+        <p:style>
+          <a:lnRef idx="1">
+            <a:schemeClr val="accent1"/>
+          </a:lnRef>
+          <a:fillRef idx="3">
+            <a:schemeClr val="accent1"/>
+          </a:fillRef>
+          <a:effectRef idx="2">
+            <a:schemeClr val="accent1"/>
+          </a:effectRef>
+          <a:fontRef idx="minor">
+            <a:schemeClr val="lt1"/>
+          </a:fontRef>
+        </p:style>
+        <p:txBody>
+          <a:bodyPr rtlCol="0" anchor="ctr" tIns="0" bIns="0"/>
+          <a:lstStyle/>
+          <a:p>
+            <a:pPr algn="ctr"/>
+            <a:r>
+              <a:rPr sz="1200" b="1">
+                <a:solidFill>
+                  <a:srgbClr val="14234B"/>
+                </a:solidFill>
+                <a:latin typeface="Calibri"/>
+              </a:rPr>
+              <a:t>PARTLY MODEL-LABELLED</a:t>
+            </a:r>
+          </a:p>
+        </p:txBody>
+      </p:sp>
+      <p:sp>
+        <p:nvSpPr>
+          <p:cNvPr id="4" name="Rounded Rectangle 3"/>
+          <p:cNvSpPr/>
+          <p:nvPr/>
+        </p:nvSpPr>
+        <p:spPr>
+          <a:xfrm>
             <a:off x="548640" y="1463040"/>
-            <a:ext cx="11064240" cy="960120"/>
+            <a:ext cx="5394960" cy="2103120"/>
           </a:xfrm>
           <a:prstGeom prst="roundRect">
             <a:avLst>
@@ -6773,14 +6844,67 @@
       </p:sp>
       <p:sp>
         <p:nvSpPr>
-          <p:cNvPr id="4" name="TextBox 3"/>
+          <p:cNvPr id="5" name="Oval 4"/>
+          <p:cNvSpPr/>
+          <p:nvPr/>
+        </p:nvSpPr>
+        <p:spPr>
+          <a:xfrm>
+            <a:off x="822960" y="1737360"/>
+            <a:ext cx="502920" cy="502920"/>
+          </a:xfrm>
+          <a:prstGeom prst="ellipse">
+            <a:avLst/>
+          </a:prstGeom>
+          <a:solidFill>
+            <a:srgbClr val="14234B"/>
+          </a:solidFill>
+          <a:ln>
+            <a:noFill/>
+          </a:ln>
+          <a:effectLst/>
+        </p:spPr>
+        <p:style>
+          <a:lnRef idx="1">
+            <a:schemeClr val="accent1"/>
+          </a:lnRef>
+          <a:fillRef idx="3">
+            <a:schemeClr val="accent1"/>
+          </a:fillRef>
+          <a:effectRef idx="2">
+            <a:schemeClr val="accent1"/>
+          </a:effectRef>
+          <a:fontRef idx="minor">
+            <a:schemeClr val="lt1"/>
+          </a:fontRef>
+        </p:style>
+        <p:txBody>
+          <a:bodyPr rtlCol="0" anchor="ctr" lIns="0" rIns="0" tIns="0" bIns="0"/>
+          <a:lstStyle/>
+          <a:p>
+            <a:pPr algn="ctr"/>
+            <a:r>
+              <a:rPr sz="1800" b="1">
+                <a:solidFill>
+                  <a:srgbClr val="FFFFFF"/>
+                </a:solidFill>
+                <a:latin typeface="Cambria"/>
+              </a:rPr>
+              <a:t>1</a:t>
+            </a:r>
+          </a:p>
+        </p:txBody>
+      </p:sp>
+      <p:sp>
+        <p:nvSpPr>
+          <p:cNvPr id="6" name="TextBox 5"/>
           <p:cNvSpPr txBox="1"/>
           <p:nvPr/>
         </p:nvSpPr>
         <p:spPr>
           <a:xfrm>
-            <a:off x="822960" y="1554480"/>
-            <a:ext cx="3017520" cy="777240"/>
+            <a:off x="1554480" y="1764792"/>
+            <a:ext cx="4114800" cy="457200"/>
           </a:xfrm>
           <a:prstGeom prst="rect">
             <a:avLst/>
@@ -6788,7 +6912,7 @@
           <a:noFill/>
         </p:spPr>
         <p:txBody>
-          <a:bodyPr wrap="square" anchor="ctr" lIns="0" rIns="0" tIns="0" bIns="0">
+          <a:bodyPr wrap="square" anchor="t" lIns="0" rIns="0" tIns="0" bIns="0">
             <a:spAutoFit/>
           </a:bodyPr>
           <a:lstStyle/>
@@ -6805,21 +6929,21 @@
                 </a:solidFill>
                 <a:latin typeface="Cambria"/>
               </a:rPr>
-              <a:t>Frozen contract</a:t>
-            </a:r>
-          </a:p>
-        </p:txBody>
-      </p:sp>
-      <p:sp>
-        <p:nvSpPr>
-          <p:cNvPr id="5" name="TextBox 4"/>
+              <a:t>No equivalent exists</a:t>
+            </a:r>
+          </a:p>
+        </p:txBody>
+      </p:sp>
+      <p:sp>
+        <p:nvSpPr>
+          <p:cNvPr id="7" name="TextBox 6"/>
           <p:cNvSpPr txBox="1"/>
           <p:nvPr/>
         </p:nvSpPr>
         <p:spPr>
           <a:xfrm>
-            <a:off x="3931920" y="1554480"/>
-            <a:ext cx="7498079" cy="777240"/>
+            <a:off x="1554480" y="2286000"/>
+            <a:ext cx="4114800" cy="1188720"/>
           </a:xfrm>
           <a:prstGeom prst="rect">
             <a:avLst/>
@@ -6827,7 +6951,7 @@
           <a:noFill/>
         </p:spPr>
         <p:txBody>
-          <a:bodyPr wrap="square" anchor="ctr" lIns="0" rIns="0" tIns="0" bIns="0">
+          <a:bodyPr wrap="square" anchor="t" lIns="0" rIns="0" tIns="0" bIns="0">
             <a:spAutoFit/>
           </a:bodyPr>
           <a:lstStyle/>
@@ -6838,27 +6962,27 @@
               </a:spcAft>
             </a:pPr>
             <a:r>
-              <a:rPr sz="1500" b="0" i="0">
+              <a:rPr sz="1400" b="0" i="0">
                 <a:solidFill>
                   <a:srgbClr val="1F2433"/>
                 </a:solidFill>
                 <a:latin typeface="Calibri"/>
               </a:rPr>
-              <a:t>A Matcher protocol and a stub let the interface and the engine be built in parallel from day one.</a:t>
-            </a:r>
-          </a:p>
-        </p:txBody>
-      </p:sp>
-      <p:sp>
-        <p:nvSpPr>
-          <p:cNvPr id="6" name="Rounded Rectangle 5"/>
+              <a:t>Algebra against a computer science catalogue still returns five candidates. Ranking cannot say none of these; a confidence floor can.</a:t>
+            </a:r>
+          </a:p>
+        </p:txBody>
+      </p:sp>
+      <p:sp>
+        <p:nvSpPr>
+          <p:cNvPr id="8" name="Rounded Rectangle 7"/>
           <p:cNvSpPr/>
           <p:nvPr/>
         </p:nvSpPr>
         <p:spPr>
           <a:xfrm>
-            <a:off x="548640" y="2651760"/>
-            <a:ext cx="11064240" cy="960120"/>
+            <a:off x="6217920" y="1463040"/>
+            <a:ext cx="5394960" cy="2103120"/>
           </a:xfrm>
           <a:prstGeom prst="roundRect">
             <a:avLst>
@@ -6897,14 +7021,67 @@
       </p:sp>
       <p:sp>
         <p:nvSpPr>
-          <p:cNvPr id="7" name="TextBox 6"/>
+          <p:cNvPr id="9" name="Oval 8"/>
+          <p:cNvSpPr/>
+          <p:nvPr/>
+        </p:nvSpPr>
+        <p:spPr>
+          <a:xfrm>
+            <a:off x="6492240" y="1737360"/>
+            <a:ext cx="502920" cy="502920"/>
+          </a:xfrm>
+          <a:prstGeom prst="ellipse">
+            <a:avLst/>
+          </a:prstGeom>
+          <a:solidFill>
+            <a:srgbClr val="14234B"/>
+          </a:solidFill>
+          <a:ln>
+            <a:noFill/>
+          </a:ln>
+          <a:effectLst/>
+        </p:spPr>
+        <p:style>
+          <a:lnRef idx="1">
+            <a:schemeClr val="accent1"/>
+          </a:lnRef>
+          <a:fillRef idx="3">
+            <a:schemeClr val="accent1"/>
+          </a:fillRef>
+          <a:effectRef idx="2">
+            <a:schemeClr val="accent1"/>
+          </a:effectRef>
+          <a:fontRef idx="minor">
+            <a:schemeClr val="lt1"/>
+          </a:fontRef>
+        </p:style>
+        <p:txBody>
+          <a:bodyPr rtlCol="0" anchor="ctr" lIns="0" rIns="0" tIns="0" bIns="0"/>
+          <a:lstStyle/>
+          <a:p>
+            <a:pPr algn="ctr"/>
+            <a:r>
+              <a:rPr sz="1800" b="1">
+                <a:solidFill>
+                  <a:srgbClr val="FFFFFF"/>
+                </a:solidFill>
+                <a:latin typeface="Cambria"/>
+              </a:rPr>
+              <a:t>2</a:t>
+            </a:r>
+          </a:p>
+        </p:txBody>
+      </p:sp>
+      <p:sp>
+        <p:nvSpPr>
+          <p:cNvPr id="10" name="TextBox 9"/>
           <p:cNvSpPr txBox="1"/>
           <p:nvPr/>
         </p:nvSpPr>
         <p:spPr>
           <a:xfrm>
-            <a:off x="822960" y="2743200"/>
-            <a:ext cx="3017520" cy="777240"/>
+            <a:off x="7223760" y="1764792"/>
+            <a:ext cx="4114800" cy="457200"/>
           </a:xfrm>
           <a:prstGeom prst="rect">
             <a:avLst/>
@@ -6912,7 +7089,7 @@
           <a:noFill/>
         </p:spPr>
         <p:txBody>
-          <a:bodyPr wrap="square" anchor="ctr" lIns="0" rIns="0" tIns="0" bIns="0">
+          <a:bodyPr wrap="square" anchor="t" lIns="0" rIns="0" tIns="0" bIns="0">
             <a:spAutoFit/>
           </a:bodyPr>
           <a:lstStyle/>
@@ -6929,21 +7106,21 @@
                 </a:solidFill>
                 <a:latin typeface="Cambria"/>
               </a:rPr>
-              <a:t>Offline by design</a:t>
-            </a:r>
-          </a:p>
-        </p:txBody>
-      </p:sp>
-      <p:sp>
-        <p:nvSpPr>
-          <p:cNvPr id="8" name="TextBox 7"/>
+              <a:t>Granularity</a:t>
+            </a:r>
+          </a:p>
+        </p:txBody>
+      </p:sp>
+      <p:sp>
+        <p:nvSpPr>
+          <p:cNvPr id="11" name="TextBox 10"/>
           <p:cNvSpPr txBox="1"/>
           <p:nvPr/>
         </p:nvSpPr>
         <p:spPr>
           <a:xfrm>
-            <a:off x="3931920" y="2743200"/>
-            <a:ext cx="7498079" cy="777240"/>
+            <a:off x="7223760" y="2286000"/>
+            <a:ext cx="4114800" cy="1188720"/>
           </a:xfrm>
           <a:prstGeom prst="rect">
             <a:avLst/>
@@ -6951,7 +7128,7 @@
           <a:noFill/>
         </p:spPr>
         <p:txBody>
-          <a:bodyPr wrap="square" anchor="ctr" lIns="0" rIns="0" tIns="0" bIns="0">
+          <a:bodyPr wrap="square" anchor="t" lIns="0" rIns="0" tIns="0" bIns="0">
             <a:spAutoFit/>
           </a:bodyPr>
           <a:lstStyle/>
@@ -6962,27 +7139,27 @@
               </a:spcAft>
             </a:pPr>
             <a:r>
-              <a:rPr sz="1500" b="0" i="0">
+              <a:rPr sz="1400" b="0" i="0">
                 <a:solidFill>
                   <a:srgbClr val="1F2433"/>
                 </a:solidFill>
                 <a:latin typeface="Calibri"/>
               </a:rPr>
-              <a:t>Models baked into the image at build time; the runtime never touches the network.</a:t>
-            </a:r>
-          </a:p>
-        </p:txBody>
-      </p:sp>
-      <p:sp>
-        <p:nvSpPr>
-          <p:cNvPr id="9" name="Rounded Rectangle 8"/>
+              <a:t>The right answer is half of a 15 ECTS module, and the whole module description dilutes it.</a:t>
+            </a:r>
+          </a:p>
+        </p:txBody>
+      </p:sp>
+      <p:sp>
+        <p:nvSpPr>
+          <p:cNvPr id="12" name="Rounded Rectangle 11"/>
           <p:cNvSpPr/>
           <p:nvPr/>
         </p:nvSpPr>
         <p:spPr>
           <a:xfrm>
             <a:off x="548640" y="3840480"/>
-            <a:ext cx="11064240" cy="960120"/>
+            <a:ext cx="5394960" cy="2103120"/>
           </a:xfrm>
           <a:prstGeom prst="roundRect">
             <a:avLst>
@@ -7021,14 +7198,67 @@
       </p:sp>
       <p:sp>
         <p:nvSpPr>
-          <p:cNvPr id="10" name="TextBox 9"/>
+          <p:cNvPr id="13" name="Oval 12"/>
+          <p:cNvSpPr/>
+          <p:nvPr/>
+        </p:nvSpPr>
+        <p:spPr>
+          <a:xfrm>
+            <a:off x="822960" y="4114800"/>
+            <a:ext cx="502920" cy="502920"/>
+          </a:xfrm>
+          <a:prstGeom prst="ellipse">
+            <a:avLst/>
+          </a:prstGeom>
+          <a:solidFill>
+            <a:srgbClr val="14234B"/>
+          </a:solidFill>
+          <a:ln>
+            <a:noFill/>
+          </a:ln>
+          <a:effectLst/>
+        </p:spPr>
+        <p:style>
+          <a:lnRef idx="1">
+            <a:schemeClr val="accent1"/>
+          </a:lnRef>
+          <a:fillRef idx="3">
+            <a:schemeClr val="accent1"/>
+          </a:fillRef>
+          <a:effectRef idx="2">
+            <a:schemeClr val="accent1"/>
+          </a:effectRef>
+          <a:fontRef idx="minor">
+            <a:schemeClr val="lt1"/>
+          </a:fontRef>
+        </p:style>
+        <p:txBody>
+          <a:bodyPr rtlCol="0" anchor="ctr" lIns="0" rIns="0" tIns="0" bIns="0"/>
+          <a:lstStyle/>
+          <a:p>
+            <a:pPr algn="ctr"/>
+            <a:r>
+              <a:rPr sz="1800" b="1">
+                <a:solidFill>
+                  <a:srgbClr val="FFFFFF"/>
+                </a:solidFill>
+                <a:latin typeface="Cambria"/>
+              </a:rPr>
+              <a:t>3</a:t>
+            </a:r>
+          </a:p>
+        </p:txBody>
+      </p:sp>
+      <p:sp>
+        <p:nvSpPr>
+          <p:cNvPr id="14" name="TextBox 13"/>
           <p:cNvSpPr txBox="1"/>
           <p:nvPr/>
         </p:nvSpPr>
         <p:spPr>
           <a:xfrm>
-            <a:off x="822960" y="3931920"/>
-            <a:ext cx="3017520" cy="777240"/>
+            <a:off x="1554480" y="4142232"/>
+            <a:ext cx="4114800" cy="457200"/>
           </a:xfrm>
           <a:prstGeom prst="rect">
             <a:avLst/>
@@ -7036,7 +7266,7 @@
           <a:noFill/>
         </p:spPr>
         <p:txBody>
-          <a:bodyPr wrap="square" anchor="ctr" lIns="0" rIns="0" tIns="0" bIns="0">
+          <a:bodyPr wrap="square" anchor="t" lIns="0" rIns="0" tIns="0" bIns="0">
             <a:spAutoFit/>
           </a:bodyPr>
           <a:lstStyle/>
@@ -7053,21 +7283,21 @@
                 </a:solidFill>
                 <a:latin typeface="Cambria"/>
               </a:rPr>
-              <a:t>SQLite</a:t>
-            </a:r>
-          </a:p>
-        </p:txBody>
-      </p:sp>
-      <p:sp>
-        <p:nvSpPr>
-          <p:cNvPr id="11" name="TextBox 10"/>
+              <a:t>Look-alike projects</a:t>
+            </a:r>
+          </a:p>
+        </p:txBody>
+      </p:sp>
+      <p:sp>
+        <p:nvSpPr>
+          <p:cNvPr id="15" name="TextBox 14"/>
           <p:cNvSpPr txBox="1"/>
           <p:nvPr/>
         </p:nvSpPr>
         <p:spPr>
           <a:xfrm>
-            <a:off x="3931920" y="3931920"/>
-            <a:ext cx="7498079" cy="777240"/>
+            <a:off x="1554480" y="4663440"/>
+            <a:ext cx="4114800" cy="1188720"/>
           </a:xfrm>
           <a:prstGeom prst="rect">
             <a:avLst/>
@@ -7075,7 +7305,7 @@
           <a:noFill/>
         </p:spPr>
         <p:txBody>
-          <a:bodyPr wrap="square" anchor="ctr" lIns="0" rIns="0" tIns="0" bIns="0">
+          <a:bodyPr wrap="square" anchor="t" lIns="0" rIns="0" tIns="0" bIns="0">
             <a:spAutoFit/>
           </a:bodyPr>
           <a:lstStyle/>
@@ -7086,27 +7316,27 @@
               </a:spcAft>
             </a:pPr>
             <a:r>
-              <a:rPr sz="1500" b="0" i="0">
+              <a:rPr sz="1400" b="0" i="0">
                 <a:solidFill>
                   <a:srgbClr val="1F2433"/>
                 </a:solidFill>
                 <a:latin typeface="Calibri"/>
               </a:rPr>
-              <a:t>A few hundred courses: one file in a volume keeps compose to two services.</a:t>
-            </a:r>
-          </a:p>
-        </p:txBody>
-      </p:sp>
-      <p:sp>
-        <p:nvSpPr>
-          <p:cNvPr id="12" name="Rounded Rectangle 11"/>
+              <a:t>Project courses read alike across a catalogue, so the text cannot separate them.</a:t>
+            </a:r>
+          </a:p>
+        </p:txBody>
+      </p:sp>
+      <p:sp>
+        <p:nvSpPr>
+          <p:cNvPr id="16" name="Rounded Rectangle 15"/>
           <p:cNvSpPr/>
           <p:nvPr/>
         </p:nvSpPr>
         <p:spPr>
           <a:xfrm>
-            <a:off x="548640" y="5029200"/>
-            <a:ext cx="11064240" cy="960120"/>
+            <a:off x="6217920" y="3840480"/>
+            <a:ext cx="5394960" cy="2103120"/>
           </a:xfrm>
           <a:prstGeom prst="roundRect">
             <a:avLst>
@@ -7145,14 +7375,67 @@
       </p:sp>
       <p:sp>
         <p:nvSpPr>
-          <p:cNvPr id="13" name="TextBox 12"/>
+          <p:cNvPr id="17" name="Oval 16"/>
+          <p:cNvSpPr/>
+          <p:nvPr/>
+        </p:nvSpPr>
+        <p:spPr>
+          <a:xfrm>
+            <a:off x="6492240" y="4114800"/>
+            <a:ext cx="502920" cy="502920"/>
+          </a:xfrm>
+          <a:prstGeom prst="ellipse">
+            <a:avLst/>
+          </a:prstGeom>
+          <a:solidFill>
+            <a:srgbClr val="14234B"/>
+          </a:solidFill>
+          <a:ln>
+            <a:noFill/>
+          </a:ln>
+          <a:effectLst/>
+        </p:spPr>
+        <p:style>
+          <a:lnRef idx="1">
+            <a:schemeClr val="accent1"/>
+          </a:lnRef>
+          <a:fillRef idx="3">
+            <a:schemeClr val="accent1"/>
+          </a:fillRef>
+          <a:effectRef idx="2">
+            <a:schemeClr val="accent1"/>
+          </a:effectRef>
+          <a:fontRef idx="minor">
+            <a:schemeClr val="lt1"/>
+          </a:fontRef>
+        </p:style>
+        <p:txBody>
+          <a:bodyPr rtlCol="0" anchor="ctr" lIns="0" rIns="0" tIns="0" bIns="0"/>
+          <a:lstStyle/>
+          <a:p>
+            <a:pPr algn="ctr"/>
+            <a:r>
+              <a:rPr sz="1800" b="1">
+                <a:solidFill>
+                  <a:srgbClr val="FFFFFF"/>
+                </a:solidFill>
+                <a:latin typeface="Cambria"/>
+              </a:rPr>
+              <a:t>4</a:t>
+            </a:r>
+          </a:p>
+        </p:txBody>
+      </p:sp>
+      <p:sp>
+        <p:nvSpPr>
+          <p:cNvPr id="18" name="TextBox 17"/>
           <p:cNvSpPr txBox="1"/>
           <p:nvPr/>
         </p:nvSpPr>
         <p:spPr>
           <a:xfrm>
-            <a:off x="822960" y="5120640"/>
-            <a:ext cx="3017520" cy="777240"/>
+            <a:off x="7223760" y="4142232"/>
+            <a:ext cx="4114800" cy="457200"/>
           </a:xfrm>
           <a:prstGeom prst="rect">
             <a:avLst/>
@@ -7160,7 +7443,7 @@
           <a:noFill/>
         </p:spPr>
         <p:txBody>
-          <a:bodyPr wrap="square" anchor="ctr" lIns="0" rIns="0" tIns="0" bIns="0">
+          <a:bodyPr wrap="square" anchor="t" lIns="0" rIns="0" tIns="0" bIns="0">
             <a:spAutoFit/>
           </a:bodyPr>
           <a:lstStyle/>
@@ -7177,21 +7460,21 @@
                 </a:solidFill>
                 <a:latin typeface="Cambria"/>
               </a:rPr>
-              <a:t>Clean-machine build</a:t>
-            </a:r>
-          </a:p>
-        </p:txBody>
-      </p:sp>
-      <p:sp>
-        <p:nvSpPr>
-          <p:cNvPr id="14" name="TextBox 13"/>
+              <a:t>Level in the title</a:t>
+            </a:r>
+          </a:p>
+        </p:txBody>
+      </p:sp>
+      <p:sp>
+        <p:nvSpPr>
+          <p:cNvPr id="19" name="TextBox 18"/>
           <p:cNvSpPr txBox="1"/>
           <p:nvPr/>
         </p:nvSpPr>
         <p:spPr>
           <a:xfrm>
-            <a:off x="3931920" y="5120640"/>
-            <a:ext cx="7498079" cy="777240"/>
+            <a:off x="7223760" y="4663440"/>
+            <a:ext cx="4114800" cy="1188720"/>
           </a:xfrm>
           <a:prstGeom prst="rect">
             <a:avLst/>
@@ -7199,7 +7482,7 @@
           <a:noFill/>
         </p:spPr>
         <p:txBody>
-          <a:bodyPr wrap="square" anchor="ctr" lIns="0" rIns="0" tIns="0" bIns="0">
+          <a:bodyPr wrap="square" anchor="t" lIns="0" rIns="0" tIns="0" bIns="0">
             <a:spAutoFit/>
           </a:bodyPr>
           <a:lstStyle/>
@@ -7210,13 +7493,13 @@
               </a:spcAft>
             </a:pPr>
             <a:r>
-              <a:rPr sz="1500" b="0" i="0">
+              <a:rPr sz="1400" b="0" i="0">
                 <a:solidFill>
                   <a:srgbClr val="1F2433"/>
                 </a:solidFill>
                 <a:latin typeface="Calibri"/>
               </a:rPr>
-              <a:t>Fresh clone to running app measured at 297 s, recorded in the README.</a:t>
+              <a:t>Modelling and Programming 3 outranks 1: the sequence number is kept out of the embedding by design (ADR-0004).</a:t>
             </a:r>
           </a:p>
         </p:txBody>
@@ -7230,6 +7513,567 @@
 </file>
 
 <file path=ppt/slides/slide12.xml><?xml version="1.0" encoding="utf-8"?>
+<p:sld xmlns:a="http://schemas.openxmlformats.org/drawingml/2006/main" xmlns:p="http://schemas.openxmlformats.org/presentationml/2006/main" xmlns:r="http://schemas.openxmlformats.org/officeDocument/2006/relationships">
+  <p:cSld>
+    <p:bg>
+      <p:bgPr>
+        <a:solidFill>
+          <a:srgbClr val="FFFFFF"/>
+        </a:solidFill>
+        <a:effectLst/>
+      </p:bgPr>
+    </p:bg>
+    <p:spTree>
+      <p:nvGrpSpPr>
+        <p:cNvPr id="1" name=""/>
+        <p:cNvGrpSpPr/>
+        <p:nvPr/>
+      </p:nvGrpSpPr>
+      <p:grpSpPr/>
+      <p:sp>
+        <p:nvSpPr>
+          <p:cNvPr id="2" name="TextBox 1"/>
+          <p:cNvSpPr txBox="1"/>
+          <p:nvPr/>
+        </p:nvSpPr>
+        <p:spPr>
+          <a:xfrm>
+            <a:off x="548640" y="411480"/>
+            <a:ext cx="11064240" cy="822960"/>
+          </a:xfrm>
+          <a:prstGeom prst="rect">
+            <a:avLst/>
+          </a:prstGeom>
+          <a:noFill/>
+        </p:spPr>
+        <p:txBody>
+          <a:bodyPr wrap="square" anchor="t" lIns="0" rIns="0" tIns="0" bIns="0">
+            <a:spAutoFit/>
+          </a:bodyPr>
+          <a:lstStyle/>
+          <a:p>
+            <a:pPr algn="l">
+              <a:spcAft>
+                <a:spcPts val="800"/>
+              </a:spcAft>
+            </a:pPr>
+            <a:r>
+              <a:rPr sz="3600" b="1" i="0">
+                <a:solidFill>
+                  <a:srgbClr val="14234B"/>
+                </a:solidFill>
+                <a:latin typeface="Cambria"/>
+              </a:rPr>
+              <a:t>Engineering choices</a:t>
+            </a:r>
+          </a:p>
+        </p:txBody>
+      </p:sp>
+      <p:sp>
+        <p:nvSpPr>
+          <p:cNvPr id="3" name="Rounded Rectangle 2"/>
+          <p:cNvSpPr/>
+          <p:nvPr/>
+        </p:nvSpPr>
+        <p:spPr>
+          <a:xfrm>
+            <a:off x="548640" y="1463040"/>
+            <a:ext cx="11064240" cy="960120"/>
+          </a:xfrm>
+          <a:prstGeom prst="roundRect">
+            <a:avLst>
+              <a:gd name="adj" fmla="val 12000"/>
+            </a:avLst>
+          </a:prstGeom>
+          <a:solidFill>
+            <a:srgbClr val="EEF1F8"/>
+          </a:solidFill>
+          <a:ln>
+            <a:noFill/>
+          </a:ln>
+          <a:effectLst/>
+        </p:spPr>
+        <p:style>
+          <a:lnRef idx="1">
+            <a:schemeClr val="accent1"/>
+          </a:lnRef>
+          <a:fillRef idx="3">
+            <a:schemeClr val="accent1"/>
+          </a:fillRef>
+          <a:effectRef idx="2">
+            <a:schemeClr val="accent1"/>
+          </a:effectRef>
+          <a:fontRef idx="minor">
+            <a:schemeClr val="lt1"/>
+          </a:fontRef>
+        </p:style>
+        <p:txBody>
+          <a:bodyPr rtlCol="0" anchor="ctr"/>
+          <a:lstStyle/>
+          <a:p>
+            <a:pPr algn="ctr"/>
+          </a:p>
+        </p:txBody>
+      </p:sp>
+      <p:sp>
+        <p:nvSpPr>
+          <p:cNvPr id="4" name="TextBox 3"/>
+          <p:cNvSpPr txBox="1"/>
+          <p:nvPr/>
+        </p:nvSpPr>
+        <p:spPr>
+          <a:xfrm>
+            <a:off x="822960" y="1554480"/>
+            <a:ext cx="3017520" cy="777240"/>
+          </a:xfrm>
+          <a:prstGeom prst="rect">
+            <a:avLst/>
+          </a:prstGeom>
+          <a:noFill/>
+        </p:spPr>
+        <p:txBody>
+          <a:bodyPr wrap="square" anchor="ctr" lIns="0" rIns="0" tIns="0" bIns="0">
+            <a:spAutoFit/>
+          </a:bodyPr>
+          <a:lstStyle/>
+          <a:p>
+            <a:pPr algn="l">
+              <a:spcAft>
+                <a:spcPts val="800"/>
+              </a:spcAft>
+            </a:pPr>
+            <a:r>
+              <a:rPr sz="1800" b="1" i="0">
+                <a:solidFill>
+                  <a:srgbClr val="14234B"/>
+                </a:solidFill>
+                <a:latin typeface="Cambria"/>
+              </a:rPr>
+              <a:t>Frozen contract</a:t>
+            </a:r>
+          </a:p>
+        </p:txBody>
+      </p:sp>
+      <p:sp>
+        <p:nvSpPr>
+          <p:cNvPr id="5" name="TextBox 4"/>
+          <p:cNvSpPr txBox="1"/>
+          <p:nvPr/>
+        </p:nvSpPr>
+        <p:spPr>
+          <a:xfrm>
+            <a:off x="3931920" y="1554480"/>
+            <a:ext cx="7498079" cy="777240"/>
+          </a:xfrm>
+          <a:prstGeom prst="rect">
+            <a:avLst/>
+          </a:prstGeom>
+          <a:noFill/>
+        </p:spPr>
+        <p:txBody>
+          <a:bodyPr wrap="square" anchor="ctr" lIns="0" rIns="0" tIns="0" bIns="0">
+            <a:spAutoFit/>
+          </a:bodyPr>
+          <a:lstStyle/>
+          <a:p>
+            <a:pPr algn="l">
+              <a:spcAft>
+                <a:spcPts val="800"/>
+              </a:spcAft>
+            </a:pPr>
+            <a:r>
+              <a:rPr sz="1500" b="0" i="0">
+                <a:solidFill>
+                  <a:srgbClr val="1F2433"/>
+                </a:solidFill>
+                <a:latin typeface="Calibri"/>
+              </a:rPr>
+              <a:t>A Matcher protocol and a stub let the interface and the engine be built in parallel from day one.</a:t>
+            </a:r>
+          </a:p>
+        </p:txBody>
+      </p:sp>
+      <p:sp>
+        <p:nvSpPr>
+          <p:cNvPr id="6" name="Rounded Rectangle 5"/>
+          <p:cNvSpPr/>
+          <p:nvPr/>
+        </p:nvSpPr>
+        <p:spPr>
+          <a:xfrm>
+            <a:off x="548640" y="2651760"/>
+            <a:ext cx="11064240" cy="960120"/>
+          </a:xfrm>
+          <a:prstGeom prst="roundRect">
+            <a:avLst>
+              <a:gd name="adj" fmla="val 12000"/>
+            </a:avLst>
+          </a:prstGeom>
+          <a:solidFill>
+            <a:srgbClr val="EEF1F8"/>
+          </a:solidFill>
+          <a:ln>
+            <a:noFill/>
+          </a:ln>
+          <a:effectLst/>
+        </p:spPr>
+        <p:style>
+          <a:lnRef idx="1">
+            <a:schemeClr val="accent1"/>
+          </a:lnRef>
+          <a:fillRef idx="3">
+            <a:schemeClr val="accent1"/>
+          </a:fillRef>
+          <a:effectRef idx="2">
+            <a:schemeClr val="accent1"/>
+          </a:effectRef>
+          <a:fontRef idx="minor">
+            <a:schemeClr val="lt1"/>
+          </a:fontRef>
+        </p:style>
+        <p:txBody>
+          <a:bodyPr rtlCol="0" anchor="ctr"/>
+          <a:lstStyle/>
+          <a:p>
+            <a:pPr algn="ctr"/>
+          </a:p>
+        </p:txBody>
+      </p:sp>
+      <p:sp>
+        <p:nvSpPr>
+          <p:cNvPr id="7" name="TextBox 6"/>
+          <p:cNvSpPr txBox="1"/>
+          <p:nvPr/>
+        </p:nvSpPr>
+        <p:spPr>
+          <a:xfrm>
+            <a:off x="822960" y="2743200"/>
+            <a:ext cx="3017520" cy="777240"/>
+          </a:xfrm>
+          <a:prstGeom prst="rect">
+            <a:avLst/>
+          </a:prstGeom>
+          <a:noFill/>
+        </p:spPr>
+        <p:txBody>
+          <a:bodyPr wrap="square" anchor="ctr" lIns="0" rIns="0" tIns="0" bIns="0">
+            <a:spAutoFit/>
+          </a:bodyPr>
+          <a:lstStyle/>
+          <a:p>
+            <a:pPr algn="l">
+              <a:spcAft>
+                <a:spcPts val="800"/>
+              </a:spcAft>
+            </a:pPr>
+            <a:r>
+              <a:rPr sz="1800" b="1" i="0">
+                <a:solidFill>
+                  <a:srgbClr val="14234B"/>
+                </a:solidFill>
+                <a:latin typeface="Cambria"/>
+              </a:rPr>
+              <a:t>Offline by design</a:t>
+            </a:r>
+          </a:p>
+        </p:txBody>
+      </p:sp>
+      <p:sp>
+        <p:nvSpPr>
+          <p:cNvPr id="8" name="TextBox 7"/>
+          <p:cNvSpPr txBox="1"/>
+          <p:nvPr/>
+        </p:nvSpPr>
+        <p:spPr>
+          <a:xfrm>
+            <a:off x="3931920" y="2743200"/>
+            <a:ext cx="7498079" cy="777240"/>
+          </a:xfrm>
+          <a:prstGeom prst="rect">
+            <a:avLst/>
+          </a:prstGeom>
+          <a:noFill/>
+        </p:spPr>
+        <p:txBody>
+          <a:bodyPr wrap="square" anchor="ctr" lIns="0" rIns="0" tIns="0" bIns="0">
+            <a:spAutoFit/>
+          </a:bodyPr>
+          <a:lstStyle/>
+          <a:p>
+            <a:pPr algn="l">
+              <a:spcAft>
+                <a:spcPts val="800"/>
+              </a:spcAft>
+            </a:pPr>
+            <a:r>
+              <a:rPr sz="1500" b="0" i="0">
+                <a:solidFill>
+                  <a:srgbClr val="1F2433"/>
+                </a:solidFill>
+                <a:latin typeface="Calibri"/>
+              </a:rPr>
+              <a:t>Models baked into the image at build time; the runtime never touches the network.</a:t>
+            </a:r>
+          </a:p>
+        </p:txBody>
+      </p:sp>
+      <p:sp>
+        <p:nvSpPr>
+          <p:cNvPr id="9" name="Rounded Rectangle 8"/>
+          <p:cNvSpPr/>
+          <p:nvPr/>
+        </p:nvSpPr>
+        <p:spPr>
+          <a:xfrm>
+            <a:off x="548640" y="3840480"/>
+            <a:ext cx="11064240" cy="960120"/>
+          </a:xfrm>
+          <a:prstGeom prst="roundRect">
+            <a:avLst>
+              <a:gd name="adj" fmla="val 12000"/>
+            </a:avLst>
+          </a:prstGeom>
+          <a:solidFill>
+            <a:srgbClr val="EEF1F8"/>
+          </a:solidFill>
+          <a:ln>
+            <a:noFill/>
+          </a:ln>
+          <a:effectLst/>
+        </p:spPr>
+        <p:style>
+          <a:lnRef idx="1">
+            <a:schemeClr val="accent1"/>
+          </a:lnRef>
+          <a:fillRef idx="3">
+            <a:schemeClr val="accent1"/>
+          </a:fillRef>
+          <a:effectRef idx="2">
+            <a:schemeClr val="accent1"/>
+          </a:effectRef>
+          <a:fontRef idx="minor">
+            <a:schemeClr val="lt1"/>
+          </a:fontRef>
+        </p:style>
+        <p:txBody>
+          <a:bodyPr rtlCol="0" anchor="ctr"/>
+          <a:lstStyle/>
+          <a:p>
+            <a:pPr algn="ctr"/>
+          </a:p>
+        </p:txBody>
+      </p:sp>
+      <p:sp>
+        <p:nvSpPr>
+          <p:cNvPr id="10" name="TextBox 9"/>
+          <p:cNvSpPr txBox="1"/>
+          <p:nvPr/>
+        </p:nvSpPr>
+        <p:spPr>
+          <a:xfrm>
+            <a:off x="822960" y="3931920"/>
+            <a:ext cx="3017520" cy="777240"/>
+          </a:xfrm>
+          <a:prstGeom prst="rect">
+            <a:avLst/>
+          </a:prstGeom>
+          <a:noFill/>
+        </p:spPr>
+        <p:txBody>
+          <a:bodyPr wrap="square" anchor="ctr" lIns="0" rIns="0" tIns="0" bIns="0">
+            <a:spAutoFit/>
+          </a:bodyPr>
+          <a:lstStyle/>
+          <a:p>
+            <a:pPr algn="l">
+              <a:spcAft>
+                <a:spcPts val="800"/>
+              </a:spcAft>
+            </a:pPr>
+            <a:r>
+              <a:rPr sz="1800" b="1" i="0">
+                <a:solidFill>
+                  <a:srgbClr val="14234B"/>
+                </a:solidFill>
+                <a:latin typeface="Cambria"/>
+              </a:rPr>
+              <a:t>SQLite</a:t>
+            </a:r>
+          </a:p>
+        </p:txBody>
+      </p:sp>
+      <p:sp>
+        <p:nvSpPr>
+          <p:cNvPr id="11" name="TextBox 10"/>
+          <p:cNvSpPr txBox="1"/>
+          <p:nvPr/>
+        </p:nvSpPr>
+        <p:spPr>
+          <a:xfrm>
+            <a:off x="3931920" y="3931920"/>
+            <a:ext cx="7498079" cy="777240"/>
+          </a:xfrm>
+          <a:prstGeom prst="rect">
+            <a:avLst/>
+          </a:prstGeom>
+          <a:noFill/>
+        </p:spPr>
+        <p:txBody>
+          <a:bodyPr wrap="square" anchor="ctr" lIns="0" rIns="0" tIns="0" bIns="0">
+            <a:spAutoFit/>
+          </a:bodyPr>
+          <a:lstStyle/>
+          <a:p>
+            <a:pPr algn="l">
+              <a:spcAft>
+                <a:spcPts val="800"/>
+              </a:spcAft>
+            </a:pPr>
+            <a:r>
+              <a:rPr sz="1500" b="0" i="0">
+                <a:solidFill>
+                  <a:srgbClr val="1F2433"/>
+                </a:solidFill>
+                <a:latin typeface="Calibri"/>
+              </a:rPr>
+              <a:t>A few hundred courses: one file in a volume keeps compose to two services.</a:t>
+            </a:r>
+          </a:p>
+        </p:txBody>
+      </p:sp>
+      <p:sp>
+        <p:nvSpPr>
+          <p:cNvPr id="12" name="Rounded Rectangle 11"/>
+          <p:cNvSpPr/>
+          <p:nvPr/>
+        </p:nvSpPr>
+        <p:spPr>
+          <a:xfrm>
+            <a:off x="548640" y="5029200"/>
+            <a:ext cx="11064240" cy="960120"/>
+          </a:xfrm>
+          <a:prstGeom prst="roundRect">
+            <a:avLst>
+              <a:gd name="adj" fmla="val 12000"/>
+            </a:avLst>
+          </a:prstGeom>
+          <a:solidFill>
+            <a:srgbClr val="EEF1F8"/>
+          </a:solidFill>
+          <a:ln>
+            <a:noFill/>
+          </a:ln>
+          <a:effectLst/>
+        </p:spPr>
+        <p:style>
+          <a:lnRef idx="1">
+            <a:schemeClr val="accent1"/>
+          </a:lnRef>
+          <a:fillRef idx="3">
+            <a:schemeClr val="accent1"/>
+          </a:fillRef>
+          <a:effectRef idx="2">
+            <a:schemeClr val="accent1"/>
+          </a:effectRef>
+          <a:fontRef idx="minor">
+            <a:schemeClr val="lt1"/>
+          </a:fontRef>
+        </p:style>
+        <p:txBody>
+          <a:bodyPr rtlCol="0" anchor="ctr"/>
+          <a:lstStyle/>
+          <a:p>
+            <a:pPr algn="ctr"/>
+          </a:p>
+        </p:txBody>
+      </p:sp>
+      <p:sp>
+        <p:nvSpPr>
+          <p:cNvPr id="13" name="TextBox 12"/>
+          <p:cNvSpPr txBox="1"/>
+          <p:nvPr/>
+        </p:nvSpPr>
+        <p:spPr>
+          <a:xfrm>
+            <a:off x="822960" y="5120640"/>
+            <a:ext cx="3017520" cy="777240"/>
+          </a:xfrm>
+          <a:prstGeom prst="rect">
+            <a:avLst/>
+          </a:prstGeom>
+          <a:noFill/>
+        </p:spPr>
+        <p:txBody>
+          <a:bodyPr wrap="square" anchor="ctr" lIns="0" rIns="0" tIns="0" bIns="0">
+            <a:spAutoFit/>
+          </a:bodyPr>
+          <a:lstStyle/>
+          <a:p>
+            <a:pPr algn="l">
+              <a:spcAft>
+                <a:spcPts val="800"/>
+              </a:spcAft>
+            </a:pPr>
+            <a:r>
+              <a:rPr sz="1800" b="1" i="0">
+                <a:solidFill>
+                  <a:srgbClr val="14234B"/>
+                </a:solidFill>
+                <a:latin typeface="Cambria"/>
+              </a:rPr>
+              <a:t>Clean-machine build</a:t>
+            </a:r>
+          </a:p>
+        </p:txBody>
+      </p:sp>
+      <p:sp>
+        <p:nvSpPr>
+          <p:cNvPr id="14" name="TextBox 13"/>
+          <p:cNvSpPr txBox="1"/>
+          <p:nvPr/>
+        </p:nvSpPr>
+        <p:spPr>
+          <a:xfrm>
+            <a:off x="3931920" y="5120640"/>
+            <a:ext cx="7498079" cy="777240"/>
+          </a:xfrm>
+          <a:prstGeom prst="rect">
+            <a:avLst/>
+          </a:prstGeom>
+          <a:noFill/>
+        </p:spPr>
+        <p:txBody>
+          <a:bodyPr wrap="square" anchor="ctr" lIns="0" rIns="0" tIns="0" bIns="0">
+            <a:spAutoFit/>
+          </a:bodyPr>
+          <a:lstStyle/>
+          <a:p>
+            <a:pPr algn="l">
+              <a:spcAft>
+                <a:spcPts val="800"/>
+              </a:spcAft>
+            </a:pPr>
+            <a:r>
+              <a:rPr sz="1500" b="0" i="0">
+                <a:solidFill>
+                  <a:srgbClr val="1F2433"/>
+                </a:solidFill>
+                <a:latin typeface="Calibri"/>
+              </a:rPr>
+              <a:t>Fresh clone to running app measured at 297 s, recorded in the README.</a:t>
+            </a:r>
+          </a:p>
+        </p:txBody>
+      </p:sp>
+    </p:spTree>
+  </p:cSld>
+  <p:clrMapOvr>
+    <a:masterClrMapping/>
+  </p:clrMapOvr>
+</p:sld>
+</file>
+
+<file path=ppt/slides/slide13.xml><?xml version="1.0" encoding="utf-8"?>
 <p:sld xmlns:a="http://schemas.openxmlformats.org/drawingml/2006/main" xmlns:p="http://schemas.openxmlformats.org/presentationml/2006/main" xmlns:r="http://schemas.openxmlformats.org/officeDocument/2006/relationships">
   <p:cSld>
     <p:bg>
@@ -11554,7 +12398,7 @@
                 </a:solidFill>
                 <a:latin typeface="Cambria"/>
               </a:rPr>
-              <a:t>The reranker: veto or opinion</a:t>
+              <a:t>All six host universities</a:t>
             </a:r>
           </a:p>
         </p:txBody>
@@ -11567,8 +12411,8 @@
         </p:nvSpPr>
         <p:spPr>
           <a:xfrm>
-            <a:off x="9464040" y="457200"/>
-            <a:ext cx="2194560" cy="384048"/>
+            <a:off x="8549640" y="457200"/>
+            <a:ext cx="3108960" cy="384048"/>
           </a:xfrm>
           <a:prstGeom prst="roundRect">
             <a:avLst>
@@ -11598,7 +12442,7 @@
           </a:fontRef>
         </p:style>
         <p:txBody>
-          <a:bodyPr rtlCol="0" anchor="ctr" tIns="0" bIns="0"/>
+          <a:bodyPr rtlCol="0" anchor="ctr"/>
           <a:lstStyle/>
           <a:p>
             <a:pPr algn="ctr"/>
@@ -11609,26 +12453,774 @@
                 </a:solidFill>
                 <a:latin typeface="Calibri"/>
               </a:rPr>
-              <a:t>PROVISIONAL LABELS</a:t>
+              <a:t>MODEL-JUDGED (SILVER) LABELS</a:t>
             </a:r>
           </a:p>
         </p:txBody>
       </p:sp>
       <p:graphicFrame>
         <p:nvGraphicFramePr>
-          <p:cNvPr id="4" name="Chart 3"/>
+          <p:cNvPr id="4" name="Table 3"/>
           <p:cNvGraphicFramePr>
             <a:graphicFrameLocks noGrp="1"/>
           </p:cNvGraphicFramePr>
           <p:nvPr/>
         </p:nvGraphicFramePr>
         <p:xfrm>
-          <a:off x="457200" y="1371600"/>
-          <a:ext cx="6766560" cy="4937760"/>
+          <a:off x="548640" y="1463040"/>
+          <a:ext cx="7680960" cy="4206240"/>
         </p:xfrm>
         <a:graphic>
-          <a:graphicData uri="http://schemas.openxmlformats.org/drawingml/2006/chart">
-            <c:chart xmlns:c="http://schemas.openxmlformats.org/drawingml/2006/chart" r:id="rId2"/>
+          <a:graphicData uri="http://schemas.openxmlformats.org/drawingml/2006/table">
+            <a:tbl>
+              <a:tblPr firstRow="1" bandRow="1">
+                <a:tableStyleId>{5C22544A-7EE6-4342-B048-85BDC9FD1C3A}</a:tableStyleId>
+              </a:tblPr>
+              <a:tblGrid>
+                <a:gridCol w="1280160"/>
+                <a:gridCol w="1280160"/>
+                <a:gridCol w="1280160"/>
+                <a:gridCol w="1280160"/>
+                <a:gridCol w="1280160"/>
+                <a:gridCol w="1280160"/>
+              </a:tblGrid>
+              <a:tr h="525780">
+                <a:tc>
+                  <a:txBody>
+                    <a:bodyPr/>
+                    <a:lstStyle/>
+                    <a:p>
+                      <a:r>
+                        <a:rPr sz="1300">
+                          <a:latin typeface="Calibri"/>
+                        </a:rPr>
+                        <a:t>P@1 (Recall@5)</a:t>
+                      </a:r>
+                    </a:p>
+                  </a:txBody>
+                  <a:tcPr/>
+                </a:tc>
+                <a:tc>
+                  <a:txBody>
+                    <a:bodyPr/>
+                    <a:lstStyle/>
+                    <a:p>
+                      <a:r>
+                        <a:rPr sz="1300">
+                          <a:latin typeface="Calibri"/>
+                        </a:rPr>
+                        <a:t>Queries</a:t>
+                      </a:r>
+                    </a:p>
+                  </a:txBody>
+                  <a:tcPr/>
+                </a:tc>
+                <a:tc>
+                  <a:txBody>
+                    <a:bodyPr/>
+                    <a:lstStyle/>
+                    <a:p>
+                      <a:r>
+                        <a:rPr sz="1300">
+                          <a:latin typeface="Calibri"/>
+                        </a:rPr>
+                        <a:t>bm25</a:t>
+                      </a:r>
+                    </a:p>
+                  </a:txBody>
+                  <a:tcPr/>
+                </a:tc>
+                <a:tc>
+                  <a:txBody>
+                    <a:bodyPr/>
+                    <a:lstStyle/>
+                    <a:p>
+                      <a:r>
+                        <a:rPr sz="1300">
+                          <a:latin typeface="Calibri"/>
+                        </a:rPr>
+                        <a:t>dense-minilm</a:t>
+                      </a:r>
+                    </a:p>
+                  </a:txBody>
+                  <a:tcPr/>
+                </a:tc>
+                <a:tc>
+                  <a:txBody>
+                    <a:bodyPr/>
+                    <a:lstStyle/>
+                    <a:p>
+                      <a:r>
+                        <a:rPr sz="1300">
+                          <a:latin typeface="Calibri"/>
+                        </a:rPr>
+                        <a:t>hybrid</a:t>
+                      </a:r>
+                    </a:p>
+                  </a:txBody>
+                  <a:tcPr/>
+                </a:tc>
+                <a:tc>
+                  <a:txBody>
+                    <a:bodyPr/>
+                    <a:lstStyle/>
+                    <a:p>
+                      <a:r>
+                        <a:rPr sz="1300">
+                          <a:latin typeface="Calibri"/>
+                        </a:rPr>
+                        <a:t>hybrid+ce</a:t>
+                      </a:r>
+                    </a:p>
+                  </a:txBody>
+                  <a:tcPr/>
+                </a:tc>
+              </a:tr>
+              <a:tr h="525780">
+                <a:tc>
+                  <a:txBody>
+                    <a:bodyPr/>
+                    <a:lstStyle/>
+                    <a:p>
+                      <a:r>
+                        <a:rPr sz="1300">
+                          <a:latin typeface="Calibri"/>
+                        </a:rPr>
+                        <a:t>EPFL</a:t>
+                      </a:r>
+                    </a:p>
+                  </a:txBody>
+                  <a:tcPr/>
+                </a:tc>
+                <a:tc>
+                  <a:txBody>
+                    <a:bodyPr/>
+                    <a:lstStyle/>
+                    <a:p>
+                      <a:r>
+                        <a:rPr sz="1300">
+                          <a:latin typeface="Calibri"/>
+                        </a:rPr>
+                        <a:t>8</a:t>
+                      </a:r>
+                    </a:p>
+                  </a:txBody>
+                  <a:tcPr/>
+                </a:tc>
+                <a:tc>
+                  <a:txBody>
+                    <a:bodyPr/>
+                    <a:lstStyle/>
+                    <a:p>
+                      <a:r>
+                        <a:rPr sz="1300">
+                          <a:latin typeface="Calibri"/>
+                        </a:rPr>
+                        <a:t>0.75 (0.88)</a:t>
+                      </a:r>
+                    </a:p>
+                  </a:txBody>
+                  <a:tcPr/>
+                </a:tc>
+                <a:tc>
+                  <a:txBody>
+                    <a:bodyPr/>
+                    <a:lstStyle/>
+                    <a:p>
+                      <a:r>
+                        <a:rPr sz="1300">
+                          <a:latin typeface="Calibri"/>
+                        </a:rPr>
+                        <a:t>0.38 (0.79)</a:t>
+                      </a:r>
+                    </a:p>
+                  </a:txBody>
+                  <a:tcPr/>
+                </a:tc>
+                <a:tc>
+                  <a:txBody>
+                    <a:bodyPr/>
+                    <a:lstStyle/>
+                    <a:p>
+                      <a:r>
+                        <a:rPr sz="1300">
+                          <a:latin typeface="Calibri"/>
+                        </a:rPr>
+                        <a:t>0.38 (0.69)</a:t>
+                      </a:r>
+                    </a:p>
+                  </a:txBody>
+                  <a:tcPr/>
+                </a:tc>
+                <a:tc>
+                  <a:txBody>
+                    <a:bodyPr/>
+                    <a:lstStyle/>
+                    <a:p>
+                      <a:r>
+                        <a:rPr sz="1300">
+                          <a:latin typeface="Calibri"/>
+                        </a:rPr>
+                        <a:t>0.38 (0.71)</a:t>
+                      </a:r>
+                    </a:p>
+                  </a:txBody>
+                  <a:tcPr/>
+                </a:tc>
+              </a:tr>
+              <a:tr h="525780">
+                <a:tc>
+                  <a:txBody>
+                    <a:bodyPr/>
+                    <a:lstStyle/>
+                    <a:p>
+                      <a:r>
+                        <a:rPr sz="1300">
+                          <a:latin typeface="Calibri"/>
+                        </a:rPr>
+                        <a:t>TU Delft</a:t>
+                      </a:r>
+                    </a:p>
+                  </a:txBody>
+                  <a:tcPr/>
+                </a:tc>
+                <a:tc>
+                  <a:txBody>
+                    <a:bodyPr/>
+                    <a:lstStyle/>
+                    <a:p>
+                      <a:r>
+                        <a:rPr sz="1300">
+                          <a:latin typeface="Calibri"/>
+                        </a:rPr>
+                        <a:t>13</a:t>
+                      </a:r>
+                    </a:p>
+                  </a:txBody>
+                  <a:tcPr/>
+                </a:tc>
+                <a:tc>
+                  <a:txBody>
+                    <a:bodyPr/>
+                    <a:lstStyle/>
+                    <a:p>
+                      <a:r>
+                        <a:rPr sz="1300">
+                          <a:latin typeface="Calibri"/>
+                        </a:rPr>
+                        <a:t>0.69 (0.92)</a:t>
+                      </a:r>
+                    </a:p>
+                  </a:txBody>
+                  <a:tcPr/>
+                </a:tc>
+                <a:tc>
+                  <a:txBody>
+                    <a:bodyPr/>
+                    <a:lstStyle/>
+                    <a:p>
+                      <a:r>
+                        <a:rPr sz="1300">
+                          <a:latin typeface="Calibri"/>
+                        </a:rPr>
+                        <a:t>0.54 (0.88)</a:t>
+                      </a:r>
+                    </a:p>
+                  </a:txBody>
+                  <a:tcPr/>
+                </a:tc>
+                <a:tc>
+                  <a:txBody>
+                    <a:bodyPr/>
+                    <a:lstStyle/>
+                    <a:p>
+                      <a:r>
+                        <a:rPr sz="1300">
+                          <a:latin typeface="Calibri"/>
+                        </a:rPr>
+                        <a:t>0.77 (0.92)</a:t>
+                      </a:r>
+                    </a:p>
+                  </a:txBody>
+                  <a:tcPr/>
+                </a:tc>
+                <a:tc>
+                  <a:txBody>
+                    <a:bodyPr/>
+                    <a:lstStyle/>
+                    <a:p>
+                      <a:r>
+                        <a:rPr sz="1300">
+                          <a:latin typeface="Calibri"/>
+                        </a:rPr>
+                        <a:t>0.54 (0.85)</a:t>
+                      </a:r>
+                    </a:p>
+                  </a:txBody>
+                  <a:tcPr/>
+                </a:tc>
+              </a:tr>
+              <a:tr h="525780">
+                <a:tc>
+                  <a:txBody>
+                    <a:bodyPr/>
+                    <a:lstStyle/>
+                    <a:p>
+                      <a:r>
+                        <a:rPr sz="1300">
+                          <a:latin typeface="Calibri"/>
+                        </a:rPr>
+                        <a:t>Polimi</a:t>
+                      </a:r>
+                    </a:p>
+                  </a:txBody>
+                  <a:tcPr/>
+                </a:tc>
+                <a:tc>
+                  <a:txBody>
+                    <a:bodyPr/>
+                    <a:lstStyle/>
+                    <a:p>
+                      <a:r>
+                        <a:rPr sz="1300">
+                          <a:latin typeface="Calibri"/>
+                        </a:rPr>
+                        <a:t>14</a:t>
+                      </a:r>
+                    </a:p>
+                  </a:txBody>
+                  <a:tcPr/>
+                </a:tc>
+                <a:tc>
+                  <a:txBody>
+                    <a:bodyPr/>
+                    <a:lstStyle/>
+                    <a:p>
+                      <a:r>
+                        <a:rPr sz="1300">
+                          <a:latin typeface="Calibri"/>
+                        </a:rPr>
+                        <a:t>0.93 (0.98)</a:t>
+                      </a:r>
+                    </a:p>
+                  </a:txBody>
+                  <a:tcPr/>
+                </a:tc>
+                <a:tc>
+                  <a:txBody>
+                    <a:bodyPr/>
+                    <a:lstStyle/>
+                    <a:p>
+                      <a:r>
+                        <a:rPr sz="1300">
+                          <a:latin typeface="Calibri"/>
+                        </a:rPr>
+                        <a:t>0.71 (1.00)</a:t>
+                      </a:r>
+                    </a:p>
+                  </a:txBody>
+                  <a:tcPr/>
+                </a:tc>
+                <a:tc>
+                  <a:txBody>
+                    <a:bodyPr/>
+                    <a:lstStyle/>
+                    <a:p>
+                      <a:r>
+                        <a:rPr sz="1300">
+                          <a:latin typeface="Calibri"/>
+                        </a:rPr>
+                        <a:t>0.79 (0.98)</a:t>
+                      </a:r>
+                    </a:p>
+                  </a:txBody>
+                  <a:tcPr/>
+                </a:tc>
+                <a:tc>
+                  <a:txBody>
+                    <a:bodyPr/>
+                    <a:lstStyle/>
+                    <a:p>
+                      <a:r>
+                        <a:rPr sz="1300">
+                          <a:latin typeface="Calibri"/>
+                        </a:rPr>
+                        <a:t>0.79 (0.98)</a:t>
+                      </a:r>
+                    </a:p>
+                  </a:txBody>
+                  <a:tcPr/>
+                </a:tc>
+              </a:tr>
+              <a:tr h="525780">
+                <a:tc>
+                  <a:txBody>
+                    <a:bodyPr/>
+                    <a:lstStyle/>
+                    <a:p>
+                      <a:r>
+                        <a:rPr sz="1300">
+                          <a:latin typeface="Calibri"/>
+                        </a:rPr>
+                        <a:t>KTH</a:t>
+                      </a:r>
+                    </a:p>
+                  </a:txBody>
+                  <a:tcPr/>
+                </a:tc>
+                <a:tc>
+                  <a:txBody>
+                    <a:bodyPr/>
+                    <a:lstStyle/>
+                    <a:p>
+                      <a:r>
+                        <a:rPr sz="1300">
+                          <a:latin typeface="Calibri"/>
+                        </a:rPr>
+                        <a:t>6</a:t>
+                      </a:r>
+                    </a:p>
+                  </a:txBody>
+                  <a:tcPr/>
+                </a:tc>
+                <a:tc>
+                  <a:txBody>
+                    <a:bodyPr/>
+                    <a:lstStyle/>
+                    <a:p>
+                      <a:r>
+                        <a:rPr sz="1300">
+                          <a:latin typeface="Calibri"/>
+                        </a:rPr>
+                        <a:t>0.67 (0.67)</a:t>
+                      </a:r>
+                    </a:p>
+                  </a:txBody>
+                  <a:tcPr/>
+                </a:tc>
+                <a:tc>
+                  <a:txBody>
+                    <a:bodyPr/>
+                    <a:lstStyle/>
+                    <a:p>
+                      <a:r>
+                        <a:rPr sz="1300">
+                          <a:latin typeface="Calibri"/>
+                        </a:rPr>
+                        <a:t>0.67 (0.94)</a:t>
+                      </a:r>
+                    </a:p>
+                  </a:txBody>
+                  <a:tcPr/>
+                </a:tc>
+                <a:tc>
+                  <a:txBody>
+                    <a:bodyPr/>
+                    <a:lstStyle/>
+                    <a:p>
+                      <a:r>
+                        <a:rPr sz="1300">
+                          <a:latin typeface="Calibri"/>
+                        </a:rPr>
+                        <a:t>0.67 (0.75)</a:t>
+                      </a:r>
+                    </a:p>
+                  </a:txBody>
+                  <a:tcPr/>
+                </a:tc>
+                <a:tc>
+                  <a:txBody>
+                    <a:bodyPr/>
+                    <a:lstStyle/>
+                    <a:p>
+                      <a:r>
+                        <a:rPr sz="1300">
+                          <a:latin typeface="Calibri"/>
+                        </a:rPr>
+                        <a:t>0.67 (0.83)</a:t>
+                      </a:r>
+                    </a:p>
+                  </a:txBody>
+                  <a:tcPr/>
+                </a:tc>
+              </a:tr>
+              <a:tr h="525780">
+                <a:tc>
+                  <a:txBody>
+                    <a:bodyPr/>
+                    <a:lstStyle/>
+                    <a:p>
+                      <a:r>
+                        <a:rPr sz="1300">
+                          <a:latin typeface="Calibri"/>
+                        </a:rPr>
+                        <a:t>Twente AM</a:t>
+                      </a:r>
+                    </a:p>
+                  </a:txBody>
+                  <a:tcPr/>
+                </a:tc>
+                <a:tc>
+                  <a:txBody>
+                    <a:bodyPr/>
+                    <a:lstStyle/>
+                    <a:p>
+                      <a:r>
+                        <a:rPr sz="1300">
+                          <a:latin typeface="Calibri"/>
+                        </a:rPr>
+                        <a:t>8</a:t>
+                      </a:r>
+                    </a:p>
+                  </a:txBody>
+                  <a:tcPr/>
+                </a:tc>
+                <a:tc>
+                  <a:txBody>
+                    <a:bodyPr/>
+                    <a:lstStyle/>
+                    <a:p>
+                      <a:r>
+                        <a:rPr sz="1300">
+                          <a:latin typeface="Calibri"/>
+                        </a:rPr>
+                        <a:t>1.00 (1.00)</a:t>
+                      </a:r>
+                    </a:p>
+                  </a:txBody>
+                  <a:tcPr/>
+                </a:tc>
+                <a:tc>
+                  <a:txBody>
+                    <a:bodyPr/>
+                    <a:lstStyle/>
+                    <a:p>
+                      <a:r>
+                        <a:rPr sz="1300">
+                          <a:latin typeface="Calibri"/>
+                        </a:rPr>
+                        <a:t>0.88 (1.00)</a:t>
+                      </a:r>
+                    </a:p>
+                  </a:txBody>
+                  <a:tcPr/>
+                </a:tc>
+                <a:tc>
+                  <a:txBody>
+                    <a:bodyPr/>
+                    <a:lstStyle/>
+                    <a:p>
+                      <a:r>
+                        <a:rPr sz="1300">
+                          <a:latin typeface="Calibri"/>
+                        </a:rPr>
+                        <a:t>1.00 (1.00)</a:t>
+                      </a:r>
+                    </a:p>
+                  </a:txBody>
+                  <a:tcPr/>
+                </a:tc>
+                <a:tc>
+                  <a:txBody>
+                    <a:bodyPr/>
+                    <a:lstStyle/>
+                    <a:p>
+                      <a:r>
+                        <a:rPr sz="1300">
+                          <a:latin typeface="Calibri"/>
+                        </a:rPr>
+                        <a:t>0.88 (0.96)</a:t>
+                      </a:r>
+                    </a:p>
+                  </a:txBody>
+                  <a:tcPr/>
+                </a:tc>
+              </a:tr>
+              <a:tr h="525780">
+                <a:tc>
+                  <a:txBody>
+                    <a:bodyPr/>
+                    <a:lstStyle/>
+                    <a:p>
+                      <a:r>
+                        <a:rPr sz="1300">
+                          <a:latin typeface="Calibri"/>
+                        </a:rPr>
+                        <a:t>Twente TCS</a:t>
+                      </a:r>
+                    </a:p>
+                  </a:txBody>
+                  <a:tcPr/>
+                </a:tc>
+                <a:tc>
+                  <a:txBody>
+                    <a:bodyPr/>
+                    <a:lstStyle/>
+                    <a:p>
+                      <a:r>
+                        <a:rPr sz="1300">
+                          <a:latin typeface="Calibri"/>
+                        </a:rPr>
+                        <a:t>12</a:t>
+                      </a:r>
+                    </a:p>
+                  </a:txBody>
+                  <a:tcPr/>
+                </a:tc>
+                <a:tc>
+                  <a:txBody>
+                    <a:bodyPr/>
+                    <a:lstStyle/>
+                    <a:p>
+                      <a:r>
+                        <a:rPr sz="1300">
+                          <a:latin typeface="Calibri"/>
+                        </a:rPr>
+                        <a:t>0.92 (0.89)</a:t>
+                      </a:r>
+                    </a:p>
+                  </a:txBody>
+                  <a:tcPr/>
+                </a:tc>
+                <a:tc>
+                  <a:txBody>
+                    <a:bodyPr/>
+                    <a:lstStyle/>
+                    <a:p>
+                      <a:r>
+                        <a:rPr sz="1300">
+                          <a:latin typeface="Calibri"/>
+                        </a:rPr>
+                        <a:t>0.58 (0.88)</a:t>
+                      </a:r>
+                    </a:p>
+                  </a:txBody>
+                  <a:tcPr/>
+                </a:tc>
+                <a:tc>
+                  <a:txBody>
+                    <a:bodyPr/>
+                    <a:lstStyle/>
+                    <a:p>
+                      <a:r>
+                        <a:rPr sz="1300">
+                          <a:latin typeface="Calibri"/>
+                        </a:rPr>
+                        <a:t>0.58 (0.83)</a:t>
+                      </a:r>
+                    </a:p>
+                  </a:txBody>
+                  <a:tcPr/>
+                </a:tc>
+                <a:tc>
+                  <a:txBody>
+                    <a:bodyPr/>
+                    <a:lstStyle/>
+                    <a:p>
+                      <a:r>
+                        <a:rPr sz="1300">
+                          <a:latin typeface="Calibri"/>
+                        </a:rPr>
+                        <a:t>0.75 (0.83)</a:t>
+                      </a:r>
+                    </a:p>
+                  </a:txBody>
+                  <a:tcPr/>
+                </a:tc>
+              </a:tr>
+              <a:tr h="525780">
+                <a:tc>
+                  <a:txBody>
+                    <a:bodyPr/>
+                    <a:lstStyle/>
+                    <a:p>
+                      <a:r>
+                        <a:rPr sz="1300">
+                          <a:latin typeface="Calibri"/>
+                        </a:rPr>
+                        <a:t>All</a:t>
+                      </a:r>
+                    </a:p>
+                  </a:txBody>
+                  <a:tcPr/>
+                </a:tc>
+                <a:tc>
+                  <a:txBody>
+                    <a:bodyPr/>
+                    <a:lstStyle/>
+                    <a:p>
+                      <a:r>
+                        <a:rPr sz="1300">
+                          <a:latin typeface="Calibri"/>
+                        </a:rPr>
+                        <a:t>61</a:t>
+                      </a:r>
+                    </a:p>
+                  </a:txBody>
+                  <a:tcPr/>
+                </a:tc>
+                <a:tc>
+                  <a:txBody>
+                    <a:bodyPr/>
+                    <a:lstStyle/>
+                    <a:p>
+                      <a:r>
+                        <a:rPr sz="1300">
+                          <a:latin typeface="Calibri"/>
+                        </a:rPr>
+                        <a:t>0.84 (0.91)</a:t>
+                      </a:r>
+                    </a:p>
+                  </a:txBody>
+                  <a:tcPr/>
+                </a:tc>
+                <a:tc>
+                  <a:txBody>
+                    <a:bodyPr/>
+                    <a:lstStyle/>
+                    <a:p>
+                      <a:r>
+                        <a:rPr sz="1300">
+                          <a:latin typeface="Calibri"/>
+                        </a:rPr>
+                        <a:t>0.62 (0.92)</a:t>
+                      </a:r>
+                    </a:p>
+                  </a:txBody>
+                  <a:tcPr/>
+                </a:tc>
+                <a:tc>
+                  <a:txBody>
+                    <a:bodyPr/>
+                    <a:lstStyle/>
+                    <a:p>
+                      <a:r>
+                        <a:rPr sz="1300">
+                          <a:latin typeface="Calibri"/>
+                        </a:rPr>
+                        <a:t>0.70 (0.88)</a:t>
+                      </a:r>
+                    </a:p>
+                  </a:txBody>
+                  <a:tcPr/>
+                </a:tc>
+                <a:tc>
+                  <a:txBody>
+                    <a:bodyPr/>
+                    <a:lstStyle/>
+                    <a:p>
+                      <a:r>
+                        <a:rPr sz="1300">
+                          <a:latin typeface="Calibri"/>
+                        </a:rPr>
+                        <a:t>0.67 (0.87)</a:t>
+                      </a:r>
+                    </a:p>
+                  </a:txBody>
+                  <a:tcPr/>
+                </a:tc>
+              </a:tr>
+            </a:tbl>
           </a:graphicData>
         </a:graphic>
       </p:graphicFrame>
@@ -11640,8 +13232,8 @@
         </p:nvSpPr>
         <p:spPr>
           <a:xfrm>
-            <a:off x="7680960" y="1554480"/>
-            <a:ext cx="4023360" cy="4572000"/>
+            <a:off x="8595360" y="1554480"/>
+            <a:ext cx="3108960" cy="4572000"/>
           </a:xfrm>
           <a:prstGeom prst="rect">
             <a:avLst/>
@@ -11660,13 +13252,13 @@
               </a:spcAft>
             </a:pPr>
             <a:r>
-              <a:rPr sz="1500" b="0" i="0">
+              <a:rPr sz="1400" b="0" i="0">
                 <a:solidFill>
                   <a:srgbClr val="1F2433"/>
                 </a:solidFill>
                 <a:latin typeface="Calibri"/>
               </a:rPr>
-              <a:t>The proposal expected the cross-encoder to win. Letting it replace the retrieval order made every metric worse.</a:t>
+              <a:t>20 home courses stratified by subject, the same against every host, pooled from all five strategies and labelled blind by a model.</a:t>
             </a:r>
           </a:p>
           <a:p>
@@ -11676,13 +13268,13 @@
               </a:spcAft>
             </a:pPr>
             <a:r>
-              <a:rPr sz="1500" b="0" i="0">
+              <a:rPr sz="1400" b="0" i="0">
                 <a:solidFill>
                   <a:srgbClr val="1F2433"/>
                 </a:solidFill>
                 <a:latin typeface="Calibri"/>
               </a:rPr>
-              <a:t>It was trained on short web queries against passages. Here both sides are long course descriptions.</a:t>
+              <a:t>Recall is level everywhere. Plain BM25 has the best first answer: standard course titles make keyword overlap a strong signal.</a:t>
             </a:r>
           </a:p>
           <a:p>
@@ -11692,13 +13284,13 @@
               </a:spcAft>
             </a:pPr>
             <a:r>
-              <a:rPr sz="1500" b="0" i="0">
+              <a:rPr sz="1400" b="0" i="0">
                 <a:solidFill>
                   <a:srgbClr val="1F2433"/>
                 </a:solidFill>
                 <a:latin typeface="Calibri"/>
               </a:rPr>
-              <a:t>Fused as a third ranking beside BM25 and dense, it recovers to level with hybrid. One opinion among three, never a veto.</a:t>
+              <a:t>Silver against the human-checked gold rows: weighted kappa 0.63.</a:t>
             </a:r>
           </a:p>
         </p:txBody>
@@ -11763,7 +13355,7 @@
                 </a:solidFill>
                 <a:latin typeface="Cambria"/>
               </a:rPr>
-              <a:t>From a score to recognised ECTS</a:t>
+              <a:t>The reranker: veto or opinion</a:t>
             </a:r>
           </a:p>
         </p:txBody>
@@ -11818,7 +13410,7 @@
                 </a:solidFill>
                 <a:latin typeface="Calibri"/>
               </a:rPr>
-              <a:t>PARTLY MODEL-LABELLED</a:t>
+              <a:t>PROVISIONAL LABELS</a:t>
             </a:r>
           </a:p>
         </p:txBody>
@@ -11833,7 +13425,7 @@
         </p:nvGraphicFramePr>
         <p:xfrm>
           <a:off x="457200" y="1371600"/>
-          <a:ext cx="6035040" cy="4846320"/>
+          <a:ext cx="6766560" cy="4937760"/>
         </p:xfrm>
         <a:graphic>
           <a:graphicData uri="http://schemas.openxmlformats.org/drawingml/2006/chart">
@@ -11843,60 +13435,14 @@
       </p:graphicFrame>
       <p:sp>
         <p:nvSpPr>
-          <p:cNvPr id="5" name="Rounded Rectangle 4"/>
-          <p:cNvSpPr/>
-          <p:nvPr/>
-        </p:nvSpPr>
-        <p:spPr>
-          <a:xfrm>
-            <a:off x="6949440" y="1463040"/>
-            <a:ext cx="4663440" cy="1371600"/>
-          </a:xfrm>
-          <a:prstGeom prst="roundRect">
-            <a:avLst>
-              <a:gd name="adj" fmla="val 12000"/>
-            </a:avLst>
-          </a:prstGeom>
-          <a:solidFill>
-            <a:srgbClr val="14234B"/>
-          </a:solidFill>
-          <a:ln>
-            <a:noFill/>
-          </a:ln>
-          <a:effectLst/>
-        </p:spPr>
-        <p:style>
-          <a:lnRef idx="1">
-            <a:schemeClr val="accent1"/>
-          </a:lnRef>
-          <a:fillRef idx="3">
-            <a:schemeClr val="accent1"/>
-          </a:fillRef>
-          <a:effectRef idx="2">
-            <a:schemeClr val="accent1"/>
-          </a:effectRef>
-          <a:fontRef idx="minor">
-            <a:schemeClr val="lt1"/>
-          </a:fontRef>
-        </p:style>
-        <p:txBody>
-          <a:bodyPr rtlCol="0" anchor="ctr"/>
-          <a:lstStyle/>
-          <a:p>
-            <a:pPr algn="ctr"/>
-          </a:p>
-        </p:txBody>
-      </p:sp>
-      <p:sp>
-        <p:nvSpPr>
-          <p:cNvPr id="6" name="TextBox 5"/>
+          <p:cNvPr id="5" name="TextBox 4"/>
           <p:cNvSpPr txBox="1"/>
           <p:nvPr/>
         </p:nvSpPr>
         <p:spPr>
           <a:xfrm>
-            <a:off x="7223760" y="1600200"/>
-            <a:ext cx="4206240" cy="1097280"/>
+            <a:off x="7680960" y="1554480"/>
+            <a:ext cx="4023360" cy="4572000"/>
           </a:xfrm>
           <a:prstGeom prst="rect">
             <a:avLst/>
@@ -11904,7 +13450,7 @@
           <a:noFill/>
         </p:spPr>
         <p:txBody>
-          <a:bodyPr wrap="square" anchor="ctr" lIns="0" rIns="0" tIns="0" bIns="0">
+          <a:bodyPr wrap="square" anchor="t" lIns="0" rIns="0" tIns="0" bIns="0">
             <a:spAutoFit/>
           </a:bodyPr>
           <a:lstStyle/>
@@ -11915,13 +13461,13 @@
               </a:spcAft>
             </a:pPr>
             <a:r>
-              <a:rPr sz="1700" b="0" i="0">
-                <a:solidFill>
-                  <a:srgbClr val="FFFFFF"/>
-                </a:solidFill>
-                <a:latin typeface="Cambria"/>
+              <a:rPr sz="1500" b="0" i="0">
+                <a:solidFill>
+                  <a:srgbClr val="1F2433"/>
+                </a:solidFill>
+                <a:latin typeface="Calibri"/>
               </a:rPr>
-              <a:t>expected ECTS =</a:t>
+              <a:t>The proposal expected the cross-encoder to win. Letting it replace the retrieval order made every metric worse.</a:t>
             </a:r>
           </a:p>
           <a:p>
@@ -11931,38 +13477,15 @@
               </a:spcAft>
             </a:pPr>
             <a:r>
-              <a:rPr sz="1700" b="0" i="0">
-                <a:solidFill>
-                  <a:srgbClr val="FFFFFF"/>
-                </a:solidFill>
-                <a:latin typeface="Cambria"/>
+              <a:rPr sz="1500" b="0" i="0">
+                <a:solidFill>
+                  <a:srgbClr val="1F2433"/>
+                </a:solidFill>
+                <a:latin typeface="Calibri"/>
               </a:rPr>
-              <a:t>sum of p(best match) x ECTS(home course)</a:t>
-            </a:r>
-          </a:p>
-        </p:txBody>
-      </p:sp>
-      <p:sp>
-        <p:nvSpPr>
-          <p:cNvPr id="7" name="TextBox 6"/>
-          <p:cNvSpPr txBox="1"/>
-          <p:nvPr/>
-        </p:nvSpPr>
-        <p:spPr>
-          <a:xfrm>
-            <a:off x="6949440" y="3108960"/>
-            <a:ext cx="4663440" cy="3108960"/>
-          </a:xfrm>
-          <a:prstGeom prst="rect">
-            <a:avLst/>
-          </a:prstGeom>
-          <a:noFill/>
-        </p:spPr>
-        <p:txBody>
-          <a:bodyPr wrap="square" anchor="t" lIns="0" rIns="0" tIns="0" bIns="0">
-            <a:spAutoFit/>
-          </a:bodyPr>
-          <a:lstStyle/>
+              <a:t>It was trained on short web queries against passages. Here both sides are long course descriptions.</a:t>
+            </a:r>
+          </a:p>
           <a:p>
             <a:pPr algn="l">
               <a:spcAft>
@@ -11976,23 +13499,7 @@
                 </a:solidFill>
                 <a:latin typeface="Calibri"/>
               </a:rPr>
-              <a:t>Platt scaling on the fused rank score and the embedding cosine gives the probability that a human labelled the pair a match. Rank alone cannot tell a good top hit from the best of a bad lot; the cosine can.</a:t>
-            </a:r>
-          </a:p>
-          <a:p>
-            <a:pPr algn="l">
-              <a:spcAft>
-                <a:spcPts val="800"/>
-              </a:spcAft>
-            </a:pPr>
-            <a:r>
-              <a:rPr sz="1500" b="0" i="0">
-                <a:solidFill>
-                  <a:srgbClr val="1F2433"/>
-                </a:solidFill>
-                <a:latin typeface="Calibri"/>
-              </a:rPr>
-              <a:t>Only the best candidate per home course counts, partial matches count as matches, and an ECTS shortfall is shown rather than hidden.</a:t>
+              <a:t>Fused as a third ranking beside BM25 and dense, it recovers to level with hybrid. One opinion among three, never a veto.</a:t>
             </a:r>
           </a:p>
         </p:txBody>
@@ -12057,7 +13564,7 @@
                 </a:solidFill>
                 <a:latin typeface="Cambria"/>
               </a:rPr>
-              <a:t>An interface that does not overstate</a:t>
+              <a:t>From a score to recognised ECTS</a:t>
             </a:r>
           </a:p>
         </p:txBody>
@@ -12070,8 +13577,8 @@
         </p:nvSpPr>
         <p:spPr>
           <a:xfrm>
-            <a:off x="548640" y="1463040"/>
-            <a:ext cx="5394960" cy="2103120"/>
+            <a:off x="9464040" y="457200"/>
+            <a:ext cx="2194560" cy="384048"/>
           </a:xfrm>
           <a:prstGeom prst="roundRect">
             <a:avLst>
@@ -12079,7 +13586,7 @@
             </a:avLst>
           </a:prstGeom>
           <a:solidFill>
-            <a:srgbClr val="EEF1F8"/>
+            <a:srgbClr val="F2B705"/>
           </a:solidFill>
           <a:ln>
             <a:noFill/>
@@ -12101,26 +13608,55 @@
           </a:fontRef>
         </p:style>
         <p:txBody>
-          <a:bodyPr rtlCol="0" anchor="ctr"/>
+          <a:bodyPr rtlCol="0" anchor="ctr" tIns="0" bIns="0"/>
           <a:lstStyle/>
           <a:p>
             <a:pPr algn="ctr"/>
-          </a:p>
-        </p:txBody>
-      </p:sp>
-      <p:sp>
-        <p:nvSpPr>
-          <p:cNvPr id="4" name="Oval 3"/>
+            <a:r>
+              <a:rPr sz="1200" b="1">
+                <a:solidFill>
+                  <a:srgbClr val="14234B"/>
+                </a:solidFill>
+                <a:latin typeface="Calibri"/>
+              </a:rPr>
+              <a:t>PARTLY MODEL-LABELLED</a:t>
+            </a:r>
+          </a:p>
+        </p:txBody>
+      </p:sp>
+      <p:graphicFrame>
+        <p:nvGraphicFramePr>
+          <p:cNvPr id="4" name="Chart 3"/>
+          <p:cNvGraphicFramePr>
+            <a:graphicFrameLocks noGrp="1"/>
+          </p:cNvGraphicFramePr>
+          <p:nvPr/>
+        </p:nvGraphicFramePr>
+        <p:xfrm>
+          <a:off x="457200" y="1371600"/>
+          <a:ext cx="6035040" cy="4846320"/>
+        </p:xfrm>
+        <a:graphic>
+          <a:graphicData uri="http://schemas.openxmlformats.org/drawingml/2006/chart">
+            <c:chart xmlns:c="http://schemas.openxmlformats.org/drawingml/2006/chart" r:id="rId2"/>
+          </a:graphicData>
+        </a:graphic>
+      </p:graphicFrame>
+      <p:sp>
+        <p:nvSpPr>
+          <p:cNvPr id="5" name="Rounded Rectangle 4"/>
           <p:cNvSpPr/>
           <p:nvPr/>
         </p:nvSpPr>
         <p:spPr>
           <a:xfrm>
-            <a:off x="822960" y="1737360"/>
-            <a:ext cx="502920" cy="502920"/>
-          </a:xfrm>
-          <a:prstGeom prst="ellipse">
-            <a:avLst/>
+            <a:off x="6949440" y="1463040"/>
+            <a:ext cx="4663440" cy="1371600"/>
+          </a:xfrm>
+          <a:prstGeom prst="roundRect">
+            <a:avLst>
+              <a:gd name="adj" fmla="val 12000"/>
+            </a:avLst>
           </a:prstGeom>
           <a:solidFill>
             <a:srgbClr val="14234B"/>
@@ -12145,32 +13681,23 @@
           </a:fontRef>
         </p:style>
         <p:txBody>
-          <a:bodyPr rtlCol="0" anchor="ctr" lIns="0" rIns="0" tIns="0" bIns="0"/>
+          <a:bodyPr rtlCol="0" anchor="ctr"/>
           <a:lstStyle/>
           <a:p>
             <a:pPr algn="ctr"/>
-            <a:r>
-              <a:rPr sz="1800" b="1">
-                <a:solidFill>
-                  <a:srgbClr val="FFFFFF"/>
-                </a:solidFill>
-                <a:latin typeface="Cambria"/>
-              </a:rPr>
-              <a:t>1</a:t>
-            </a:r>
-          </a:p>
-        </p:txBody>
-      </p:sp>
-      <p:sp>
-        <p:nvSpPr>
-          <p:cNvPr id="5" name="TextBox 4"/>
+          </a:p>
+        </p:txBody>
+      </p:sp>
+      <p:sp>
+        <p:nvSpPr>
+          <p:cNvPr id="6" name="TextBox 5"/>
           <p:cNvSpPr txBox="1"/>
           <p:nvPr/>
         </p:nvSpPr>
         <p:spPr>
           <a:xfrm>
-            <a:off x="1554480" y="1764792"/>
-            <a:ext cx="4114800" cy="457200"/>
+            <a:off x="7223760" y="1600200"/>
+            <a:ext cx="4206240" cy="1097280"/>
           </a:xfrm>
           <a:prstGeom prst="rect">
             <a:avLst/>
@@ -12178,7 +13705,7 @@
           <a:noFill/>
         </p:spPr>
         <p:txBody>
-          <a:bodyPr wrap="square" anchor="t" lIns="0" rIns="0" tIns="0" bIns="0">
+          <a:bodyPr wrap="square" anchor="ctr" lIns="0" rIns="0" tIns="0" bIns="0">
             <a:spAutoFit/>
           </a:bodyPr>
           <a:lstStyle/>
@@ -12189,38 +13716,15 @@
               </a:spcAft>
             </a:pPr>
             <a:r>
-              <a:rPr sz="1800" b="1" i="0">
-                <a:solidFill>
-                  <a:srgbClr val="14234B"/>
+              <a:rPr sz="1700" b="0" i="0">
+                <a:solidFill>
+                  <a:srgbClr val="FFFFFF"/>
                 </a:solidFill>
                 <a:latin typeface="Cambria"/>
               </a:rPr>
-              <a:t>Two kinds of score</a:t>
-            </a:r>
-          </a:p>
-        </p:txBody>
-      </p:sp>
-      <p:sp>
-        <p:nvSpPr>
-          <p:cNvPr id="6" name="TextBox 5"/>
-          <p:cNvSpPr txBox="1"/>
-          <p:nvPr/>
-        </p:nvSpPr>
-        <p:spPr>
-          <a:xfrm>
-            <a:off x="1554480" y="2286000"/>
-            <a:ext cx="4114800" cy="1188720"/>
-          </a:xfrm>
-          <a:prstGeom prst="rect">
-            <a:avLst/>
-          </a:prstGeom>
-          <a:noFill/>
-        </p:spPr>
-        <p:txBody>
-          <a:bodyPr wrap="square" anchor="t" lIns="0" rIns="0" tIns="0" bIns="0">
-            <a:spAutoFit/>
-          </a:bodyPr>
-          <a:lstStyle/>
+              <a:t>expected ECTS =</a:t>
+            </a:r>
+          </a:p>
           <a:p>
             <a:pPr algn="l">
               <a:spcAft>
@@ -12228,126 +13732,27 @@
               </a:spcAft>
             </a:pPr>
             <a:r>
-              <a:rPr sz="1400" b="0" i="0">
-                <a:solidFill>
-                  <a:srgbClr val="1F2433"/>
-                </a:solidFill>
-                <a:latin typeface="Calibri"/>
-              </a:rPr>
-              <a:t>A calibrated strategy shows a percentage and a likely, borderline or unlikely band. The others show a bare relative number and a tooltip saying it is not a probability. One file formats every score.</a:t>
-            </a:r>
-          </a:p>
-        </p:txBody>
-      </p:sp>
-      <p:sp>
-        <p:nvSpPr>
-          <p:cNvPr id="7" name="Rounded Rectangle 6"/>
-          <p:cNvSpPr/>
-          <p:nvPr/>
-        </p:nvSpPr>
-        <p:spPr>
-          <a:xfrm>
-            <a:off x="6217920" y="1463040"/>
-            <a:ext cx="5394960" cy="2103120"/>
-          </a:xfrm>
-          <a:prstGeom prst="roundRect">
-            <a:avLst>
-              <a:gd name="adj" fmla="val 12000"/>
-            </a:avLst>
-          </a:prstGeom>
-          <a:solidFill>
-            <a:srgbClr val="EEF1F8"/>
-          </a:solidFill>
-          <a:ln>
-            <a:noFill/>
-          </a:ln>
-          <a:effectLst/>
-        </p:spPr>
-        <p:style>
-          <a:lnRef idx="1">
-            <a:schemeClr val="accent1"/>
-          </a:lnRef>
-          <a:fillRef idx="3">
-            <a:schemeClr val="accent1"/>
-          </a:fillRef>
-          <a:effectRef idx="2">
-            <a:schemeClr val="accent1"/>
-          </a:effectRef>
-          <a:fontRef idx="minor">
-            <a:schemeClr val="lt1"/>
-          </a:fontRef>
-        </p:style>
-        <p:txBody>
-          <a:bodyPr rtlCol="0" anchor="ctr"/>
-          <a:lstStyle/>
-          <a:p>
-            <a:pPr algn="ctr"/>
-          </a:p>
-        </p:txBody>
-      </p:sp>
-      <p:sp>
-        <p:nvSpPr>
-          <p:cNvPr id="8" name="Oval 7"/>
-          <p:cNvSpPr/>
-          <p:nvPr/>
-        </p:nvSpPr>
-        <p:spPr>
-          <a:xfrm>
-            <a:off x="6492240" y="1737360"/>
-            <a:ext cx="502920" cy="502920"/>
-          </a:xfrm>
-          <a:prstGeom prst="ellipse">
-            <a:avLst/>
-          </a:prstGeom>
-          <a:solidFill>
-            <a:srgbClr val="14234B"/>
-          </a:solidFill>
-          <a:ln>
-            <a:noFill/>
-          </a:ln>
-          <a:effectLst/>
-        </p:spPr>
-        <p:style>
-          <a:lnRef idx="1">
-            <a:schemeClr val="accent1"/>
-          </a:lnRef>
-          <a:fillRef idx="3">
-            <a:schemeClr val="accent1"/>
-          </a:fillRef>
-          <a:effectRef idx="2">
-            <a:schemeClr val="accent1"/>
-          </a:effectRef>
-          <a:fontRef idx="minor">
-            <a:schemeClr val="lt1"/>
-          </a:fontRef>
-        </p:style>
-        <p:txBody>
-          <a:bodyPr rtlCol="0" anchor="ctr" lIns="0" rIns="0" tIns="0" bIns="0"/>
-          <a:lstStyle/>
-          <a:p>
-            <a:pPr algn="ctr"/>
-            <a:r>
-              <a:rPr sz="1800" b="1">
+              <a:rPr sz="1700" b="0" i="0">
                 <a:solidFill>
                   <a:srgbClr val="FFFFFF"/>
                 </a:solidFill>
                 <a:latin typeface="Cambria"/>
               </a:rPr>
-              <a:t>2</a:t>
-            </a:r>
-          </a:p>
-        </p:txBody>
-      </p:sp>
-      <p:sp>
-        <p:nvSpPr>
-          <p:cNvPr id="9" name="TextBox 8"/>
+              <a:t>sum of p(best match) x ECTS(home course)</a:t>
+            </a:r>
+          </a:p>
+        </p:txBody>
+      </p:sp>
+      <p:sp>
+        <p:nvSpPr>
+          <p:cNvPr id="7" name="TextBox 6"/>
           <p:cNvSpPr txBox="1"/>
           <p:nvPr/>
         </p:nvSpPr>
         <p:spPr>
           <a:xfrm>
-            <a:off x="7223760" y="1764792"/>
-            <a:ext cx="4114800" cy="457200"/>
+            <a:off x="6949440" y="3108960"/>
+            <a:ext cx="4663440" cy="3108960"/>
           </a:xfrm>
           <a:prstGeom prst="rect">
             <a:avLst/>
@@ -12366,38 +13771,15 @@
               </a:spcAft>
             </a:pPr>
             <a:r>
-              <a:rPr sz="1800" b="1" i="0">
-                <a:solidFill>
-                  <a:srgbClr val="14234B"/>
-                </a:solidFill>
-                <a:latin typeface="Cambria"/>
+              <a:rPr sz="1500" b="0" i="0">
+                <a:solidFill>
+                  <a:srgbClr val="1F2433"/>
+                </a:solidFill>
+                <a:latin typeface="Calibri"/>
               </a:rPr>
-              <a:t>No sum without a calibration</a:t>
-            </a:r>
-          </a:p>
-        </p:txBody>
-      </p:sp>
-      <p:sp>
-        <p:nvSpPr>
-          <p:cNvPr id="10" name="TextBox 9"/>
-          <p:cNvSpPr txBox="1"/>
-          <p:nvPr/>
-        </p:nvSpPr>
-        <p:spPr>
-          <a:xfrm>
-            <a:off x="7223760" y="2286000"/>
-            <a:ext cx="4114800" cy="1188720"/>
-          </a:xfrm>
-          <a:prstGeom prst="rect">
-            <a:avLst/>
-          </a:prstGeom>
-          <a:noFill/>
-        </p:spPr>
-        <p:txBody>
-          <a:bodyPr wrap="square" anchor="t" lIns="0" rIns="0" tIns="0" bIns="0">
-            <a:spAutoFit/>
-          </a:bodyPr>
-          <a:lstStyle/>
+              <a:t>Platt scaling on the fused rank score and the embedding cosine gives the probability that a human labelled the pair a match. Rank alone cannot tell a good top hit from the best of a bad lot; the cosine can.</a:t>
+            </a:r>
+          </a:p>
           <a:p>
             <a:pPr algn="l">
               <a:spcAft>
@@ -12405,367 +13787,13 @@
               </a:spcAft>
             </a:pPr>
             <a:r>
-              <a:rPr sz="1400" b="0" i="0">
+              <a:rPr sz="1500" b="0" i="0">
                 <a:solidFill>
                   <a:srgbClr val="1F2433"/>
                 </a:solidFill>
                 <a:latin typeface="Calibri"/>
               </a:rPr>
-              <a:t>The recognition panel will not add up ECTS for a strategy without a fitted calibration. Summing display values would be arithmetic on the wrong thing.</a:t>
-            </a:r>
-          </a:p>
-        </p:txBody>
-      </p:sp>
-      <p:sp>
-        <p:nvSpPr>
-          <p:cNvPr id="11" name="Rounded Rectangle 10"/>
-          <p:cNvSpPr/>
-          <p:nvPr/>
-        </p:nvSpPr>
-        <p:spPr>
-          <a:xfrm>
-            <a:off x="548640" y="3840480"/>
-            <a:ext cx="5394960" cy="2103120"/>
-          </a:xfrm>
-          <a:prstGeom prst="roundRect">
-            <a:avLst>
-              <a:gd name="adj" fmla="val 12000"/>
-            </a:avLst>
-          </a:prstGeom>
-          <a:solidFill>
-            <a:srgbClr val="EEF1F8"/>
-          </a:solidFill>
-          <a:ln>
-            <a:noFill/>
-          </a:ln>
-          <a:effectLst/>
-        </p:spPr>
-        <p:style>
-          <a:lnRef idx="1">
-            <a:schemeClr val="accent1"/>
-          </a:lnRef>
-          <a:fillRef idx="3">
-            <a:schemeClr val="accent1"/>
-          </a:fillRef>
-          <a:effectRef idx="2">
-            <a:schemeClr val="accent1"/>
-          </a:effectRef>
-          <a:fontRef idx="minor">
-            <a:schemeClr val="lt1"/>
-          </a:fontRef>
-        </p:style>
-        <p:txBody>
-          <a:bodyPr rtlCol="0" anchor="ctr"/>
-          <a:lstStyle/>
-          <a:p>
-            <a:pPr algn="ctr"/>
-          </a:p>
-        </p:txBody>
-      </p:sp>
-      <p:sp>
-        <p:nvSpPr>
-          <p:cNvPr id="12" name="Oval 11"/>
-          <p:cNvSpPr/>
-          <p:nvPr/>
-        </p:nvSpPr>
-        <p:spPr>
-          <a:xfrm>
-            <a:off x="822960" y="4114800"/>
-            <a:ext cx="502920" cy="502920"/>
-          </a:xfrm>
-          <a:prstGeom prst="ellipse">
-            <a:avLst/>
-          </a:prstGeom>
-          <a:solidFill>
-            <a:srgbClr val="14234B"/>
-          </a:solidFill>
-          <a:ln>
-            <a:noFill/>
-          </a:ln>
-          <a:effectLst/>
-        </p:spPr>
-        <p:style>
-          <a:lnRef idx="1">
-            <a:schemeClr val="accent1"/>
-          </a:lnRef>
-          <a:fillRef idx="3">
-            <a:schemeClr val="accent1"/>
-          </a:fillRef>
-          <a:effectRef idx="2">
-            <a:schemeClr val="accent1"/>
-          </a:effectRef>
-          <a:fontRef idx="minor">
-            <a:schemeClr val="lt1"/>
-          </a:fontRef>
-        </p:style>
-        <p:txBody>
-          <a:bodyPr rtlCol="0" anchor="ctr" lIns="0" rIns="0" tIns="0" bIns="0"/>
-          <a:lstStyle/>
-          <a:p>
-            <a:pPr algn="ctr"/>
-            <a:r>
-              <a:rPr sz="1800" b="1">
-                <a:solidFill>
-                  <a:srgbClr val="FFFFFF"/>
-                </a:solidFill>
-                <a:latin typeface="Cambria"/>
-              </a:rPr>
-              <a:t>3</a:t>
-            </a:r>
-          </a:p>
-        </p:txBody>
-      </p:sp>
-      <p:sp>
-        <p:nvSpPr>
-          <p:cNvPr id="13" name="TextBox 12"/>
-          <p:cNvSpPr txBox="1"/>
-          <p:nvPr/>
-        </p:nvSpPr>
-        <p:spPr>
-          <a:xfrm>
-            <a:off x="1554480" y="4142232"/>
-            <a:ext cx="4114800" cy="457200"/>
-          </a:xfrm>
-          <a:prstGeom prst="rect">
-            <a:avLst/>
-          </a:prstGeom>
-          <a:noFill/>
-        </p:spPr>
-        <p:txBody>
-          <a:bodyPr wrap="square" anchor="t" lIns="0" rIns="0" tIns="0" bIns="0">
-            <a:spAutoFit/>
-          </a:bodyPr>
-          <a:lstStyle/>
-          <a:p>
-            <a:pPr algn="l">
-              <a:spcAft>
-                <a:spcPts val="800"/>
-              </a:spcAft>
-            </a:pPr>
-            <a:r>
-              <a:rPr sz="1800" b="1" i="0">
-                <a:solidFill>
-                  <a:srgbClr val="14234B"/>
-                </a:solidFill>
-                <a:latin typeface="Cambria"/>
-              </a:rPr>
-              <a:t>Provisional says so</a:t>
-            </a:r>
-          </a:p>
-        </p:txBody>
-      </p:sp>
-      <p:sp>
-        <p:nvSpPr>
-          <p:cNvPr id="14" name="TextBox 13"/>
-          <p:cNvSpPr txBox="1"/>
-          <p:nvPr/>
-        </p:nvSpPr>
-        <p:spPr>
-          <a:xfrm>
-            <a:off x="1554480" y="4663440"/>
-            <a:ext cx="4114800" cy="1188720"/>
-          </a:xfrm>
-          <a:prstGeom prst="rect">
-            <a:avLst/>
-          </a:prstGeom>
-          <a:noFill/>
-        </p:spPr>
-        <p:txBody>
-          <a:bodyPr wrap="square" anchor="t" lIns="0" rIns="0" tIns="0" bIns="0">
-            <a:spAutoFit/>
-          </a:bodyPr>
-          <a:lstStyle/>
-          <a:p>
-            <a:pPr algn="l">
-              <a:spcAft>
-                <a:spcPts val="800"/>
-              </a:spcAft>
-            </a:pPr>
-            <a:r>
-              <a:rPr sz="1400" b="0" i="0">
-                <a:solidFill>
-                  <a:srgbClr val="1F2433"/>
-                </a:solidFill>
-                <a:latin typeface="Calibri"/>
-              </a:rPr>
-              <a:t>While a calibration rests on labels that are not all a person's, every probability and the ECTS estimate carry a warning. The flag is read from the calibration file, not typed into the interface.</a:t>
-            </a:r>
-          </a:p>
-        </p:txBody>
-      </p:sp>
-      <p:sp>
-        <p:nvSpPr>
-          <p:cNvPr id="15" name="Rounded Rectangle 14"/>
-          <p:cNvSpPr/>
-          <p:nvPr/>
-        </p:nvSpPr>
-        <p:spPr>
-          <a:xfrm>
-            <a:off x="6217920" y="3840480"/>
-            <a:ext cx="5394960" cy="2103120"/>
-          </a:xfrm>
-          <a:prstGeom prst="roundRect">
-            <a:avLst>
-              <a:gd name="adj" fmla="val 12000"/>
-            </a:avLst>
-          </a:prstGeom>
-          <a:solidFill>
-            <a:srgbClr val="EEF1F8"/>
-          </a:solidFill>
-          <a:ln>
-            <a:noFill/>
-          </a:ln>
-          <a:effectLst/>
-        </p:spPr>
-        <p:style>
-          <a:lnRef idx="1">
-            <a:schemeClr val="accent1"/>
-          </a:lnRef>
-          <a:fillRef idx="3">
-            <a:schemeClr val="accent1"/>
-          </a:fillRef>
-          <a:effectRef idx="2">
-            <a:schemeClr val="accent1"/>
-          </a:effectRef>
-          <a:fontRef idx="minor">
-            <a:schemeClr val="lt1"/>
-          </a:fontRef>
-        </p:style>
-        <p:txBody>
-          <a:bodyPr rtlCol="0" anchor="ctr"/>
-          <a:lstStyle/>
-          <a:p>
-            <a:pPr algn="ctr"/>
-          </a:p>
-        </p:txBody>
-      </p:sp>
-      <p:sp>
-        <p:nvSpPr>
-          <p:cNvPr id="16" name="Oval 15"/>
-          <p:cNvSpPr/>
-          <p:nvPr/>
-        </p:nvSpPr>
-        <p:spPr>
-          <a:xfrm>
-            <a:off x="6492240" y="4114800"/>
-            <a:ext cx="502920" cy="502920"/>
-          </a:xfrm>
-          <a:prstGeom prst="ellipse">
-            <a:avLst/>
-          </a:prstGeom>
-          <a:solidFill>
-            <a:srgbClr val="14234B"/>
-          </a:solidFill>
-          <a:ln>
-            <a:noFill/>
-          </a:ln>
-          <a:effectLst/>
-        </p:spPr>
-        <p:style>
-          <a:lnRef idx="1">
-            <a:schemeClr val="accent1"/>
-          </a:lnRef>
-          <a:fillRef idx="3">
-            <a:schemeClr val="accent1"/>
-          </a:fillRef>
-          <a:effectRef idx="2">
-            <a:schemeClr val="accent1"/>
-          </a:effectRef>
-          <a:fontRef idx="minor">
-            <a:schemeClr val="lt1"/>
-          </a:fontRef>
-        </p:style>
-        <p:txBody>
-          <a:bodyPr rtlCol="0" anchor="ctr" lIns="0" rIns="0" tIns="0" bIns="0"/>
-          <a:lstStyle/>
-          <a:p>
-            <a:pPr algn="ctr"/>
-            <a:r>
-              <a:rPr sz="1800" b="1">
-                <a:solidFill>
-                  <a:srgbClr val="FFFFFF"/>
-                </a:solidFill>
-                <a:latin typeface="Cambria"/>
-              </a:rPr>
-              <a:t>4</a:t>
-            </a:r>
-          </a:p>
-        </p:txBody>
-      </p:sp>
-      <p:sp>
-        <p:nvSpPr>
-          <p:cNvPr id="17" name="TextBox 16"/>
-          <p:cNvSpPr txBox="1"/>
-          <p:nvPr/>
-        </p:nvSpPr>
-        <p:spPr>
-          <a:xfrm>
-            <a:off x="7223760" y="4142232"/>
-            <a:ext cx="4114800" cy="457200"/>
-          </a:xfrm>
-          <a:prstGeom prst="rect">
-            <a:avLst/>
-          </a:prstGeom>
-          <a:noFill/>
-        </p:spPr>
-        <p:txBody>
-          <a:bodyPr wrap="square" anchor="t" lIns="0" rIns="0" tIns="0" bIns="0">
-            <a:spAutoFit/>
-          </a:bodyPr>
-          <a:lstStyle/>
-          <a:p>
-            <a:pPr algn="l">
-              <a:spcAft>
-                <a:spcPts val="800"/>
-              </a:spcAft>
-            </a:pPr>
-            <a:r>
-              <a:rPr sz="1800" b="1" i="0">
-                <a:solidFill>
-                  <a:srgbClr val="14234B"/>
-                </a:solidFill>
-                <a:latin typeface="Cambria"/>
-              </a:rPr>
-              <a:t>The evaluation page counts</a:t>
-            </a:r>
-          </a:p>
-        </p:txBody>
-      </p:sp>
-      <p:sp>
-        <p:nvSpPr>
-          <p:cNvPr id="18" name="TextBox 17"/>
-          <p:cNvSpPr txBox="1"/>
-          <p:nvPr/>
-        </p:nvSpPr>
-        <p:spPr>
-          <a:xfrm>
-            <a:off x="7223760" y="4663440"/>
-            <a:ext cx="4114800" cy="1188720"/>
-          </a:xfrm>
-          <a:prstGeom prst="rect">
-            <a:avLst/>
-          </a:prstGeom>
-          <a:noFill/>
-        </p:spPr>
-        <p:txBody>
-          <a:bodyPr wrap="square" anchor="t" lIns="0" rIns="0" tIns="0" bIns="0">
-            <a:spAutoFit/>
-          </a:bodyPr>
-          <a:lstStyle/>
-          <a:p>
-            <a:pPr algn="l">
-              <a:spcAft>
-                <a:spcPts val="800"/>
-              </a:spcAft>
-            </a:pPr>
-            <a:r>
-              <a:rPr sz="1400" b="0" i="0">
-                <a:solidFill>
-                  <a:srgbClr val="1F2433"/>
-                </a:solidFill>
-                <a:latin typeface="Calibri"/>
-              </a:rPr>
-              <a:t>It says how many of the 1142 gold labels a person gave (680) and how many a second model gave (462), instead of calling them all checked.</a:t>
+              <a:t>Only the best candidate per home course counts, partial matches count as matches, and an ECTS shortfall is shown rather than hidden.</a:t>
             </a:r>
           </a:p>
         </p:txBody>

</xml_diff>